<commit_message>
Modified plots for rainfall.
</commit_message>
<xml_diff>
--- a/chapter_04/figures/prob_tp_exceeding_50rp.pptx
+++ b/chapter_04/figures/prob_tp_exceeding_50rp.pptx
@@ -2,12 +2,12 @@
 <file path=ppt/presentation.xml><?xml version="1.0" encoding="utf-8"?>
 <p:presentation xmlns:a="http://schemas.openxmlformats.org/drawingml/2006/main" xmlns:r="http://schemas.openxmlformats.org/officeDocument/2006/relationships" xmlns:p="http://schemas.openxmlformats.org/presentationml/2006/main" saveSubsetFonts="1">
   <p:sldMasterIdLst>
-    <p:sldMasterId id="2147483672" r:id="rId1"/>
+    <p:sldMasterId id="2147483684" r:id="rId1"/>
   </p:sldMasterIdLst>
   <p:sldIdLst>
     <p:sldId id="257" r:id="rId2"/>
   </p:sldIdLst>
-  <p:sldSz cx="4140200" cy="5111750"/>
+  <p:sldSz cx="4140200" cy="4895850"/>
   <p:notesSz cx="6858000" cy="9144000"/>
   <p:defaultTextStyle>
     <a:defPPr>
@@ -115,14 +115,933 @@
 <file path=ppt/revisionInfo.xml><?xml version="1.0" encoding="utf-8"?>
 <p1510:revInfo xmlns:a="http://schemas.openxmlformats.org/drawingml/2006/main" xmlns:r="http://schemas.openxmlformats.org/officeDocument/2006/relationships" xmlns:p1510="http://schemas.microsoft.com/office/powerpoint/2015/10/main">
   <p1510:revLst>
-    <p1510:client id="{9A2B42D9-F292-4BF4-BB93-D16CACD71501}" v="2" dt="2025-06-10T16:03:15.028"/>
-    <p1510:client id="{B9A31C07-789E-48D4-B2E6-C80B6605FE08}" v="12" dt="2025-06-10T16:15:22.964"/>
+    <p1510:client id="{B5DC09CA-6CD4-43F7-8607-5135DBD6D67A}" v="2" dt="2025-07-15T02:45:17.215"/>
   </p1510:revLst>
 </p1510:revInfo>
 </file>
 
 <file path=ppt/changesInfos/changesInfo1.xml><?xml version="1.0" encoding="utf-8"?>
 <pc:chgInfo xmlns:a="http://schemas.openxmlformats.org/drawingml/2006/main" xmlns:r="http://schemas.openxmlformats.org/officeDocument/2006/relationships" xmlns:ac="http://schemas.microsoft.com/office/drawing/2013/main/command" xmlns:pc="http://schemas.microsoft.com/office/powerpoint/2013/main/command">
+  <pc:docChgLst>
+    <pc:chgData name="Fatima Pillosu" userId="a6295d4dc9e22643" providerId="LiveId" clId="{B5DC09CA-6CD4-43F7-8607-5135DBD6D67A}"/>
+    <pc:docChg chg="undo custSel modSld">
+      <pc:chgData name="Fatima Pillosu" userId="a6295d4dc9e22643" providerId="LiveId" clId="{B5DC09CA-6CD4-43F7-8607-5135DBD6D67A}" dt="2025-07-15T02:45:25.851" v="19" actId="1036"/>
+      <pc:docMkLst>
+        <pc:docMk/>
+      </pc:docMkLst>
+      <pc:sldChg chg="addSp delSp modSp mod">
+        <pc:chgData name="Fatima Pillosu" userId="a6295d4dc9e22643" providerId="LiveId" clId="{B5DC09CA-6CD4-43F7-8607-5135DBD6D67A}" dt="2025-07-15T02:45:25.851" v="19" actId="1036"/>
+        <pc:sldMkLst>
+          <pc:docMk/>
+          <pc:sldMk cId="1403429394" sldId="257"/>
+        </pc:sldMkLst>
+        <pc:spChg chg="add del">
+          <ac:chgData name="Fatima Pillosu" userId="a6295d4dc9e22643" providerId="LiveId" clId="{B5DC09CA-6CD4-43F7-8607-5135DBD6D67A}" dt="2025-07-15T02:44:36.699" v="2" actId="22"/>
+          <ac:spMkLst>
+            <pc:docMk/>
+            <pc:sldMk cId="1403429394" sldId="257"/>
+            <ac:spMk id="3" creationId="{4BB9EFAB-D6FE-5B26-B821-0CA7E7C4B463}"/>
+          </ac:spMkLst>
+        </pc:spChg>
+        <pc:spChg chg="add mod">
+          <ac:chgData name="Fatima Pillosu" userId="a6295d4dc9e22643" providerId="LiveId" clId="{B5DC09CA-6CD4-43F7-8607-5135DBD6D67A}" dt="2025-07-15T02:45:25.851" v="19" actId="1036"/>
+          <ac:spMkLst>
+            <pc:docMk/>
+            <pc:sldMk cId="1403429394" sldId="257"/>
+            <ac:spMk id="17" creationId="{082CB828-3055-C01D-1D9B-34D32699459C}"/>
+          </ac:spMkLst>
+        </pc:spChg>
+        <pc:spChg chg="add mod">
+          <ac:chgData name="Fatima Pillosu" userId="a6295d4dc9e22643" providerId="LiveId" clId="{B5DC09CA-6CD4-43F7-8607-5135DBD6D67A}" dt="2025-07-15T02:45:25.851" v="19" actId="1036"/>
+          <ac:spMkLst>
+            <pc:docMk/>
+            <pc:sldMk cId="1403429394" sldId="257"/>
+            <ac:spMk id="18" creationId="{26462B98-3F43-7391-382E-5FA37001F70A}"/>
+          </ac:spMkLst>
+        </pc:spChg>
+        <pc:spChg chg="add mod">
+          <ac:chgData name="Fatima Pillosu" userId="a6295d4dc9e22643" providerId="LiveId" clId="{B5DC09CA-6CD4-43F7-8607-5135DBD6D67A}" dt="2025-07-15T02:45:25.851" v="19" actId="1036"/>
+          <ac:spMkLst>
+            <pc:docMk/>
+            <pc:sldMk cId="1403429394" sldId="257"/>
+            <ac:spMk id="19" creationId="{FB1D83BF-C5B8-0F42-ACF1-801724C77646}"/>
+          </ac:spMkLst>
+        </pc:spChg>
+        <pc:spChg chg="add mod">
+          <ac:chgData name="Fatima Pillosu" userId="a6295d4dc9e22643" providerId="LiveId" clId="{B5DC09CA-6CD4-43F7-8607-5135DBD6D67A}" dt="2025-07-15T02:45:25.851" v="19" actId="1036"/>
+          <ac:spMkLst>
+            <pc:docMk/>
+            <pc:sldMk cId="1403429394" sldId="257"/>
+            <ac:spMk id="20" creationId="{EFB51189-ED1C-9467-A21E-04098224201A}"/>
+          </ac:spMkLst>
+        </pc:spChg>
+        <pc:spChg chg="add mod">
+          <ac:chgData name="Fatima Pillosu" userId="a6295d4dc9e22643" providerId="LiveId" clId="{B5DC09CA-6CD4-43F7-8607-5135DBD6D67A}" dt="2025-07-15T02:45:25.851" v="19" actId="1036"/>
+          <ac:spMkLst>
+            <pc:docMk/>
+            <pc:sldMk cId="1403429394" sldId="257"/>
+            <ac:spMk id="21" creationId="{21C332B9-C99D-6C2F-F7A7-D75A6499E176}"/>
+          </ac:spMkLst>
+        </pc:spChg>
+        <pc:spChg chg="add mod">
+          <ac:chgData name="Fatima Pillosu" userId="a6295d4dc9e22643" providerId="LiveId" clId="{B5DC09CA-6CD4-43F7-8607-5135DBD6D67A}" dt="2025-07-15T02:45:25.851" v="19" actId="1036"/>
+          <ac:spMkLst>
+            <pc:docMk/>
+            <pc:sldMk cId="1403429394" sldId="257"/>
+            <ac:spMk id="22" creationId="{88809429-C163-FEA9-654A-C938A20C2ED1}"/>
+          </ac:spMkLst>
+        </pc:spChg>
+        <pc:spChg chg="add mod">
+          <ac:chgData name="Fatima Pillosu" userId="a6295d4dc9e22643" providerId="LiveId" clId="{B5DC09CA-6CD4-43F7-8607-5135DBD6D67A}" dt="2025-07-15T02:45:25.851" v="19" actId="1036"/>
+          <ac:spMkLst>
+            <pc:docMk/>
+            <pc:sldMk cId="1403429394" sldId="257"/>
+            <ac:spMk id="23" creationId="{64A6DF9F-4002-0BE8-0275-A7A7B18AE50E}"/>
+          </ac:spMkLst>
+        </pc:spChg>
+        <pc:spChg chg="add mod">
+          <ac:chgData name="Fatima Pillosu" userId="a6295d4dc9e22643" providerId="LiveId" clId="{B5DC09CA-6CD4-43F7-8607-5135DBD6D67A}" dt="2025-07-15T02:45:25.851" v="19" actId="1036"/>
+          <ac:spMkLst>
+            <pc:docMk/>
+            <pc:sldMk cId="1403429394" sldId="257"/>
+            <ac:spMk id="24" creationId="{FBF4F939-D8E0-4CA6-4395-BE2703ED47D3}"/>
+          </ac:spMkLst>
+        </pc:spChg>
+        <pc:spChg chg="add mod">
+          <ac:chgData name="Fatima Pillosu" userId="a6295d4dc9e22643" providerId="LiveId" clId="{B5DC09CA-6CD4-43F7-8607-5135DBD6D67A}" dt="2025-07-15T02:45:25.851" v="19" actId="1036"/>
+          <ac:spMkLst>
+            <pc:docMk/>
+            <pc:sldMk cId="1403429394" sldId="257"/>
+            <ac:spMk id="25" creationId="{9886A46A-5F0E-29C0-5553-F3C415C39030}"/>
+          </ac:spMkLst>
+        </pc:spChg>
+        <pc:spChg chg="add mod">
+          <ac:chgData name="Fatima Pillosu" userId="a6295d4dc9e22643" providerId="LiveId" clId="{B5DC09CA-6CD4-43F7-8607-5135DBD6D67A}" dt="2025-07-15T02:45:25.851" v="19" actId="1036"/>
+          <ac:spMkLst>
+            <pc:docMk/>
+            <pc:sldMk cId="1403429394" sldId="257"/>
+            <ac:spMk id="26" creationId="{DD731501-A656-7957-75AF-86B51CC75396}"/>
+          </ac:spMkLst>
+        </pc:spChg>
+        <pc:spChg chg="add mod">
+          <ac:chgData name="Fatima Pillosu" userId="a6295d4dc9e22643" providerId="LiveId" clId="{B5DC09CA-6CD4-43F7-8607-5135DBD6D67A}" dt="2025-07-15T02:45:25.851" v="19" actId="1036"/>
+          <ac:spMkLst>
+            <pc:docMk/>
+            <pc:sldMk cId="1403429394" sldId="257"/>
+            <ac:spMk id="27" creationId="{DE08B4AE-3720-60F1-D6B9-743C32AD6707}"/>
+          </ac:spMkLst>
+        </pc:spChg>
+        <pc:spChg chg="add mod">
+          <ac:chgData name="Fatima Pillosu" userId="a6295d4dc9e22643" providerId="LiveId" clId="{B5DC09CA-6CD4-43F7-8607-5135DBD6D67A}" dt="2025-07-15T02:45:25.851" v="19" actId="1036"/>
+          <ac:spMkLst>
+            <pc:docMk/>
+            <pc:sldMk cId="1403429394" sldId="257"/>
+            <ac:spMk id="28" creationId="{9C4F17D1-D949-02CB-0B46-48106B0B393C}"/>
+          </ac:spMkLst>
+        </pc:spChg>
+        <pc:spChg chg="add mod">
+          <ac:chgData name="Fatima Pillosu" userId="a6295d4dc9e22643" providerId="LiveId" clId="{B5DC09CA-6CD4-43F7-8607-5135DBD6D67A}" dt="2025-07-15T02:45:25.851" v="19" actId="1036"/>
+          <ac:spMkLst>
+            <pc:docMk/>
+            <pc:sldMk cId="1403429394" sldId="257"/>
+            <ac:spMk id="29" creationId="{455A54B8-5CD9-B620-BC08-5F6DA9DF0ED8}"/>
+          </ac:spMkLst>
+        </pc:spChg>
+        <pc:spChg chg="add mod">
+          <ac:chgData name="Fatima Pillosu" userId="a6295d4dc9e22643" providerId="LiveId" clId="{B5DC09CA-6CD4-43F7-8607-5135DBD6D67A}" dt="2025-07-15T02:45:25.851" v="19" actId="1036"/>
+          <ac:spMkLst>
+            <pc:docMk/>
+            <pc:sldMk cId="1403429394" sldId="257"/>
+            <ac:spMk id="30" creationId="{55890E00-81A3-E28D-C052-5E4FA9603339}"/>
+          </ac:spMkLst>
+        </pc:spChg>
+        <pc:spChg chg="add mod">
+          <ac:chgData name="Fatima Pillosu" userId="a6295d4dc9e22643" providerId="LiveId" clId="{B5DC09CA-6CD4-43F7-8607-5135DBD6D67A}" dt="2025-07-15T02:45:25.851" v="19" actId="1036"/>
+          <ac:spMkLst>
+            <pc:docMk/>
+            <pc:sldMk cId="1403429394" sldId="257"/>
+            <ac:spMk id="31" creationId="{D22BC35C-D8BA-9C47-5E36-D7A2E39E7940}"/>
+          </ac:spMkLst>
+        </pc:spChg>
+        <pc:spChg chg="add mod">
+          <ac:chgData name="Fatima Pillosu" userId="a6295d4dc9e22643" providerId="LiveId" clId="{B5DC09CA-6CD4-43F7-8607-5135DBD6D67A}" dt="2025-07-15T02:45:25.851" v="19" actId="1036"/>
+          <ac:spMkLst>
+            <pc:docMk/>
+            <pc:sldMk cId="1403429394" sldId="257"/>
+            <ac:spMk id="32" creationId="{2847A4E1-5D8A-BA47-5F8F-485D455DD114}"/>
+          </ac:spMkLst>
+        </pc:spChg>
+        <pc:spChg chg="add mod">
+          <ac:chgData name="Fatima Pillosu" userId="a6295d4dc9e22643" providerId="LiveId" clId="{B5DC09CA-6CD4-43F7-8607-5135DBD6D67A}" dt="2025-07-15T02:45:25.851" v="19" actId="1036"/>
+          <ac:spMkLst>
+            <pc:docMk/>
+            <pc:sldMk cId="1403429394" sldId="257"/>
+            <ac:spMk id="33" creationId="{9A16AC1B-8EF3-92A4-CABD-D73AD244F75E}"/>
+          </ac:spMkLst>
+        </pc:spChg>
+        <pc:spChg chg="add mod">
+          <ac:chgData name="Fatima Pillosu" userId="a6295d4dc9e22643" providerId="LiveId" clId="{B5DC09CA-6CD4-43F7-8607-5135DBD6D67A}" dt="2025-07-15T02:45:17.215" v="11"/>
+          <ac:spMkLst>
+            <pc:docMk/>
+            <pc:sldMk cId="1403429394" sldId="257"/>
+            <ac:spMk id="34" creationId="{15B66109-5EC0-175E-124D-C46996895CE7}"/>
+          </ac:spMkLst>
+        </pc:spChg>
+        <pc:spChg chg="add mod">
+          <ac:chgData name="Fatima Pillosu" userId="a6295d4dc9e22643" providerId="LiveId" clId="{B5DC09CA-6CD4-43F7-8607-5135DBD6D67A}" dt="2025-07-15T02:45:25.851" v="19" actId="1036"/>
+          <ac:spMkLst>
+            <pc:docMk/>
+            <pc:sldMk cId="1403429394" sldId="257"/>
+            <ac:spMk id="35" creationId="{376BC6E3-86E2-3737-AB80-3B95CB16E8E3}"/>
+          </ac:spMkLst>
+        </pc:spChg>
+        <pc:spChg chg="add mod">
+          <ac:chgData name="Fatima Pillosu" userId="a6295d4dc9e22643" providerId="LiveId" clId="{B5DC09CA-6CD4-43F7-8607-5135DBD6D67A}" dt="2025-07-15T02:45:25.851" v="19" actId="1036"/>
+          <ac:spMkLst>
+            <pc:docMk/>
+            <pc:sldMk cId="1403429394" sldId="257"/>
+            <ac:spMk id="36" creationId="{12D385A0-4768-7304-9AF2-9662B3618F45}"/>
+          </ac:spMkLst>
+        </pc:spChg>
+        <pc:spChg chg="add mod">
+          <ac:chgData name="Fatima Pillosu" userId="a6295d4dc9e22643" providerId="LiveId" clId="{B5DC09CA-6CD4-43F7-8607-5135DBD6D67A}" dt="2025-07-15T02:45:25.851" v="19" actId="1036"/>
+          <ac:spMkLst>
+            <pc:docMk/>
+            <pc:sldMk cId="1403429394" sldId="257"/>
+            <ac:spMk id="37" creationId="{57E75AC1-1794-5E7F-F1C7-E3D46F9F3C6B}"/>
+          </ac:spMkLst>
+        </pc:spChg>
+        <pc:spChg chg="add mod">
+          <ac:chgData name="Fatima Pillosu" userId="a6295d4dc9e22643" providerId="LiveId" clId="{B5DC09CA-6CD4-43F7-8607-5135DBD6D67A}" dt="2025-07-15T02:45:25.851" v="19" actId="1036"/>
+          <ac:spMkLst>
+            <pc:docMk/>
+            <pc:sldMk cId="1403429394" sldId="257"/>
+            <ac:spMk id="38" creationId="{51966A53-077B-E857-FB56-6D8CABD214E0}"/>
+          </ac:spMkLst>
+        </pc:spChg>
+        <pc:spChg chg="add mod">
+          <ac:chgData name="Fatima Pillosu" userId="a6295d4dc9e22643" providerId="LiveId" clId="{B5DC09CA-6CD4-43F7-8607-5135DBD6D67A}" dt="2025-07-15T02:45:25.851" v="19" actId="1036"/>
+          <ac:spMkLst>
+            <pc:docMk/>
+            <pc:sldMk cId="1403429394" sldId="257"/>
+            <ac:spMk id="39" creationId="{35DD87AC-C1BC-2933-33E1-AC551ED331CE}"/>
+          </ac:spMkLst>
+        </pc:spChg>
+        <pc:spChg chg="add mod">
+          <ac:chgData name="Fatima Pillosu" userId="a6295d4dc9e22643" providerId="LiveId" clId="{B5DC09CA-6CD4-43F7-8607-5135DBD6D67A}" dt="2025-07-15T02:45:25.851" v="19" actId="1036"/>
+          <ac:spMkLst>
+            <pc:docMk/>
+            <pc:sldMk cId="1403429394" sldId="257"/>
+            <ac:spMk id="40" creationId="{75493878-E8E3-4B21-EDED-882FA025EE50}"/>
+          </ac:spMkLst>
+        </pc:spChg>
+        <pc:spChg chg="add mod">
+          <ac:chgData name="Fatima Pillosu" userId="a6295d4dc9e22643" providerId="LiveId" clId="{B5DC09CA-6CD4-43F7-8607-5135DBD6D67A}" dt="2025-07-15T02:45:25.851" v="19" actId="1036"/>
+          <ac:spMkLst>
+            <pc:docMk/>
+            <pc:sldMk cId="1403429394" sldId="257"/>
+            <ac:spMk id="41" creationId="{000021FB-3D9A-C671-5BD8-5FD3D4F57EAF}"/>
+          </ac:spMkLst>
+        </pc:spChg>
+        <pc:spChg chg="add mod">
+          <ac:chgData name="Fatima Pillosu" userId="a6295d4dc9e22643" providerId="LiveId" clId="{B5DC09CA-6CD4-43F7-8607-5135DBD6D67A}" dt="2025-07-15T02:45:25.851" v="19" actId="1036"/>
+          <ac:spMkLst>
+            <pc:docMk/>
+            <pc:sldMk cId="1403429394" sldId="257"/>
+            <ac:spMk id="42" creationId="{1D9A1454-C5EC-EF96-9456-6EFA68D93F96}"/>
+          </ac:spMkLst>
+        </pc:spChg>
+        <pc:spChg chg="add mod">
+          <ac:chgData name="Fatima Pillosu" userId="a6295d4dc9e22643" providerId="LiveId" clId="{B5DC09CA-6CD4-43F7-8607-5135DBD6D67A}" dt="2025-07-15T02:45:25.851" v="19" actId="1036"/>
+          <ac:spMkLst>
+            <pc:docMk/>
+            <pc:sldMk cId="1403429394" sldId="257"/>
+            <ac:spMk id="43" creationId="{CE3B5F6B-A16B-67FA-B1F3-40AF319AD7BD}"/>
+          </ac:spMkLst>
+        </pc:spChg>
+        <pc:spChg chg="add mod">
+          <ac:chgData name="Fatima Pillosu" userId="a6295d4dc9e22643" providerId="LiveId" clId="{B5DC09CA-6CD4-43F7-8607-5135DBD6D67A}" dt="2025-07-15T02:45:25.851" v="19" actId="1036"/>
+          <ac:spMkLst>
+            <pc:docMk/>
+            <pc:sldMk cId="1403429394" sldId="257"/>
+            <ac:spMk id="44" creationId="{3FF0EAA4-2EF5-4F38-B6EC-35ED6BE230C8}"/>
+          </ac:spMkLst>
+        </pc:spChg>
+        <pc:spChg chg="add mod">
+          <ac:chgData name="Fatima Pillosu" userId="a6295d4dc9e22643" providerId="LiveId" clId="{B5DC09CA-6CD4-43F7-8607-5135DBD6D67A}" dt="2025-07-15T02:45:25.851" v="19" actId="1036"/>
+          <ac:spMkLst>
+            <pc:docMk/>
+            <pc:sldMk cId="1403429394" sldId="257"/>
+            <ac:spMk id="45" creationId="{9C0BF0B8-9ECF-FB3A-55AD-9010A6D0C88A}"/>
+          </ac:spMkLst>
+        </pc:spChg>
+        <pc:spChg chg="add mod">
+          <ac:chgData name="Fatima Pillosu" userId="a6295d4dc9e22643" providerId="LiveId" clId="{B5DC09CA-6CD4-43F7-8607-5135DBD6D67A}" dt="2025-07-15T02:45:25.851" v="19" actId="1036"/>
+          <ac:spMkLst>
+            <pc:docMk/>
+            <pc:sldMk cId="1403429394" sldId="257"/>
+            <ac:spMk id="46" creationId="{B4F89EAC-F5BE-5AB3-6D3A-51942411D6AC}"/>
+          </ac:spMkLst>
+        </pc:spChg>
+        <pc:spChg chg="add mod">
+          <ac:chgData name="Fatima Pillosu" userId="a6295d4dc9e22643" providerId="LiveId" clId="{B5DC09CA-6CD4-43F7-8607-5135DBD6D67A}" dt="2025-07-15T02:45:25.851" v="19" actId="1036"/>
+          <ac:spMkLst>
+            <pc:docMk/>
+            <pc:sldMk cId="1403429394" sldId="257"/>
+            <ac:spMk id="47" creationId="{4B314188-7F22-6C36-D5F3-C79B9823CCF9}"/>
+          </ac:spMkLst>
+        </pc:spChg>
+        <pc:spChg chg="add mod">
+          <ac:chgData name="Fatima Pillosu" userId="a6295d4dc9e22643" providerId="LiveId" clId="{B5DC09CA-6CD4-43F7-8607-5135DBD6D67A}" dt="2025-07-15T02:45:25.851" v="19" actId="1036"/>
+          <ac:spMkLst>
+            <pc:docMk/>
+            <pc:sldMk cId="1403429394" sldId="257"/>
+            <ac:spMk id="48" creationId="{445A7559-4D19-A6F6-DA0F-D756F483D299}"/>
+          </ac:spMkLst>
+        </pc:spChg>
+        <pc:spChg chg="add mod">
+          <ac:chgData name="Fatima Pillosu" userId="a6295d4dc9e22643" providerId="LiveId" clId="{B5DC09CA-6CD4-43F7-8607-5135DBD6D67A}" dt="2025-07-15T02:45:25.851" v="19" actId="1036"/>
+          <ac:spMkLst>
+            <pc:docMk/>
+            <pc:sldMk cId="1403429394" sldId="257"/>
+            <ac:spMk id="49" creationId="{A4EE99A9-33C7-3773-9DEA-E39F625A5212}"/>
+          </ac:spMkLst>
+        </pc:spChg>
+        <pc:spChg chg="add mod">
+          <ac:chgData name="Fatima Pillosu" userId="a6295d4dc9e22643" providerId="LiveId" clId="{B5DC09CA-6CD4-43F7-8607-5135DBD6D67A}" dt="2025-07-15T02:45:25.851" v="19" actId="1036"/>
+          <ac:spMkLst>
+            <pc:docMk/>
+            <pc:sldMk cId="1403429394" sldId="257"/>
+            <ac:spMk id="50" creationId="{D8B522E8-1814-1FE6-CF46-055B320030EF}"/>
+          </ac:spMkLst>
+        </pc:spChg>
+        <pc:spChg chg="add mod">
+          <ac:chgData name="Fatima Pillosu" userId="a6295d4dc9e22643" providerId="LiveId" clId="{B5DC09CA-6CD4-43F7-8607-5135DBD6D67A}" dt="2025-07-15T02:45:25.851" v="19" actId="1036"/>
+          <ac:spMkLst>
+            <pc:docMk/>
+            <pc:sldMk cId="1403429394" sldId="257"/>
+            <ac:spMk id="51" creationId="{F0474377-B166-9FE7-F0CD-757289DF5B18}"/>
+          </ac:spMkLst>
+        </pc:spChg>
+        <pc:spChg chg="add mod">
+          <ac:chgData name="Fatima Pillosu" userId="a6295d4dc9e22643" providerId="LiveId" clId="{B5DC09CA-6CD4-43F7-8607-5135DBD6D67A}" dt="2025-07-15T02:45:25.851" v="19" actId="1036"/>
+          <ac:spMkLst>
+            <pc:docMk/>
+            <pc:sldMk cId="1403429394" sldId="257"/>
+            <ac:spMk id="52" creationId="{2EC17A87-5F98-30A0-B0E4-2CF025030731}"/>
+          </ac:spMkLst>
+        </pc:spChg>
+        <pc:spChg chg="add mod">
+          <ac:chgData name="Fatima Pillosu" userId="a6295d4dc9e22643" providerId="LiveId" clId="{B5DC09CA-6CD4-43F7-8607-5135DBD6D67A}" dt="2025-07-15T02:45:25.851" v="19" actId="1036"/>
+          <ac:spMkLst>
+            <pc:docMk/>
+            <pc:sldMk cId="1403429394" sldId="257"/>
+            <ac:spMk id="53" creationId="{B449B9DC-BC6D-3397-ECEA-E2B1A14A2A1D}"/>
+          </ac:spMkLst>
+        </pc:spChg>
+        <pc:spChg chg="add mod">
+          <ac:chgData name="Fatima Pillosu" userId="a6295d4dc9e22643" providerId="LiveId" clId="{B5DC09CA-6CD4-43F7-8607-5135DBD6D67A}" dt="2025-07-15T02:45:25.851" v="19" actId="1036"/>
+          <ac:spMkLst>
+            <pc:docMk/>
+            <pc:sldMk cId="1403429394" sldId="257"/>
+            <ac:spMk id="54" creationId="{F931034A-7D6F-8EA8-77FA-38D23B11D246}"/>
+          </ac:spMkLst>
+        </pc:spChg>
+        <pc:spChg chg="add mod">
+          <ac:chgData name="Fatima Pillosu" userId="a6295d4dc9e22643" providerId="LiveId" clId="{B5DC09CA-6CD4-43F7-8607-5135DBD6D67A}" dt="2025-07-15T02:45:25.851" v="19" actId="1036"/>
+          <ac:spMkLst>
+            <pc:docMk/>
+            <pc:sldMk cId="1403429394" sldId="257"/>
+            <ac:spMk id="55" creationId="{4E92A261-3F68-2130-689A-A1282F999C88}"/>
+          </ac:spMkLst>
+        </pc:spChg>
+        <pc:spChg chg="add mod">
+          <ac:chgData name="Fatima Pillosu" userId="a6295d4dc9e22643" providerId="LiveId" clId="{B5DC09CA-6CD4-43F7-8607-5135DBD6D67A}" dt="2025-07-15T02:45:25.851" v="19" actId="1036"/>
+          <ac:spMkLst>
+            <pc:docMk/>
+            <pc:sldMk cId="1403429394" sldId="257"/>
+            <ac:spMk id="56" creationId="{13B4ED1F-BA20-584D-160D-E72FD57F6E94}"/>
+          </ac:spMkLst>
+        </pc:spChg>
+        <pc:spChg chg="add mod">
+          <ac:chgData name="Fatima Pillosu" userId="a6295d4dc9e22643" providerId="LiveId" clId="{B5DC09CA-6CD4-43F7-8607-5135DBD6D67A}" dt="2025-07-15T02:45:25.851" v="19" actId="1036"/>
+          <ac:spMkLst>
+            <pc:docMk/>
+            <pc:sldMk cId="1403429394" sldId="257"/>
+            <ac:spMk id="57" creationId="{9E17B2EA-5075-2F32-48F1-B8F79DC14C38}"/>
+          </ac:spMkLst>
+        </pc:spChg>
+        <pc:spChg chg="add mod">
+          <ac:chgData name="Fatima Pillosu" userId="a6295d4dc9e22643" providerId="LiveId" clId="{B5DC09CA-6CD4-43F7-8607-5135DBD6D67A}" dt="2025-07-15T02:45:25.851" v="19" actId="1036"/>
+          <ac:spMkLst>
+            <pc:docMk/>
+            <pc:sldMk cId="1403429394" sldId="257"/>
+            <ac:spMk id="58" creationId="{3C88EA91-CBB6-2923-84E8-958EAB03D695}"/>
+          </ac:spMkLst>
+        </pc:spChg>
+        <pc:spChg chg="add mod">
+          <ac:chgData name="Fatima Pillosu" userId="a6295d4dc9e22643" providerId="LiveId" clId="{B5DC09CA-6CD4-43F7-8607-5135DBD6D67A}" dt="2025-07-15T02:45:25.851" v="19" actId="1036"/>
+          <ac:spMkLst>
+            <pc:docMk/>
+            <pc:sldMk cId="1403429394" sldId="257"/>
+            <ac:spMk id="59" creationId="{398D0DBF-C0BF-0EAB-70D2-6FAFBE8D8584}"/>
+          </ac:spMkLst>
+        </pc:spChg>
+        <pc:spChg chg="add mod">
+          <ac:chgData name="Fatima Pillosu" userId="a6295d4dc9e22643" providerId="LiveId" clId="{B5DC09CA-6CD4-43F7-8607-5135DBD6D67A}" dt="2025-07-15T02:45:25.851" v="19" actId="1036"/>
+          <ac:spMkLst>
+            <pc:docMk/>
+            <pc:sldMk cId="1403429394" sldId="257"/>
+            <ac:spMk id="60" creationId="{BB947B23-D613-6274-5A1A-0612C9DDC7BA}"/>
+          </ac:spMkLst>
+        </pc:spChg>
+        <pc:spChg chg="add mod">
+          <ac:chgData name="Fatima Pillosu" userId="a6295d4dc9e22643" providerId="LiveId" clId="{B5DC09CA-6CD4-43F7-8607-5135DBD6D67A}" dt="2025-07-15T02:45:25.851" v="19" actId="1036"/>
+          <ac:spMkLst>
+            <pc:docMk/>
+            <pc:sldMk cId="1403429394" sldId="257"/>
+            <ac:spMk id="61" creationId="{5B5E25C5-CF55-1AD6-2F46-56FF2C9AA072}"/>
+          </ac:spMkLst>
+        </pc:spChg>
+        <pc:spChg chg="add mod">
+          <ac:chgData name="Fatima Pillosu" userId="a6295d4dc9e22643" providerId="LiveId" clId="{B5DC09CA-6CD4-43F7-8607-5135DBD6D67A}" dt="2025-07-15T02:45:25.851" v="19" actId="1036"/>
+          <ac:spMkLst>
+            <pc:docMk/>
+            <pc:sldMk cId="1403429394" sldId="257"/>
+            <ac:spMk id="62" creationId="{89D57BAF-EDF7-DFF3-25C8-DBF5CA7C01E8}"/>
+          </ac:spMkLst>
+        </pc:spChg>
+        <pc:spChg chg="add mod">
+          <ac:chgData name="Fatima Pillosu" userId="a6295d4dc9e22643" providerId="LiveId" clId="{B5DC09CA-6CD4-43F7-8607-5135DBD6D67A}" dt="2025-07-15T02:45:25.851" v="19" actId="1036"/>
+          <ac:spMkLst>
+            <pc:docMk/>
+            <pc:sldMk cId="1403429394" sldId="257"/>
+            <ac:spMk id="63" creationId="{2A0340DF-C636-D189-A28F-EA34AB5D27EE}"/>
+          </ac:spMkLst>
+        </pc:spChg>
+        <pc:spChg chg="add mod">
+          <ac:chgData name="Fatima Pillosu" userId="a6295d4dc9e22643" providerId="LiveId" clId="{B5DC09CA-6CD4-43F7-8607-5135DBD6D67A}" dt="2025-07-15T02:45:25.851" v="19" actId="1036"/>
+          <ac:spMkLst>
+            <pc:docMk/>
+            <pc:sldMk cId="1403429394" sldId="257"/>
+            <ac:spMk id="64" creationId="{12F38479-AB54-6B30-2D3C-FF8C0302CC0C}"/>
+          </ac:spMkLst>
+        </pc:spChg>
+        <pc:spChg chg="add mod">
+          <ac:chgData name="Fatima Pillosu" userId="a6295d4dc9e22643" providerId="LiveId" clId="{B5DC09CA-6CD4-43F7-8607-5135DBD6D67A}" dt="2025-07-15T02:45:25.851" v="19" actId="1036"/>
+          <ac:spMkLst>
+            <pc:docMk/>
+            <pc:sldMk cId="1403429394" sldId="257"/>
+            <ac:spMk id="65" creationId="{F814593F-D80C-3FAD-DC51-3489C5EF4A97}"/>
+          </ac:spMkLst>
+        </pc:spChg>
+        <pc:spChg chg="del mod">
+          <ac:chgData name="Fatima Pillosu" userId="a6295d4dc9e22643" providerId="LiveId" clId="{B5DC09CA-6CD4-43F7-8607-5135DBD6D67A}" dt="2025-07-15T02:45:05.956" v="10" actId="21"/>
+          <ac:spMkLst>
+            <pc:docMk/>
+            <pc:sldMk cId="1403429394" sldId="257"/>
+            <ac:spMk id="76" creationId="{082CB828-3055-C01D-1D9B-34D32699459C}"/>
+          </ac:spMkLst>
+        </pc:spChg>
+        <pc:spChg chg="del mod">
+          <ac:chgData name="Fatima Pillosu" userId="a6295d4dc9e22643" providerId="LiveId" clId="{B5DC09CA-6CD4-43F7-8607-5135DBD6D67A}" dt="2025-07-15T02:45:05.956" v="10" actId="21"/>
+          <ac:spMkLst>
+            <pc:docMk/>
+            <pc:sldMk cId="1403429394" sldId="257"/>
+            <ac:spMk id="77" creationId="{26462B98-3F43-7391-382E-5FA37001F70A}"/>
+          </ac:spMkLst>
+        </pc:spChg>
+        <pc:spChg chg="del mod">
+          <ac:chgData name="Fatima Pillosu" userId="a6295d4dc9e22643" providerId="LiveId" clId="{B5DC09CA-6CD4-43F7-8607-5135DBD6D67A}" dt="2025-07-15T02:45:05.956" v="10" actId="21"/>
+          <ac:spMkLst>
+            <pc:docMk/>
+            <pc:sldMk cId="1403429394" sldId="257"/>
+            <ac:spMk id="78" creationId="{FB1D83BF-C5B8-0F42-ACF1-801724C77646}"/>
+          </ac:spMkLst>
+        </pc:spChg>
+        <pc:spChg chg="del mod">
+          <ac:chgData name="Fatima Pillosu" userId="a6295d4dc9e22643" providerId="LiveId" clId="{B5DC09CA-6CD4-43F7-8607-5135DBD6D67A}" dt="2025-07-15T02:45:05.956" v="10" actId="21"/>
+          <ac:spMkLst>
+            <pc:docMk/>
+            <pc:sldMk cId="1403429394" sldId="257"/>
+            <ac:spMk id="79" creationId="{EFB51189-ED1C-9467-A21E-04098224201A}"/>
+          </ac:spMkLst>
+        </pc:spChg>
+        <pc:spChg chg="del mod">
+          <ac:chgData name="Fatima Pillosu" userId="a6295d4dc9e22643" providerId="LiveId" clId="{B5DC09CA-6CD4-43F7-8607-5135DBD6D67A}" dt="2025-07-15T02:45:05.956" v="10" actId="21"/>
+          <ac:spMkLst>
+            <pc:docMk/>
+            <pc:sldMk cId="1403429394" sldId="257"/>
+            <ac:spMk id="80" creationId="{21C332B9-C99D-6C2F-F7A7-D75A6499E176}"/>
+          </ac:spMkLst>
+        </pc:spChg>
+        <pc:spChg chg="del mod">
+          <ac:chgData name="Fatima Pillosu" userId="a6295d4dc9e22643" providerId="LiveId" clId="{B5DC09CA-6CD4-43F7-8607-5135DBD6D67A}" dt="2025-07-15T02:45:05.956" v="10" actId="21"/>
+          <ac:spMkLst>
+            <pc:docMk/>
+            <pc:sldMk cId="1403429394" sldId="257"/>
+            <ac:spMk id="81" creationId="{88809429-C163-FEA9-654A-C938A20C2ED1}"/>
+          </ac:spMkLst>
+        </pc:spChg>
+        <pc:spChg chg="del mod">
+          <ac:chgData name="Fatima Pillosu" userId="a6295d4dc9e22643" providerId="LiveId" clId="{B5DC09CA-6CD4-43F7-8607-5135DBD6D67A}" dt="2025-07-15T02:45:05.956" v="10" actId="21"/>
+          <ac:spMkLst>
+            <pc:docMk/>
+            <pc:sldMk cId="1403429394" sldId="257"/>
+            <ac:spMk id="82" creationId="{64A6DF9F-4002-0BE8-0275-A7A7B18AE50E}"/>
+          </ac:spMkLst>
+        </pc:spChg>
+        <pc:spChg chg="del mod">
+          <ac:chgData name="Fatima Pillosu" userId="a6295d4dc9e22643" providerId="LiveId" clId="{B5DC09CA-6CD4-43F7-8607-5135DBD6D67A}" dt="2025-07-15T02:45:05.956" v="10" actId="21"/>
+          <ac:spMkLst>
+            <pc:docMk/>
+            <pc:sldMk cId="1403429394" sldId="257"/>
+            <ac:spMk id="83" creationId="{FBF4F939-D8E0-4CA6-4395-BE2703ED47D3}"/>
+          </ac:spMkLst>
+        </pc:spChg>
+        <pc:spChg chg="del mod">
+          <ac:chgData name="Fatima Pillosu" userId="a6295d4dc9e22643" providerId="LiveId" clId="{B5DC09CA-6CD4-43F7-8607-5135DBD6D67A}" dt="2025-07-15T02:45:05.956" v="10" actId="21"/>
+          <ac:spMkLst>
+            <pc:docMk/>
+            <pc:sldMk cId="1403429394" sldId="257"/>
+            <ac:spMk id="84" creationId="{9886A46A-5F0E-29C0-5553-F3C415C39030}"/>
+          </ac:spMkLst>
+        </pc:spChg>
+        <pc:spChg chg="del mod">
+          <ac:chgData name="Fatima Pillosu" userId="a6295d4dc9e22643" providerId="LiveId" clId="{B5DC09CA-6CD4-43F7-8607-5135DBD6D67A}" dt="2025-07-15T02:45:05.956" v="10" actId="21"/>
+          <ac:spMkLst>
+            <pc:docMk/>
+            <pc:sldMk cId="1403429394" sldId="257"/>
+            <ac:spMk id="85" creationId="{DD731501-A656-7957-75AF-86B51CC75396}"/>
+          </ac:spMkLst>
+        </pc:spChg>
+        <pc:spChg chg="del mod">
+          <ac:chgData name="Fatima Pillosu" userId="a6295d4dc9e22643" providerId="LiveId" clId="{B5DC09CA-6CD4-43F7-8607-5135DBD6D67A}" dt="2025-07-15T02:45:05.956" v="10" actId="21"/>
+          <ac:spMkLst>
+            <pc:docMk/>
+            <pc:sldMk cId="1403429394" sldId="257"/>
+            <ac:spMk id="86" creationId="{DE08B4AE-3720-60F1-D6B9-743C32AD6707}"/>
+          </ac:spMkLst>
+        </pc:spChg>
+        <pc:spChg chg="del mod">
+          <ac:chgData name="Fatima Pillosu" userId="a6295d4dc9e22643" providerId="LiveId" clId="{B5DC09CA-6CD4-43F7-8607-5135DBD6D67A}" dt="2025-07-15T02:45:05.956" v="10" actId="21"/>
+          <ac:spMkLst>
+            <pc:docMk/>
+            <pc:sldMk cId="1403429394" sldId="257"/>
+            <ac:spMk id="87" creationId="{9C4F17D1-D949-02CB-0B46-48106B0B393C}"/>
+          </ac:spMkLst>
+        </pc:spChg>
+        <pc:spChg chg="del mod">
+          <ac:chgData name="Fatima Pillosu" userId="a6295d4dc9e22643" providerId="LiveId" clId="{B5DC09CA-6CD4-43F7-8607-5135DBD6D67A}" dt="2025-07-15T02:45:05.956" v="10" actId="21"/>
+          <ac:spMkLst>
+            <pc:docMk/>
+            <pc:sldMk cId="1403429394" sldId="257"/>
+            <ac:spMk id="88" creationId="{455A54B8-5CD9-B620-BC08-5F6DA9DF0ED8}"/>
+          </ac:spMkLst>
+        </pc:spChg>
+        <pc:spChg chg="del mod">
+          <ac:chgData name="Fatima Pillosu" userId="a6295d4dc9e22643" providerId="LiveId" clId="{B5DC09CA-6CD4-43F7-8607-5135DBD6D67A}" dt="2025-07-15T02:45:05.956" v="10" actId="21"/>
+          <ac:spMkLst>
+            <pc:docMk/>
+            <pc:sldMk cId="1403429394" sldId="257"/>
+            <ac:spMk id="89" creationId="{55890E00-81A3-E28D-C052-5E4FA9603339}"/>
+          </ac:spMkLst>
+        </pc:spChg>
+        <pc:spChg chg="del mod">
+          <ac:chgData name="Fatima Pillosu" userId="a6295d4dc9e22643" providerId="LiveId" clId="{B5DC09CA-6CD4-43F7-8607-5135DBD6D67A}" dt="2025-07-15T02:45:05.956" v="10" actId="21"/>
+          <ac:spMkLst>
+            <pc:docMk/>
+            <pc:sldMk cId="1403429394" sldId="257"/>
+            <ac:spMk id="90" creationId="{D22BC35C-D8BA-9C47-5E36-D7A2E39E7940}"/>
+          </ac:spMkLst>
+        </pc:spChg>
+        <pc:spChg chg="del mod">
+          <ac:chgData name="Fatima Pillosu" userId="a6295d4dc9e22643" providerId="LiveId" clId="{B5DC09CA-6CD4-43F7-8607-5135DBD6D67A}" dt="2025-07-15T02:45:05.956" v="10" actId="21"/>
+          <ac:spMkLst>
+            <pc:docMk/>
+            <pc:sldMk cId="1403429394" sldId="257"/>
+            <ac:spMk id="91" creationId="{2847A4E1-5D8A-BA47-5F8F-485D455DD114}"/>
+          </ac:spMkLst>
+        </pc:spChg>
+        <pc:spChg chg="del mod">
+          <ac:chgData name="Fatima Pillosu" userId="a6295d4dc9e22643" providerId="LiveId" clId="{B5DC09CA-6CD4-43F7-8607-5135DBD6D67A}" dt="2025-07-15T02:45:05.956" v="10" actId="21"/>
+          <ac:spMkLst>
+            <pc:docMk/>
+            <pc:sldMk cId="1403429394" sldId="257"/>
+            <ac:spMk id="92" creationId="{9A16AC1B-8EF3-92A4-CABD-D73AD244F75E}"/>
+          </ac:spMkLst>
+        </pc:spChg>
+        <pc:spChg chg="add del mod">
+          <ac:chgData name="Fatima Pillosu" userId="a6295d4dc9e22643" providerId="LiveId" clId="{B5DC09CA-6CD4-43F7-8607-5135DBD6D67A}" dt="2025-07-15T02:45:05.956" v="10" actId="21"/>
+          <ac:spMkLst>
+            <pc:docMk/>
+            <pc:sldMk cId="1403429394" sldId="257"/>
+            <ac:spMk id="93" creationId="{15B66109-5EC0-175E-124D-C46996895CE7}"/>
+          </ac:spMkLst>
+        </pc:spChg>
+        <pc:spChg chg="del mod">
+          <ac:chgData name="Fatima Pillosu" userId="a6295d4dc9e22643" providerId="LiveId" clId="{B5DC09CA-6CD4-43F7-8607-5135DBD6D67A}" dt="2025-07-15T02:45:05.956" v="10" actId="21"/>
+          <ac:spMkLst>
+            <pc:docMk/>
+            <pc:sldMk cId="1403429394" sldId="257"/>
+            <ac:spMk id="94" creationId="{376BC6E3-86E2-3737-AB80-3B95CB16E8E3}"/>
+          </ac:spMkLst>
+        </pc:spChg>
+        <pc:spChg chg="del mod">
+          <ac:chgData name="Fatima Pillosu" userId="a6295d4dc9e22643" providerId="LiveId" clId="{B5DC09CA-6CD4-43F7-8607-5135DBD6D67A}" dt="2025-07-15T02:45:05.956" v="10" actId="21"/>
+          <ac:spMkLst>
+            <pc:docMk/>
+            <pc:sldMk cId="1403429394" sldId="257"/>
+            <ac:spMk id="95" creationId="{12D385A0-4768-7304-9AF2-9662B3618F45}"/>
+          </ac:spMkLst>
+        </pc:spChg>
+        <pc:spChg chg="del mod">
+          <ac:chgData name="Fatima Pillosu" userId="a6295d4dc9e22643" providerId="LiveId" clId="{B5DC09CA-6CD4-43F7-8607-5135DBD6D67A}" dt="2025-07-15T02:45:05.956" v="10" actId="21"/>
+          <ac:spMkLst>
+            <pc:docMk/>
+            <pc:sldMk cId="1403429394" sldId="257"/>
+            <ac:spMk id="96" creationId="{57E75AC1-1794-5E7F-F1C7-E3D46F9F3C6B}"/>
+          </ac:spMkLst>
+        </pc:spChg>
+        <pc:spChg chg="del mod">
+          <ac:chgData name="Fatima Pillosu" userId="a6295d4dc9e22643" providerId="LiveId" clId="{B5DC09CA-6CD4-43F7-8607-5135DBD6D67A}" dt="2025-07-15T02:45:05.956" v="10" actId="21"/>
+          <ac:spMkLst>
+            <pc:docMk/>
+            <pc:sldMk cId="1403429394" sldId="257"/>
+            <ac:spMk id="97" creationId="{51966A53-077B-E857-FB56-6D8CABD214E0}"/>
+          </ac:spMkLst>
+        </pc:spChg>
+        <pc:spChg chg="del mod">
+          <ac:chgData name="Fatima Pillosu" userId="a6295d4dc9e22643" providerId="LiveId" clId="{B5DC09CA-6CD4-43F7-8607-5135DBD6D67A}" dt="2025-07-15T02:45:05.956" v="10" actId="21"/>
+          <ac:spMkLst>
+            <pc:docMk/>
+            <pc:sldMk cId="1403429394" sldId="257"/>
+            <ac:spMk id="98" creationId="{35DD87AC-C1BC-2933-33E1-AC551ED331CE}"/>
+          </ac:spMkLst>
+        </pc:spChg>
+        <pc:spChg chg="del mod">
+          <ac:chgData name="Fatima Pillosu" userId="a6295d4dc9e22643" providerId="LiveId" clId="{B5DC09CA-6CD4-43F7-8607-5135DBD6D67A}" dt="2025-07-15T02:45:05.956" v="10" actId="21"/>
+          <ac:spMkLst>
+            <pc:docMk/>
+            <pc:sldMk cId="1403429394" sldId="257"/>
+            <ac:spMk id="99" creationId="{75493878-E8E3-4B21-EDED-882FA025EE50}"/>
+          </ac:spMkLst>
+        </pc:spChg>
+        <pc:spChg chg="del mod">
+          <ac:chgData name="Fatima Pillosu" userId="a6295d4dc9e22643" providerId="LiveId" clId="{B5DC09CA-6CD4-43F7-8607-5135DBD6D67A}" dt="2025-07-15T02:45:05.956" v="10" actId="21"/>
+          <ac:spMkLst>
+            <pc:docMk/>
+            <pc:sldMk cId="1403429394" sldId="257"/>
+            <ac:spMk id="100" creationId="{000021FB-3D9A-C671-5BD8-5FD3D4F57EAF}"/>
+          </ac:spMkLst>
+        </pc:spChg>
+        <pc:spChg chg="del mod">
+          <ac:chgData name="Fatima Pillosu" userId="a6295d4dc9e22643" providerId="LiveId" clId="{B5DC09CA-6CD4-43F7-8607-5135DBD6D67A}" dt="2025-07-15T02:45:05.956" v="10" actId="21"/>
+          <ac:spMkLst>
+            <pc:docMk/>
+            <pc:sldMk cId="1403429394" sldId="257"/>
+            <ac:spMk id="101" creationId="{1D9A1454-C5EC-EF96-9456-6EFA68D93F96}"/>
+          </ac:spMkLst>
+        </pc:spChg>
+        <pc:spChg chg="del mod">
+          <ac:chgData name="Fatima Pillosu" userId="a6295d4dc9e22643" providerId="LiveId" clId="{B5DC09CA-6CD4-43F7-8607-5135DBD6D67A}" dt="2025-07-15T02:45:05.956" v="10" actId="21"/>
+          <ac:spMkLst>
+            <pc:docMk/>
+            <pc:sldMk cId="1403429394" sldId="257"/>
+            <ac:spMk id="102" creationId="{CE3B5F6B-A16B-67FA-B1F3-40AF319AD7BD}"/>
+          </ac:spMkLst>
+        </pc:spChg>
+        <pc:spChg chg="del mod">
+          <ac:chgData name="Fatima Pillosu" userId="a6295d4dc9e22643" providerId="LiveId" clId="{B5DC09CA-6CD4-43F7-8607-5135DBD6D67A}" dt="2025-07-15T02:45:05.956" v="10" actId="21"/>
+          <ac:spMkLst>
+            <pc:docMk/>
+            <pc:sldMk cId="1403429394" sldId="257"/>
+            <ac:spMk id="103" creationId="{3FF0EAA4-2EF5-4F38-B6EC-35ED6BE230C8}"/>
+          </ac:spMkLst>
+        </pc:spChg>
+        <pc:spChg chg="del mod">
+          <ac:chgData name="Fatima Pillosu" userId="a6295d4dc9e22643" providerId="LiveId" clId="{B5DC09CA-6CD4-43F7-8607-5135DBD6D67A}" dt="2025-07-15T02:45:05.956" v="10" actId="21"/>
+          <ac:spMkLst>
+            <pc:docMk/>
+            <pc:sldMk cId="1403429394" sldId="257"/>
+            <ac:spMk id="104" creationId="{9C0BF0B8-9ECF-FB3A-55AD-9010A6D0C88A}"/>
+          </ac:spMkLst>
+        </pc:spChg>
+        <pc:spChg chg="del mod">
+          <ac:chgData name="Fatima Pillosu" userId="a6295d4dc9e22643" providerId="LiveId" clId="{B5DC09CA-6CD4-43F7-8607-5135DBD6D67A}" dt="2025-07-15T02:45:05.956" v="10" actId="21"/>
+          <ac:spMkLst>
+            <pc:docMk/>
+            <pc:sldMk cId="1403429394" sldId="257"/>
+            <ac:spMk id="105" creationId="{B4F89EAC-F5BE-5AB3-6D3A-51942411D6AC}"/>
+          </ac:spMkLst>
+        </pc:spChg>
+        <pc:spChg chg="del mod">
+          <ac:chgData name="Fatima Pillosu" userId="a6295d4dc9e22643" providerId="LiveId" clId="{B5DC09CA-6CD4-43F7-8607-5135DBD6D67A}" dt="2025-07-15T02:45:05.956" v="10" actId="21"/>
+          <ac:spMkLst>
+            <pc:docMk/>
+            <pc:sldMk cId="1403429394" sldId="257"/>
+            <ac:spMk id="106" creationId="{4B314188-7F22-6C36-D5F3-C79B9823CCF9}"/>
+          </ac:spMkLst>
+        </pc:spChg>
+        <pc:spChg chg="del mod">
+          <ac:chgData name="Fatima Pillosu" userId="a6295d4dc9e22643" providerId="LiveId" clId="{B5DC09CA-6CD4-43F7-8607-5135DBD6D67A}" dt="2025-07-15T02:45:05.956" v="10" actId="21"/>
+          <ac:spMkLst>
+            <pc:docMk/>
+            <pc:sldMk cId="1403429394" sldId="257"/>
+            <ac:spMk id="107" creationId="{445A7559-4D19-A6F6-DA0F-D756F483D299}"/>
+          </ac:spMkLst>
+        </pc:spChg>
+        <pc:spChg chg="del mod">
+          <ac:chgData name="Fatima Pillosu" userId="a6295d4dc9e22643" providerId="LiveId" clId="{B5DC09CA-6CD4-43F7-8607-5135DBD6D67A}" dt="2025-07-15T02:45:05.956" v="10" actId="21"/>
+          <ac:spMkLst>
+            <pc:docMk/>
+            <pc:sldMk cId="1403429394" sldId="257"/>
+            <ac:spMk id="108" creationId="{A4EE99A9-33C7-3773-9DEA-E39F625A5212}"/>
+          </ac:spMkLst>
+        </pc:spChg>
+        <pc:spChg chg="del mod">
+          <ac:chgData name="Fatima Pillosu" userId="a6295d4dc9e22643" providerId="LiveId" clId="{B5DC09CA-6CD4-43F7-8607-5135DBD6D67A}" dt="2025-07-15T02:45:05.956" v="10" actId="21"/>
+          <ac:spMkLst>
+            <pc:docMk/>
+            <pc:sldMk cId="1403429394" sldId="257"/>
+            <ac:spMk id="109" creationId="{D8B522E8-1814-1FE6-CF46-055B320030EF}"/>
+          </ac:spMkLst>
+        </pc:spChg>
+        <pc:spChg chg="del mod">
+          <ac:chgData name="Fatima Pillosu" userId="a6295d4dc9e22643" providerId="LiveId" clId="{B5DC09CA-6CD4-43F7-8607-5135DBD6D67A}" dt="2025-07-15T02:45:05.956" v="10" actId="21"/>
+          <ac:spMkLst>
+            <pc:docMk/>
+            <pc:sldMk cId="1403429394" sldId="257"/>
+            <ac:spMk id="110" creationId="{F0474377-B166-9FE7-F0CD-757289DF5B18}"/>
+          </ac:spMkLst>
+        </pc:spChg>
+        <pc:spChg chg="del mod">
+          <ac:chgData name="Fatima Pillosu" userId="a6295d4dc9e22643" providerId="LiveId" clId="{B5DC09CA-6CD4-43F7-8607-5135DBD6D67A}" dt="2025-07-15T02:45:05.956" v="10" actId="21"/>
+          <ac:spMkLst>
+            <pc:docMk/>
+            <pc:sldMk cId="1403429394" sldId="257"/>
+            <ac:spMk id="111" creationId="{2EC17A87-5F98-30A0-B0E4-2CF025030731}"/>
+          </ac:spMkLst>
+        </pc:spChg>
+        <pc:spChg chg="del mod">
+          <ac:chgData name="Fatima Pillosu" userId="a6295d4dc9e22643" providerId="LiveId" clId="{B5DC09CA-6CD4-43F7-8607-5135DBD6D67A}" dt="2025-07-15T02:45:05.956" v="10" actId="21"/>
+          <ac:spMkLst>
+            <pc:docMk/>
+            <pc:sldMk cId="1403429394" sldId="257"/>
+            <ac:spMk id="112" creationId="{B449B9DC-BC6D-3397-ECEA-E2B1A14A2A1D}"/>
+          </ac:spMkLst>
+        </pc:spChg>
+        <pc:spChg chg="del mod">
+          <ac:chgData name="Fatima Pillosu" userId="a6295d4dc9e22643" providerId="LiveId" clId="{B5DC09CA-6CD4-43F7-8607-5135DBD6D67A}" dt="2025-07-15T02:45:05.956" v="10" actId="21"/>
+          <ac:spMkLst>
+            <pc:docMk/>
+            <pc:sldMk cId="1403429394" sldId="257"/>
+            <ac:spMk id="113" creationId="{F931034A-7D6F-8EA8-77FA-38D23B11D246}"/>
+          </ac:spMkLst>
+        </pc:spChg>
+        <pc:spChg chg="del mod">
+          <ac:chgData name="Fatima Pillosu" userId="a6295d4dc9e22643" providerId="LiveId" clId="{B5DC09CA-6CD4-43F7-8607-5135DBD6D67A}" dt="2025-07-15T02:45:05.956" v="10" actId="21"/>
+          <ac:spMkLst>
+            <pc:docMk/>
+            <pc:sldMk cId="1403429394" sldId="257"/>
+            <ac:spMk id="114" creationId="{4E92A261-3F68-2130-689A-A1282F999C88}"/>
+          </ac:spMkLst>
+        </pc:spChg>
+        <pc:spChg chg="del mod">
+          <ac:chgData name="Fatima Pillosu" userId="a6295d4dc9e22643" providerId="LiveId" clId="{B5DC09CA-6CD4-43F7-8607-5135DBD6D67A}" dt="2025-07-15T02:45:05.956" v="10" actId="21"/>
+          <ac:spMkLst>
+            <pc:docMk/>
+            <pc:sldMk cId="1403429394" sldId="257"/>
+            <ac:spMk id="115" creationId="{13B4ED1F-BA20-584D-160D-E72FD57F6E94}"/>
+          </ac:spMkLst>
+        </pc:spChg>
+        <pc:spChg chg="del mod">
+          <ac:chgData name="Fatima Pillosu" userId="a6295d4dc9e22643" providerId="LiveId" clId="{B5DC09CA-6CD4-43F7-8607-5135DBD6D67A}" dt="2025-07-15T02:45:05.956" v="10" actId="21"/>
+          <ac:spMkLst>
+            <pc:docMk/>
+            <pc:sldMk cId="1403429394" sldId="257"/>
+            <ac:spMk id="116" creationId="{9E17B2EA-5075-2F32-48F1-B8F79DC14C38}"/>
+          </ac:spMkLst>
+        </pc:spChg>
+        <pc:spChg chg="del mod">
+          <ac:chgData name="Fatima Pillosu" userId="a6295d4dc9e22643" providerId="LiveId" clId="{B5DC09CA-6CD4-43F7-8607-5135DBD6D67A}" dt="2025-07-15T02:45:05.956" v="10" actId="21"/>
+          <ac:spMkLst>
+            <pc:docMk/>
+            <pc:sldMk cId="1403429394" sldId="257"/>
+            <ac:spMk id="117" creationId="{3C88EA91-CBB6-2923-84E8-958EAB03D695}"/>
+          </ac:spMkLst>
+        </pc:spChg>
+        <pc:spChg chg="del mod">
+          <ac:chgData name="Fatima Pillosu" userId="a6295d4dc9e22643" providerId="LiveId" clId="{B5DC09CA-6CD4-43F7-8607-5135DBD6D67A}" dt="2025-07-15T02:45:05.956" v="10" actId="21"/>
+          <ac:spMkLst>
+            <pc:docMk/>
+            <pc:sldMk cId="1403429394" sldId="257"/>
+            <ac:spMk id="118" creationId="{398D0DBF-C0BF-0EAB-70D2-6FAFBE8D8584}"/>
+          </ac:spMkLst>
+        </pc:spChg>
+        <pc:spChg chg="del mod">
+          <ac:chgData name="Fatima Pillosu" userId="a6295d4dc9e22643" providerId="LiveId" clId="{B5DC09CA-6CD4-43F7-8607-5135DBD6D67A}" dt="2025-07-15T02:45:05.956" v="10" actId="21"/>
+          <ac:spMkLst>
+            <pc:docMk/>
+            <pc:sldMk cId="1403429394" sldId="257"/>
+            <ac:spMk id="119" creationId="{BB947B23-D613-6274-5A1A-0612C9DDC7BA}"/>
+          </ac:spMkLst>
+        </pc:spChg>
+        <pc:spChg chg="del mod">
+          <ac:chgData name="Fatima Pillosu" userId="a6295d4dc9e22643" providerId="LiveId" clId="{B5DC09CA-6CD4-43F7-8607-5135DBD6D67A}" dt="2025-07-15T02:45:05.956" v="10" actId="21"/>
+          <ac:spMkLst>
+            <pc:docMk/>
+            <pc:sldMk cId="1403429394" sldId="257"/>
+            <ac:spMk id="120" creationId="{5B5E25C5-CF55-1AD6-2F46-56FF2C9AA072}"/>
+          </ac:spMkLst>
+        </pc:spChg>
+        <pc:spChg chg="del mod">
+          <ac:chgData name="Fatima Pillosu" userId="a6295d4dc9e22643" providerId="LiveId" clId="{B5DC09CA-6CD4-43F7-8607-5135DBD6D67A}" dt="2025-07-15T02:45:05.956" v="10" actId="21"/>
+          <ac:spMkLst>
+            <pc:docMk/>
+            <pc:sldMk cId="1403429394" sldId="257"/>
+            <ac:spMk id="121" creationId="{89D57BAF-EDF7-DFF3-25C8-DBF5CA7C01E8}"/>
+          </ac:spMkLst>
+        </pc:spChg>
+        <pc:spChg chg="del mod">
+          <ac:chgData name="Fatima Pillosu" userId="a6295d4dc9e22643" providerId="LiveId" clId="{B5DC09CA-6CD4-43F7-8607-5135DBD6D67A}" dt="2025-07-15T02:45:05.956" v="10" actId="21"/>
+          <ac:spMkLst>
+            <pc:docMk/>
+            <pc:sldMk cId="1403429394" sldId="257"/>
+            <ac:spMk id="122" creationId="{2A0340DF-C636-D189-A28F-EA34AB5D27EE}"/>
+          </ac:spMkLst>
+        </pc:spChg>
+        <pc:spChg chg="del mod">
+          <ac:chgData name="Fatima Pillosu" userId="a6295d4dc9e22643" providerId="LiveId" clId="{B5DC09CA-6CD4-43F7-8607-5135DBD6D67A}" dt="2025-07-15T02:45:05.956" v="10" actId="21"/>
+          <ac:spMkLst>
+            <pc:docMk/>
+            <pc:sldMk cId="1403429394" sldId="257"/>
+            <ac:spMk id="123" creationId="{12F38479-AB54-6B30-2D3C-FF8C0302CC0C}"/>
+          </ac:spMkLst>
+        </pc:spChg>
+        <pc:spChg chg="del mod">
+          <ac:chgData name="Fatima Pillosu" userId="a6295d4dc9e22643" providerId="LiveId" clId="{B5DC09CA-6CD4-43F7-8607-5135DBD6D67A}" dt="2025-07-15T02:45:05.956" v="10" actId="21"/>
+          <ac:spMkLst>
+            <pc:docMk/>
+            <pc:sldMk cId="1403429394" sldId="257"/>
+            <ac:spMk id="124" creationId="{F814593F-D80C-3FAD-DC51-3489C5EF4A97}"/>
+          </ac:spMkLst>
+        </pc:spChg>
+        <pc:picChg chg="add mod">
+          <ac:chgData name="Fatima Pillosu" userId="a6295d4dc9e22643" providerId="LiveId" clId="{B5DC09CA-6CD4-43F7-8607-5135DBD6D67A}" dt="2025-07-15T02:45:25.851" v="19" actId="1036"/>
+          <ac:picMkLst>
+            <pc:docMk/>
+            <pc:sldMk cId="1403429394" sldId="257"/>
+            <ac:picMk id="4" creationId="{4188A312-931C-A96B-9DBB-485DE2DA9003}"/>
+          </ac:picMkLst>
+        </pc:picChg>
+        <pc:picChg chg="del mod">
+          <ac:chgData name="Fatima Pillosu" userId="a6295d4dc9e22643" providerId="LiveId" clId="{B5DC09CA-6CD4-43F7-8607-5135DBD6D67A}" dt="2025-07-15T02:45:05.956" v="10" actId="21"/>
+          <ac:picMkLst>
+            <pc:docMk/>
+            <pc:sldMk cId="1403429394" sldId="257"/>
+            <ac:picMk id="5" creationId="{4188A312-931C-A96B-9DBB-485DE2DA9003}"/>
+          </ac:picMkLst>
+        </pc:picChg>
+        <pc:picChg chg="add mod">
+          <ac:chgData name="Fatima Pillosu" userId="a6295d4dc9e22643" providerId="LiveId" clId="{B5DC09CA-6CD4-43F7-8607-5135DBD6D67A}" dt="2025-07-15T02:45:25.851" v="19" actId="1036"/>
+          <ac:picMkLst>
+            <pc:docMk/>
+            <pc:sldMk cId="1403429394" sldId="257"/>
+            <ac:picMk id="6" creationId="{7A99A4F9-239E-6C7F-B1CE-EE9C66D59500}"/>
+          </ac:picMkLst>
+        </pc:picChg>
+        <pc:picChg chg="del mod">
+          <ac:chgData name="Fatima Pillosu" userId="a6295d4dc9e22643" providerId="LiveId" clId="{B5DC09CA-6CD4-43F7-8607-5135DBD6D67A}" dt="2025-07-15T02:45:05.956" v="10" actId="21"/>
+          <ac:picMkLst>
+            <pc:docMk/>
+            <pc:sldMk cId="1403429394" sldId="257"/>
+            <ac:picMk id="7" creationId="{7A99A4F9-239E-6C7F-B1CE-EE9C66D59500}"/>
+          </ac:picMkLst>
+        </pc:picChg>
+        <pc:picChg chg="add mod">
+          <ac:chgData name="Fatima Pillosu" userId="a6295d4dc9e22643" providerId="LiveId" clId="{B5DC09CA-6CD4-43F7-8607-5135DBD6D67A}" dt="2025-07-15T02:45:25.851" v="19" actId="1036"/>
+          <ac:picMkLst>
+            <pc:docMk/>
+            <pc:sldMk cId="1403429394" sldId="257"/>
+            <ac:picMk id="8" creationId="{FD73FFD3-BDBE-202C-40CA-4F1E3FA747C9}"/>
+          </ac:picMkLst>
+        </pc:picChg>
+        <pc:picChg chg="del mod">
+          <ac:chgData name="Fatima Pillosu" userId="a6295d4dc9e22643" providerId="LiveId" clId="{B5DC09CA-6CD4-43F7-8607-5135DBD6D67A}" dt="2025-07-15T02:45:05.956" v="10" actId="21"/>
+          <ac:picMkLst>
+            <pc:docMk/>
+            <pc:sldMk cId="1403429394" sldId="257"/>
+            <ac:picMk id="9" creationId="{FD73FFD3-BDBE-202C-40CA-4F1E3FA747C9}"/>
+          </ac:picMkLst>
+        </pc:picChg>
+        <pc:picChg chg="add mod">
+          <ac:chgData name="Fatima Pillosu" userId="a6295d4dc9e22643" providerId="LiveId" clId="{B5DC09CA-6CD4-43F7-8607-5135DBD6D67A}" dt="2025-07-15T02:45:25.851" v="19" actId="1036"/>
+          <ac:picMkLst>
+            <pc:docMk/>
+            <pc:sldMk cId="1403429394" sldId="257"/>
+            <ac:picMk id="10" creationId="{1E8DAAC5-8433-D72E-639E-5B9BA3EDE766}"/>
+          </ac:picMkLst>
+        </pc:picChg>
+        <pc:picChg chg="del mod">
+          <ac:chgData name="Fatima Pillosu" userId="a6295d4dc9e22643" providerId="LiveId" clId="{B5DC09CA-6CD4-43F7-8607-5135DBD6D67A}" dt="2025-07-15T02:45:05.956" v="10" actId="21"/>
+          <ac:picMkLst>
+            <pc:docMk/>
+            <pc:sldMk cId="1403429394" sldId="257"/>
+            <ac:picMk id="11" creationId="{1E8DAAC5-8433-D72E-639E-5B9BA3EDE766}"/>
+          </ac:picMkLst>
+        </pc:picChg>
+        <pc:picChg chg="add mod">
+          <ac:chgData name="Fatima Pillosu" userId="a6295d4dc9e22643" providerId="LiveId" clId="{B5DC09CA-6CD4-43F7-8607-5135DBD6D67A}" dt="2025-07-15T02:45:25.851" v="19" actId="1036"/>
+          <ac:picMkLst>
+            <pc:docMk/>
+            <pc:sldMk cId="1403429394" sldId="257"/>
+            <ac:picMk id="12" creationId="{585070D7-CA3A-502D-4DA3-91F14EC700AB}"/>
+          </ac:picMkLst>
+        </pc:picChg>
+        <pc:picChg chg="del mod">
+          <ac:chgData name="Fatima Pillosu" userId="a6295d4dc9e22643" providerId="LiveId" clId="{B5DC09CA-6CD4-43F7-8607-5135DBD6D67A}" dt="2025-07-15T02:45:05.956" v="10" actId="21"/>
+          <ac:picMkLst>
+            <pc:docMk/>
+            <pc:sldMk cId="1403429394" sldId="257"/>
+            <ac:picMk id="13" creationId="{585070D7-CA3A-502D-4DA3-91F14EC700AB}"/>
+          </ac:picMkLst>
+        </pc:picChg>
+        <pc:picChg chg="add mod">
+          <ac:chgData name="Fatima Pillosu" userId="a6295d4dc9e22643" providerId="LiveId" clId="{B5DC09CA-6CD4-43F7-8607-5135DBD6D67A}" dt="2025-07-15T02:45:25.851" v="19" actId="1036"/>
+          <ac:picMkLst>
+            <pc:docMk/>
+            <pc:sldMk cId="1403429394" sldId="257"/>
+            <ac:picMk id="14" creationId="{4F9EDECB-B740-CAEE-DF03-9FF71FFF59EA}"/>
+          </ac:picMkLst>
+        </pc:picChg>
+        <pc:picChg chg="del mod">
+          <ac:chgData name="Fatima Pillosu" userId="a6295d4dc9e22643" providerId="LiveId" clId="{B5DC09CA-6CD4-43F7-8607-5135DBD6D67A}" dt="2025-07-15T02:45:05.956" v="10" actId="21"/>
+          <ac:picMkLst>
+            <pc:docMk/>
+            <pc:sldMk cId="1403429394" sldId="257"/>
+            <ac:picMk id="15" creationId="{4F9EDECB-B740-CAEE-DF03-9FF71FFF59EA}"/>
+          </ac:picMkLst>
+        </pc:picChg>
+        <pc:picChg chg="add mod">
+          <ac:chgData name="Fatima Pillosu" userId="a6295d4dc9e22643" providerId="LiveId" clId="{B5DC09CA-6CD4-43F7-8607-5135DBD6D67A}" dt="2025-07-15T02:45:25.851" v="19" actId="1036"/>
+          <ac:picMkLst>
+            <pc:docMk/>
+            <pc:sldMk cId="1403429394" sldId="257"/>
+            <ac:picMk id="16" creationId="{5A07DFD8-3E71-3163-27C2-16BEB825E58F}"/>
+          </ac:picMkLst>
+        </pc:picChg>
+        <pc:picChg chg="del mod">
+          <ac:chgData name="Fatima Pillosu" userId="a6295d4dc9e22643" providerId="LiveId" clId="{B5DC09CA-6CD4-43F7-8607-5135DBD6D67A}" dt="2025-07-15T02:45:05.956" v="10" actId="21"/>
+          <ac:picMkLst>
+            <pc:docMk/>
+            <pc:sldMk cId="1403429394" sldId="257"/>
+            <ac:picMk id="69" creationId="{5A07DFD8-3E71-3163-27C2-16BEB825E58F}"/>
+          </ac:picMkLst>
+        </pc:picChg>
+      </pc:sldChg>
+    </pc:docChg>
+  </pc:docChgLst>
   <pc:docChgLst>
     <pc:chgData name="Fatima Pillosu" userId="a6295d4dc9e22643" providerId="LiveId" clId="{9A2B42D9-F292-4BF4-BB93-D16CACD71501}"/>
     <pc:docChg chg="custSel delSld modSld">
@@ -1273,8 +2192,8 @@
         </p:nvSpPr>
         <p:spPr>
           <a:xfrm>
-            <a:off x="310515" y="836576"/>
-            <a:ext cx="3519170" cy="1779646"/>
+            <a:off x="310515" y="801243"/>
+            <a:ext cx="3519170" cy="1704481"/>
           </a:xfrm>
         </p:spPr>
         <p:txBody>
@@ -1305,8 +2224,8 @@
         </p:nvSpPr>
         <p:spPr>
           <a:xfrm>
-            <a:off x="517525" y="2684852"/>
-            <a:ext cx="3105150" cy="1234156"/>
+            <a:off x="517525" y="2571455"/>
+            <a:ext cx="3105150" cy="1182030"/>
           </a:xfrm>
         </p:spPr>
         <p:txBody>
@@ -1375,7 +2294,7 @@
           <a:p>
             <a:fld id="{ED515D41-4DB4-46CC-BF5F-4F1657FD0E85}" type="datetimeFigureOut">
               <a:rPr lang="en-GB" smtClean="0"/>
-              <a:t>10/06/2025</a:t>
+              <a:t>15/07/2025</a:t>
             </a:fld>
             <a:endParaRPr lang="en-GB"/>
           </a:p>
@@ -1426,7 +2345,7 @@
     </p:spTree>
     <p:extLst>
       <p:ext uri="{BB962C8B-B14F-4D97-AF65-F5344CB8AC3E}">
-        <p14:creationId xmlns:p14="http://schemas.microsoft.com/office/powerpoint/2010/main" val="3386014960"/>
+        <p14:creationId xmlns:p14="http://schemas.microsoft.com/office/powerpoint/2010/main" val="179113949"/>
       </p:ext>
     </p:extLst>
   </p:cSld>
@@ -1545,7 +2464,7 @@
           <a:p>
             <a:fld id="{ED515D41-4DB4-46CC-BF5F-4F1657FD0E85}" type="datetimeFigureOut">
               <a:rPr lang="en-GB" smtClean="0"/>
-              <a:t>10/06/2025</a:t>
+              <a:t>15/07/2025</a:t>
             </a:fld>
             <a:endParaRPr lang="en-GB"/>
           </a:p>
@@ -1596,7 +2515,7 @@
     </p:spTree>
     <p:extLst>
       <p:ext uri="{BB962C8B-B14F-4D97-AF65-F5344CB8AC3E}">
-        <p14:creationId xmlns:p14="http://schemas.microsoft.com/office/powerpoint/2010/main" val="2651969512"/>
+        <p14:creationId xmlns:p14="http://schemas.microsoft.com/office/powerpoint/2010/main" val="602787786"/>
       </p:ext>
     </p:extLst>
   </p:cSld>
@@ -1635,8 +2554,8 @@
         </p:nvSpPr>
         <p:spPr>
           <a:xfrm>
-            <a:off x="2962831" y="272153"/>
-            <a:ext cx="892731" cy="4331972"/>
+            <a:off x="2962831" y="260658"/>
+            <a:ext cx="892731" cy="4149007"/>
           </a:xfrm>
         </p:spPr>
         <p:txBody>
@@ -1663,8 +2582,8 @@
         </p:nvSpPr>
         <p:spPr>
           <a:xfrm>
-            <a:off x="284639" y="272153"/>
-            <a:ext cx="2626439" cy="4331972"/>
+            <a:off x="284639" y="260658"/>
+            <a:ext cx="2626439" cy="4149007"/>
           </a:xfrm>
         </p:spPr>
         <p:txBody>
@@ -1725,7 +2644,7 @@
           <a:p>
             <a:fld id="{ED515D41-4DB4-46CC-BF5F-4F1657FD0E85}" type="datetimeFigureOut">
               <a:rPr lang="en-GB" smtClean="0"/>
-              <a:t>10/06/2025</a:t>
+              <a:t>15/07/2025</a:t>
             </a:fld>
             <a:endParaRPr lang="en-GB"/>
           </a:p>
@@ -1776,7 +2695,7 @@
     </p:spTree>
     <p:extLst>
       <p:ext uri="{BB962C8B-B14F-4D97-AF65-F5344CB8AC3E}">
-        <p14:creationId xmlns:p14="http://schemas.microsoft.com/office/powerpoint/2010/main" val="2828065521"/>
+        <p14:creationId xmlns:p14="http://schemas.microsoft.com/office/powerpoint/2010/main" val="329981787"/>
       </p:ext>
     </p:extLst>
   </p:cSld>
@@ -1895,7 +2814,7 @@
           <a:p>
             <a:fld id="{ED515D41-4DB4-46CC-BF5F-4F1657FD0E85}" type="datetimeFigureOut">
               <a:rPr lang="en-GB" smtClean="0"/>
-              <a:t>10/06/2025</a:t>
+              <a:t>15/07/2025</a:t>
             </a:fld>
             <a:endParaRPr lang="en-GB"/>
           </a:p>
@@ -1946,7 +2865,7 @@
     </p:spTree>
     <p:extLst>
       <p:ext uri="{BB962C8B-B14F-4D97-AF65-F5344CB8AC3E}">
-        <p14:creationId xmlns:p14="http://schemas.microsoft.com/office/powerpoint/2010/main" val="3297617666"/>
+        <p14:creationId xmlns:p14="http://schemas.microsoft.com/office/powerpoint/2010/main" val="1746556520"/>
       </p:ext>
     </p:extLst>
   </p:cSld>
@@ -1985,8 +2904,8 @@
         </p:nvSpPr>
         <p:spPr>
           <a:xfrm>
-            <a:off x="282482" y="1274389"/>
-            <a:ext cx="3570923" cy="2126346"/>
+            <a:off x="282482" y="1220564"/>
+            <a:ext cx="3570923" cy="2036537"/>
           </a:xfrm>
         </p:spPr>
         <p:txBody>
@@ -2017,8 +2936,8 @@
         </p:nvSpPr>
         <p:spPr>
           <a:xfrm>
-            <a:off x="282482" y="3420851"/>
-            <a:ext cx="3570923" cy="1118195"/>
+            <a:off x="282482" y="3276368"/>
+            <a:ext cx="3570923" cy="1070967"/>
           </a:xfrm>
         </p:spPr>
         <p:txBody>
@@ -2141,7 +3060,7 @@
           <a:p>
             <a:fld id="{ED515D41-4DB4-46CC-BF5F-4F1657FD0E85}" type="datetimeFigureOut">
               <a:rPr lang="en-GB" smtClean="0"/>
-              <a:t>10/06/2025</a:t>
+              <a:t>15/07/2025</a:t>
             </a:fld>
             <a:endParaRPr lang="en-GB"/>
           </a:p>
@@ -2192,7 +3111,7 @@
     </p:spTree>
     <p:extLst>
       <p:ext uri="{BB962C8B-B14F-4D97-AF65-F5344CB8AC3E}">
-        <p14:creationId xmlns:p14="http://schemas.microsoft.com/office/powerpoint/2010/main" val="328789171"/>
+        <p14:creationId xmlns:p14="http://schemas.microsoft.com/office/powerpoint/2010/main" val="2893629543"/>
       </p:ext>
     </p:extLst>
   </p:cSld>
@@ -2254,8 +3173,8 @@
         </p:nvSpPr>
         <p:spPr>
           <a:xfrm>
-            <a:off x="284639" y="1360767"/>
-            <a:ext cx="1759585" cy="3243358"/>
+            <a:off x="284639" y="1303293"/>
+            <a:ext cx="1759585" cy="3106372"/>
           </a:xfrm>
         </p:spPr>
         <p:txBody>
@@ -2311,8 +3230,8 @@
         </p:nvSpPr>
         <p:spPr>
           <a:xfrm>
-            <a:off x="2095976" y="1360767"/>
-            <a:ext cx="1759585" cy="3243358"/>
+            <a:off x="2095976" y="1303293"/>
+            <a:ext cx="1759585" cy="3106372"/>
           </a:xfrm>
         </p:spPr>
         <p:txBody>
@@ -2373,7 +3292,7 @@
           <a:p>
             <a:fld id="{ED515D41-4DB4-46CC-BF5F-4F1657FD0E85}" type="datetimeFigureOut">
               <a:rPr lang="en-GB" smtClean="0"/>
-              <a:t>10/06/2025</a:t>
+              <a:t>15/07/2025</a:t>
             </a:fld>
             <a:endParaRPr lang="en-GB"/>
           </a:p>
@@ -2424,7 +3343,7 @@
     </p:spTree>
     <p:extLst>
       <p:ext uri="{BB962C8B-B14F-4D97-AF65-F5344CB8AC3E}">
-        <p14:creationId xmlns:p14="http://schemas.microsoft.com/office/powerpoint/2010/main" val="2810207307"/>
+        <p14:creationId xmlns:p14="http://schemas.microsoft.com/office/powerpoint/2010/main" val="759566540"/>
       </p:ext>
     </p:extLst>
   </p:cSld>
@@ -2463,8 +3382,8 @@
         </p:nvSpPr>
         <p:spPr>
           <a:xfrm>
-            <a:off x="285178" y="272155"/>
-            <a:ext cx="3570923" cy="988035"/>
+            <a:off x="285178" y="260660"/>
+            <a:ext cx="3570923" cy="946305"/>
           </a:xfrm>
         </p:spPr>
         <p:txBody>
@@ -2491,8 +3410,8 @@
         </p:nvSpPr>
         <p:spPr>
           <a:xfrm>
-            <a:off x="285179" y="1253089"/>
-            <a:ext cx="1751498" cy="614120"/>
+            <a:off x="285179" y="1200163"/>
+            <a:ext cx="1751498" cy="588182"/>
           </a:xfrm>
         </p:spPr>
         <p:txBody>
@@ -2556,8 +3475,8 @@
         </p:nvSpPr>
         <p:spPr>
           <a:xfrm>
-            <a:off x="285179" y="1867209"/>
-            <a:ext cx="1751498" cy="2746383"/>
+            <a:off x="285179" y="1788345"/>
+            <a:ext cx="1751498" cy="2630386"/>
           </a:xfrm>
         </p:spPr>
         <p:txBody>
@@ -2613,8 +3532,8 @@
         </p:nvSpPr>
         <p:spPr>
           <a:xfrm>
-            <a:off x="2095977" y="1253089"/>
-            <a:ext cx="1760124" cy="614120"/>
+            <a:off x="2095977" y="1200163"/>
+            <a:ext cx="1760124" cy="588182"/>
           </a:xfrm>
         </p:spPr>
         <p:txBody>
@@ -2678,8 +3597,8 @@
         </p:nvSpPr>
         <p:spPr>
           <a:xfrm>
-            <a:off x="2095977" y="1867209"/>
-            <a:ext cx="1760124" cy="2746383"/>
+            <a:off x="2095977" y="1788345"/>
+            <a:ext cx="1760124" cy="2630386"/>
           </a:xfrm>
         </p:spPr>
         <p:txBody>
@@ -2740,7 +3659,7 @@
           <a:p>
             <a:fld id="{ED515D41-4DB4-46CC-BF5F-4F1657FD0E85}" type="datetimeFigureOut">
               <a:rPr lang="en-GB" smtClean="0"/>
-              <a:t>10/06/2025</a:t>
+              <a:t>15/07/2025</a:t>
             </a:fld>
             <a:endParaRPr lang="en-GB"/>
           </a:p>
@@ -2791,7 +3710,7 @@
     </p:spTree>
     <p:extLst>
       <p:ext uri="{BB962C8B-B14F-4D97-AF65-F5344CB8AC3E}">
-        <p14:creationId xmlns:p14="http://schemas.microsoft.com/office/powerpoint/2010/main" val="3371933046"/>
+        <p14:creationId xmlns:p14="http://schemas.microsoft.com/office/powerpoint/2010/main" val="348323572"/>
       </p:ext>
     </p:extLst>
   </p:cSld>
@@ -2858,7 +3777,7 @@
           <a:p>
             <a:fld id="{ED515D41-4DB4-46CC-BF5F-4F1657FD0E85}" type="datetimeFigureOut">
               <a:rPr lang="en-GB" smtClean="0"/>
-              <a:t>10/06/2025</a:t>
+              <a:t>15/07/2025</a:t>
             </a:fld>
             <a:endParaRPr lang="en-GB"/>
           </a:p>
@@ -2909,7 +3828,7 @@
     </p:spTree>
     <p:extLst>
       <p:ext uri="{BB962C8B-B14F-4D97-AF65-F5344CB8AC3E}">
-        <p14:creationId xmlns:p14="http://schemas.microsoft.com/office/powerpoint/2010/main" val="2998434534"/>
+        <p14:creationId xmlns:p14="http://schemas.microsoft.com/office/powerpoint/2010/main" val="867170639"/>
       </p:ext>
     </p:extLst>
   </p:cSld>
@@ -2953,7 +3872,7 @@
           <a:p>
             <a:fld id="{ED515D41-4DB4-46CC-BF5F-4F1657FD0E85}" type="datetimeFigureOut">
               <a:rPr lang="en-GB" smtClean="0"/>
-              <a:t>10/06/2025</a:t>
+              <a:t>15/07/2025</a:t>
             </a:fld>
             <a:endParaRPr lang="en-GB"/>
           </a:p>
@@ -3004,7 +3923,7 @@
     </p:spTree>
     <p:extLst>
       <p:ext uri="{BB962C8B-B14F-4D97-AF65-F5344CB8AC3E}">
-        <p14:creationId xmlns:p14="http://schemas.microsoft.com/office/powerpoint/2010/main" val="2078448715"/>
+        <p14:creationId xmlns:p14="http://schemas.microsoft.com/office/powerpoint/2010/main" val="2941762648"/>
       </p:ext>
     </p:extLst>
   </p:cSld>
@@ -3043,8 +3962,8 @@
         </p:nvSpPr>
         <p:spPr>
           <a:xfrm>
-            <a:off x="285178" y="340783"/>
-            <a:ext cx="1335322" cy="1192742"/>
+            <a:off x="285178" y="326390"/>
+            <a:ext cx="1335322" cy="1142365"/>
           </a:xfrm>
         </p:spPr>
         <p:txBody>
@@ -3075,8 +3994,8 @@
         </p:nvSpPr>
         <p:spPr>
           <a:xfrm>
-            <a:off x="1760124" y="735998"/>
-            <a:ext cx="2095976" cy="3632656"/>
+            <a:off x="1760124" y="704913"/>
+            <a:ext cx="2095976" cy="3479227"/>
           </a:xfrm>
         </p:spPr>
         <p:txBody>
@@ -3160,8 +4079,8 @@
         </p:nvSpPr>
         <p:spPr>
           <a:xfrm>
-            <a:off x="285178" y="1533525"/>
-            <a:ext cx="1335322" cy="2841045"/>
+            <a:off x="285178" y="1468755"/>
+            <a:ext cx="1335322" cy="2721050"/>
           </a:xfrm>
         </p:spPr>
         <p:txBody>
@@ -3230,7 +4149,7 @@
           <a:p>
             <a:fld id="{ED515D41-4DB4-46CC-BF5F-4F1657FD0E85}" type="datetimeFigureOut">
               <a:rPr lang="en-GB" smtClean="0"/>
-              <a:t>10/06/2025</a:t>
+              <a:t>15/07/2025</a:t>
             </a:fld>
             <a:endParaRPr lang="en-GB"/>
           </a:p>
@@ -3281,7 +4200,7 @@
     </p:spTree>
     <p:extLst>
       <p:ext uri="{BB962C8B-B14F-4D97-AF65-F5344CB8AC3E}">
-        <p14:creationId xmlns:p14="http://schemas.microsoft.com/office/powerpoint/2010/main" val="3218002362"/>
+        <p14:creationId xmlns:p14="http://schemas.microsoft.com/office/powerpoint/2010/main" val="3387973187"/>
       </p:ext>
     </p:extLst>
   </p:cSld>
@@ -3320,8 +4239,8 @@
         </p:nvSpPr>
         <p:spPr>
           <a:xfrm>
-            <a:off x="285178" y="340783"/>
-            <a:ext cx="1335322" cy="1192742"/>
+            <a:off x="285178" y="326390"/>
+            <a:ext cx="1335322" cy="1142365"/>
           </a:xfrm>
         </p:spPr>
         <p:txBody>
@@ -3352,8 +4271,8 @@
         </p:nvSpPr>
         <p:spPr>
           <a:xfrm>
-            <a:off x="1760124" y="735998"/>
-            <a:ext cx="2095976" cy="3632656"/>
+            <a:off x="1760124" y="704913"/>
+            <a:ext cx="2095976" cy="3479227"/>
           </a:xfrm>
         </p:spPr>
         <p:txBody>
@@ -3417,8 +4336,8 @@
         </p:nvSpPr>
         <p:spPr>
           <a:xfrm>
-            <a:off x="285178" y="1533525"/>
-            <a:ext cx="1335322" cy="2841045"/>
+            <a:off x="285178" y="1468755"/>
+            <a:ext cx="1335322" cy="2721050"/>
           </a:xfrm>
         </p:spPr>
         <p:txBody>
@@ -3487,7 +4406,7 @@
           <a:p>
             <a:fld id="{ED515D41-4DB4-46CC-BF5F-4F1657FD0E85}" type="datetimeFigureOut">
               <a:rPr lang="en-GB" smtClean="0"/>
-              <a:t>10/06/2025</a:t>
+              <a:t>15/07/2025</a:t>
             </a:fld>
             <a:endParaRPr lang="en-GB"/>
           </a:p>
@@ -3538,7 +4457,7 @@
     </p:spTree>
     <p:extLst>
       <p:ext uri="{BB962C8B-B14F-4D97-AF65-F5344CB8AC3E}">
-        <p14:creationId xmlns:p14="http://schemas.microsoft.com/office/powerpoint/2010/main" val="318831292"/>
+        <p14:creationId xmlns:p14="http://schemas.microsoft.com/office/powerpoint/2010/main" val="3216933036"/>
       </p:ext>
     </p:extLst>
   </p:cSld>
@@ -3582,8 +4501,8 @@
         </p:nvSpPr>
         <p:spPr>
           <a:xfrm>
-            <a:off x="284639" y="272155"/>
-            <a:ext cx="3570923" cy="988035"/>
+            <a:off x="284639" y="260660"/>
+            <a:ext cx="3570923" cy="946305"/>
           </a:xfrm>
           <a:prstGeom prst="rect">
             <a:avLst/>
@@ -3615,8 +4534,8 @@
         </p:nvSpPr>
         <p:spPr>
           <a:xfrm>
-            <a:off x="284639" y="1360767"/>
-            <a:ext cx="3570923" cy="3243358"/>
+            <a:off x="284639" y="1303293"/>
+            <a:ext cx="3570923" cy="3106372"/>
           </a:xfrm>
           <a:prstGeom prst="rect">
             <a:avLst/>
@@ -3677,8 +4596,8 @@
         </p:nvSpPr>
         <p:spPr>
           <a:xfrm>
-            <a:off x="284639" y="4737836"/>
-            <a:ext cx="931545" cy="272153"/>
+            <a:off x="284639" y="4537729"/>
+            <a:ext cx="931545" cy="260659"/>
           </a:xfrm>
           <a:prstGeom prst="rect">
             <a:avLst/>
@@ -3700,7 +4619,7 @@
           <a:p>
             <a:fld id="{ED515D41-4DB4-46CC-BF5F-4F1657FD0E85}" type="datetimeFigureOut">
               <a:rPr lang="en-GB" smtClean="0"/>
-              <a:t>10/06/2025</a:t>
+              <a:t>15/07/2025</a:t>
             </a:fld>
             <a:endParaRPr lang="en-GB"/>
           </a:p>
@@ -3718,8 +4637,8 @@
         </p:nvSpPr>
         <p:spPr>
           <a:xfrm>
-            <a:off x="1371441" y="4737836"/>
-            <a:ext cx="1397318" cy="272153"/>
+            <a:off x="1371441" y="4537729"/>
+            <a:ext cx="1397318" cy="260659"/>
           </a:xfrm>
           <a:prstGeom prst="rect">
             <a:avLst/>
@@ -3755,8 +4674,8 @@
         </p:nvSpPr>
         <p:spPr>
           <a:xfrm>
-            <a:off x="2924016" y="4737836"/>
-            <a:ext cx="931545" cy="272153"/>
+            <a:off x="2924016" y="4537729"/>
+            <a:ext cx="931545" cy="260659"/>
           </a:xfrm>
           <a:prstGeom prst="rect">
             <a:avLst/>
@@ -3787,23 +4706,23 @@
     </p:spTree>
     <p:extLst>
       <p:ext uri="{BB962C8B-B14F-4D97-AF65-F5344CB8AC3E}">
-        <p14:creationId xmlns:p14="http://schemas.microsoft.com/office/powerpoint/2010/main" val="560362717"/>
+        <p14:creationId xmlns:p14="http://schemas.microsoft.com/office/powerpoint/2010/main" val="2124076014"/>
       </p:ext>
     </p:extLst>
   </p:cSld>
   <p:clrMap bg1="lt1" tx1="dk1" bg2="lt2" tx2="dk2" accent1="accent1" accent2="accent2" accent3="accent3" accent4="accent4" accent5="accent5" accent6="accent6" hlink="hlink" folHlink="folHlink"/>
   <p:sldLayoutIdLst>
-    <p:sldLayoutId id="2147483673" r:id="rId1"/>
-    <p:sldLayoutId id="2147483674" r:id="rId2"/>
-    <p:sldLayoutId id="2147483675" r:id="rId3"/>
-    <p:sldLayoutId id="2147483676" r:id="rId4"/>
-    <p:sldLayoutId id="2147483677" r:id="rId5"/>
-    <p:sldLayoutId id="2147483678" r:id="rId6"/>
-    <p:sldLayoutId id="2147483679" r:id="rId7"/>
-    <p:sldLayoutId id="2147483680" r:id="rId8"/>
-    <p:sldLayoutId id="2147483681" r:id="rId9"/>
-    <p:sldLayoutId id="2147483682" r:id="rId10"/>
-    <p:sldLayoutId id="2147483683" r:id="rId11"/>
+    <p:sldLayoutId id="2147483685" r:id="rId1"/>
+    <p:sldLayoutId id="2147483686" r:id="rId2"/>
+    <p:sldLayoutId id="2147483687" r:id="rId3"/>
+    <p:sldLayoutId id="2147483688" r:id="rId4"/>
+    <p:sldLayoutId id="2147483689" r:id="rId5"/>
+    <p:sldLayoutId id="2147483690" r:id="rId6"/>
+    <p:sldLayoutId id="2147483691" r:id="rId7"/>
+    <p:sldLayoutId id="2147483692" r:id="rId8"/>
+    <p:sldLayoutId id="2147483693" r:id="rId9"/>
+    <p:sldLayoutId id="2147483694" r:id="rId10"/>
+    <p:sldLayoutId id="2147483695" r:id="rId11"/>
   </p:sldLayoutIdLst>
   <p:txStyles>
     <p:titleStyle>
@@ -4107,7 +5026,7 @@
       </p:grpSpPr>
       <p:pic>
         <p:nvPicPr>
-          <p:cNvPr id="5" name="Picture 4" descr="A map of the united states&#10;&#10;AI-generated content may be incorrect.">
+          <p:cNvPr id="4" name="Picture 3" descr="A map of the united states&#10;&#10;AI-generated content may be incorrect.">
             <a:extLst>
               <a:ext uri="{FF2B5EF4-FFF2-40B4-BE49-F238E27FC236}">
                 <a16:creationId xmlns:a16="http://schemas.microsoft.com/office/drawing/2014/main" id="{4188A312-931C-A96B-9DBB-485DE2DA9003}"/>
@@ -4132,7 +5051,7 @@
         </p:blipFill>
         <p:spPr>
           <a:xfrm>
-            <a:off x="258935" y="1293226"/>
+            <a:off x="260361" y="1082805"/>
             <a:ext cx="1918800" cy="1062612"/>
           </a:xfrm>
           <a:prstGeom prst="rect">
@@ -4142,7 +5061,7 @@
       </p:pic>
       <p:pic>
         <p:nvPicPr>
-          <p:cNvPr id="7" name="Picture 6" descr="A map of the united states&#10;&#10;AI-generated content may be incorrect.">
+          <p:cNvPr id="6" name="Picture 5" descr="A map of the united states&#10;&#10;AI-generated content may be incorrect.">
             <a:extLst>
               <a:ext uri="{FF2B5EF4-FFF2-40B4-BE49-F238E27FC236}">
                 <a16:creationId xmlns:a16="http://schemas.microsoft.com/office/drawing/2014/main" id="{7A99A4F9-239E-6C7F-B1CE-EE9C66D59500}"/>
@@ -4167,7 +5086,7 @@
         </p:blipFill>
         <p:spPr>
           <a:xfrm>
-            <a:off x="2204606" y="1293226"/>
+            <a:off x="2206032" y="1082805"/>
             <a:ext cx="1918800" cy="1062612"/>
           </a:xfrm>
           <a:prstGeom prst="rect">
@@ -4177,7 +5096,7 @@
       </p:pic>
       <p:pic>
         <p:nvPicPr>
-          <p:cNvPr id="9" name="Picture 8" descr="A map of the united states&#10;&#10;AI-generated content may be incorrect.">
+          <p:cNvPr id="8" name="Picture 7" descr="A map of the united states&#10;&#10;AI-generated content may be incorrect.">
             <a:extLst>
               <a:ext uri="{FF2B5EF4-FFF2-40B4-BE49-F238E27FC236}">
                 <a16:creationId xmlns:a16="http://schemas.microsoft.com/office/drawing/2014/main" id="{FD73FFD3-BDBE-202C-40CA-4F1E3FA747C9}"/>
@@ -4202,7 +5121,7 @@
         </p:blipFill>
         <p:spPr>
           <a:xfrm>
-            <a:off x="258935" y="2595493"/>
+            <a:off x="260361" y="2385072"/>
             <a:ext cx="1918800" cy="1062612"/>
           </a:xfrm>
           <a:prstGeom prst="rect">
@@ -4212,7 +5131,7 @@
       </p:pic>
       <p:pic>
         <p:nvPicPr>
-          <p:cNvPr id="11" name="Picture 10" descr="A map of the united states&#10;&#10;AI-generated content may be incorrect.">
+          <p:cNvPr id="10" name="Picture 9" descr="A map of the united states&#10;&#10;AI-generated content may be incorrect.">
             <a:extLst>
               <a:ext uri="{FF2B5EF4-FFF2-40B4-BE49-F238E27FC236}">
                 <a16:creationId xmlns:a16="http://schemas.microsoft.com/office/drawing/2014/main" id="{1E8DAAC5-8433-D72E-639E-5B9BA3EDE766}"/>
@@ -4237,7 +5156,7 @@
         </p:blipFill>
         <p:spPr>
           <a:xfrm>
-            <a:off x="2204606" y="2595493"/>
+            <a:off x="2206032" y="2385072"/>
             <a:ext cx="1918800" cy="1063870"/>
           </a:xfrm>
           <a:prstGeom prst="rect">
@@ -4247,7 +5166,7 @@
       </p:pic>
       <p:pic>
         <p:nvPicPr>
-          <p:cNvPr id="13" name="Picture 12" descr="A map of the united states&#10;&#10;AI-generated content may be incorrect.">
+          <p:cNvPr id="12" name="Picture 11" descr="A map of the united states&#10;&#10;AI-generated content may be incorrect.">
             <a:extLst>
               <a:ext uri="{FF2B5EF4-FFF2-40B4-BE49-F238E27FC236}">
                 <a16:creationId xmlns:a16="http://schemas.microsoft.com/office/drawing/2014/main" id="{585070D7-CA3A-502D-4DA3-91F14EC700AB}"/>
@@ -4272,7 +5191,7 @@
         </p:blipFill>
         <p:spPr>
           <a:xfrm>
-            <a:off x="258935" y="3902552"/>
+            <a:off x="260361" y="3692131"/>
             <a:ext cx="1918800" cy="1066396"/>
           </a:xfrm>
           <a:prstGeom prst="rect">
@@ -4282,7 +5201,7 @@
       </p:pic>
       <p:pic>
         <p:nvPicPr>
-          <p:cNvPr id="15" name="Picture 14" descr="A map of the united states&#10;&#10;AI-generated content may be incorrect.">
+          <p:cNvPr id="14" name="Picture 13" descr="A map of the united states&#10;&#10;AI-generated content may be incorrect.">
             <a:extLst>
               <a:ext uri="{FF2B5EF4-FFF2-40B4-BE49-F238E27FC236}">
                 <a16:creationId xmlns:a16="http://schemas.microsoft.com/office/drawing/2014/main" id="{4F9EDECB-B740-CAEE-DF03-9FF71FFF59EA}"/>
@@ -4307,7 +5226,7 @@
         </p:blipFill>
         <p:spPr>
           <a:xfrm>
-            <a:off x="2204606" y="3902552"/>
+            <a:off x="2206032" y="3692131"/>
             <a:ext cx="1918800" cy="1066396"/>
           </a:xfrm>
           <a:prstGeom prst="rect">
@@ -4317,7 +5236,7 @@
       </p:pic>
       <p:pic>
         <p:nvPicPr>
-          <p:cNvPr id="69" name="Picture 68" descr="A map of the united states&#10;&#10;AI-generated content may be incorrect.">
+          <p:cNvPr id="16" name="Picture 15" descr="A map of the united states&#10;&#10;AI-generated content may be incorrect.">
             <a:extLst>
               <a:ext uri="{FF2B5EF4-FFF2-40B4-BE49-F238E27FC236}">
                 <a16:creationId xmlns:a16="http://schemas.microsoft.com/office/drawing/2014/main" id="{5A07DFD8-3E71-3163-27C2-16BEB825E58F}"/>
@@ -4336,7 +5255,7 @@
         </p:blipFill>
         <p:spPr>
           <a:xfrm>
-            <a:off x="72838" y="930871"/>
+            <a:off x="74264" y="720450"/>
             <a:ext cx="3937373" cy="113213"/>
           </a:xfrm>
           <a:prstGeom prst="rect">
@@ -4346,7 +5265,7 @@
       </p:pic>
       <p:sp>
         <p:nvSpPr>
-          <p:cNvPr id="76" name="TextBox 228">
+          <p:cNvPr id="17" name="TextBox 228">
             <a:extLst>
               <a:ext uri="{FF2B5EF4-FFF2-40B4-BE49-F238E27FC236}">
                 <a16:creationId xmlns:a16="http://schemas.microsoft.com/office/drawing/2014/main" id="{082CB828-3055-C01D-1D9B-34D32699459C}"/>
@@ -4358,7 +5277,7 @@
         </p:nvSpPr>
         <p:spPr>
           <a:xfrm rot="18900000">
-            <a:off x="2368168" y="717566"/>
+            <a:off x="2369594" y="507145"/>
             <a:ext cx="363600" cy="215444"/>
           </a:xfrm>
           <a:prstGeom prst="rect">
@@ -4403,7 +5322,7 @@
       </p:sp>
       <p:sp>
         <p:nvSpPr>
-          <p:cNvPr id="77" name="TextBox 229">
+          <p:cNvPr id="18" name="TextBox 229">
             <a:extLst>
               <a:ext uri="{FF2B5EF4-FFF2-40B4-BE49-F238E27FC236}">
                 <a16:creationId xmlns:a16="http://schemas.microsoft.com/office/drawing/2014/main" id="{26462B98-3F43-7391-382E-5FA37001F70A}"/>
@@ -4415,7 +5334,7 @@
         </p:nvSpPr>
         <p:spPr>
           <a:xfrm rot="18900000">
-            <a:off x="1995342" y="717566"/>
+            <a:off x="1996768" y="507145"/>
             <a:ext cx="363600" cy="215444"/>
           </a:xfrm>
           <a:prstGeom prst="rect">
@@ -4447,7 +5366,7 @@
       </p:sp>
       <p:sp>
         <p:nvSpPr>
-          <p:cNvPr id="78" name="TextBox 230">
+          <p:cNvPr id="19" name="TextBox 230">
             <a:extLst>
               <a:ext uri="{FF2B5EF4-FFF2-40B4-BE49-F238E27FC236}">
                 <a16:creationId xmlns:a16="http://schemas.microsoft.com/office/drawing/2014/main" id="{FB1D83BF-C5B8-0F42-ACF1-801724C77646}"/>
@@ -4459,7 +5378,7 @@
         </p:nvSpPr>
         <p:spPr>
           <a:xfrm rot="18900000">
-            <a:off x="1622516" y="717566"/>
+            <a:off x="1623942" y="507145"/>
             <a:ext cx="363600" cy="215444"/>
           </a:xfrm>
           <a:prstGeom prst="rect">
@@ -4491,7 +5410,7 @@
       </p:sp>
       <p:sp>
         <p:nvSpPr>
-          <p:cNvPr id="79" name="TextBox 231">
+          <p:cNvPr id="20" name="TextBox 231">
             <a:extLst>
               <a:ext uri="{FF2B5EF4-FFF2-40B4-BE49-F238E27FC236}">
                 <a16:creationId xmlns:a16="http://schemas.microsoft.com/office/drawing/2014/main" id="{EFB51189-ED1C-9467-A21E-04098224201A}"/>
@@ -4503,7 +5422,7 @@
         </p:nvSpPr>
         <p:spPr>
           <a:xfrm rot="18900000">
-            <a:off x="690451" y="717566"/>
+            <a:off x="691877" y="507145"/>
             <a:ext cx="363600" cy="215444"/>
           </a:xfrm>
           <a:prstGeom prst="rect">
@@ -4535,7 +5454,7 @@
       </p:sp>
       <p:sp>
         <p:nvSpPr>
-          <p:cNvPr id="80" name="TextBox 232">
+          <p:cNvPr id="21" name="TextBox 232">
             <a:extLst>
               <a:ext uri="{FF2B5EF4-FFF2-40B4-BE49-F238E27FC236}">
                 <a16:creationId xmlns:a16="http://schemas.microsoft.com/office/drawing/2014/main" id="{21C332B9-C99D-6C2F-F7A7-D75A6499E176}"/>
@@ -4547,7 +5466,7 @@
         </p:nvSpPr>
         <p:spPr>
           <a:xfrm rot="18900000">
-            <a:off x="317625" y="717566"/>
+            <a:off x="319051" y="507145"/>
             <a:ext cx="363600" cy="215444"/>
           </a:xfrm>
           <a:prstGeom prst="rect">
@@ -4579,7 +5498,7 @@
       </p:sp>
       <p:sp>
         <p:nvSpPr>
-          <p:cNvPr id="81" name="TextBox 233">
+          <p:cNvPr id="22" name="TextBox 233">
             <a:extLst>
               <a:ext uri="{FF2B5EF4-FFF2-40B4-BE49-F238E27FC236}">
                 <a16:creationId xmlns:a16="http://schemas.microsoft.com/office/drawing/2014/main" id="{88809429-C163-FEA9-654A-C938A20C2ED1}"/>
@@ -4591,7 +5510,7 @@
         </p:nvSpPr>
         <p:spPr>
           <a:xfrm rot="18900000">
-            <a:off x="-55201" y="717566"/>
+            <a:off x="-53775" y="507145"/>
             <a:ext cx="363600" cy="215444"/>
           </a:xfrm>
           <a:prstGeom prst="rect">
@@ -4623,7 +5542,7 @@
       </p:sp>
       <p:sp>
         <p:nvSpPr>
-          <p:cNvPr id="82" name="TextBox 251">
+          <p:cNvPr id="23" name="TextBox 251">
             <a:extLst>
               <a:ext uri="{FF2B5EF4-FFF2-40B4-BE49-F238E27FC236}">
                 <a16:creationId xmlns:a16="http://schemas.microsoft.com/office/drawing/2014/main" id="{64A6DF9F-4002-0BE8-0275-A7A7B18AE50E}"/>
@@ -4635,7 +5554,7 @@
         </p:nvSpPr>
         <p:spPr>
           <a:xfrm>
-            <a:off x="-203709" y="1280198"/>
+            <a:off x="-202283" y="1069777"/>
             <a:ext cx="536815" cy="215444"/>
           </a:xfrm>
           <a:prstGeom prst="rect">
@@ -4685,7 +5604,7 @@
       </p:sp>
       <p:sp>
         <p:nvSpPr>
-          <p:cNvPr id="83" name="TextBox 252">
+          <p:cNvPr id="24" name="TextBox 252">
             <a:extLst>
               <a:ext uri="{FF2B5EF4-FFF2-40B4-BE49-F238E27FC236}">
                 <a16:creationId xmlns:a16="http://schemas.microsoft.com/office/drawing/2014/main" id="{FBF4F939-D8E0-4CA6-4395-BE2703ED47D3}"/>
@@ -4697,7 +5616,7 @@
         </p:nvSpPr>
         <p:spPr>
           <a:xfrm>
-            <a:off x="-203709" y="1670511"/>
+            <a:off x="-202283" y="1460090"/>
             <a:ext cx="536815" cy="215444"/>
           </a:xfrm>
           <a:prstGeom prst="rect">
@@ -4747,7 +5666,7 @@
       </p:sp>
       <p:sp>
         <p:nvSpPr>
-          <p:cNvPr id="84" name="TextBox 253">
+          <p:cNvPr id="25" name="TextBox 253">
             <a:extLst>
               <a:ext uri="{FF2B5EF4-FFF2-40B4-BE49-F238E27FC236}">
                 <a16:creationId xmlns:a16="http://schemas.microsoft.com/office/drawing/2014/main" id="{9886A46A-5F0E-29C0-5553-F3C415C39030}"/>
@@ -4759,7 +5678,7 @@
         </p:nvSpPr>
         <p:spPr>
           <a:xfrm>
-            <a:off x="-203709" y="1997861"/>
+            <a:off x="-202283" y="1787440"/>
             <a:ext cx="536815" cy="215444"/>
           </a:xfrm>
           <a:prstGeom prst="rect">
@@ -4809,7 +5728,7 @@
       </p:sp>
       <p:sp>
         <p:nvSpPr>
-          <p:cNvPr id="85" name="TextBox 254">
+          <p:cNvPr id="26" name="TextBox 254">
             <a:extLst>
               <a:ext uri="{FF2B5EF4-FFF2-40B4-BE49-F238E27FC236}">
                 <a16:creationId xmlns:a16="http://schemas.microsoft.com/office/drawing/2014/main" id="{DD731501-A656-7957-75AF-86B51CC75396}"/>
@@ -4821,7 +5740,7 @@
         </p:nvSpPr>
         <p:spPr>
           <a:xfrm>
-            <a:off x="268615" y="4913976"/>
+            <a:off x="270041" y="4703555"/>
             <a:ext cx="536815" cy="215444"/>
           </a:xfrm>
           <a:prstGeom prst="rect">
@@ -4871,7 +5790,7 @@
       </p:sp>
       <p:sp>
         <p:nvSpPr>
-          <p:cNvPr id="86" name="TextBox 255">
+          <p:cNvPr id="27" name="TextBox 255">
             <a:extLst>
               <a:ext uri="{FF2B5EF4-FFF2-40B4-BE49-F238E27FC236}">
                 <a16:creationId xmlns:a16="http://schemas.microsoft.com/office/drawing/2014/main" id="{DE08B4AE-3720-60F1-D6B9-743C32AD6707}"/>
@@ -4883,7 +5802,7 @@
         </p:nvSpPr>
         <p:spPr>
           <a:xfrm>
-            <a:off x="814617" y="4913976"/>
+            <a:off x="816043" y="4703555"/>
             <a:ext cx="536815" cy="215444"/>
           </a:xfrm>
           <a:prstGeom prst="rect">
@@ -4933,7 +5852,7 @@
       </p:sp>
       <p:sp>
         <p:nvSpPr>
-          <p:cNvPr id="87" name="TextBox 256">
+          <p:cNvPr id="28" name="TextBox 256">
             <a:extLst>
               <a:ext uri="{FF2B5EF4-FFF2-40B4-BE49-F238E27FC236}">
                 <a16:creationId xmlns:a16="http://schemas.microsoft.com/office/drawing/2014/main" id="{9C4F17D1-D949-02CB-0B46-48106B0B393C}"/>
@@ -4945,7 +5864,7 @@
         </p:nvSpPr>
         <p:spPr>
           <a:xfrm>
-            <a:off x="1355276" y="4913976"/>
+            <a:off x="1356702" y="4703555"/>
             <a:ext cx="536815" cy="215444"/>
           </a:xfrm>
           <a:prstGeom prst="rect">
@@ -4995,7 +5914,7 @@
       </p:sp>
       <p:sp>
         <p:nvSpPr>
-          <p:cNvPr id="88" name="TextBox 260">
+          <p:cNvPr id="29" name="TextBox 260">
             <a:extLst>
               <a:ext uri="{FF2B5EF4-FFF2-40B4-BE49-F238E27FC236}">
                 <a16:creationId xmlns:a16="http://schemas.microsoft.com/office/drawing/2014/main" id="{455A54B8-5CD9-B620-BC08-5F6DA9DF0ED8}"/>
@@ -5007,7 +5926,7 @@
         </p:nvSpPr>
         <p:spPr>
           <a:xfrm rot="18900000">
-            <a:off x="131212" y="717566"/>
+            <a:off x="132638" y="507145"/>
             <a:ext cx="363600" cy="215444"/>
           </a:xfrm>
           <a:prstGeom prst="rect">
@@ -5039,7 +5958,7 @@
       </p:sp>
       <p:sp>
         <p:nvSpPr>
-          <p:cNvPr id="89" name="TextBox 261">
+          <p:cNvPr id="30" name="TextBox 261">
             <a:extLst>
               <a:ext uri="{FF2B5EF4-FFF2-40B4-BE49-F238E27FC236}">
                 <a16:creationId xmlns:a16="http://schemas.microsoft.com/office/drawing/2014/main" id="{55890E00-81A3-E28D-C052-5E4FA9603339}"/>
@@ -5051,7 +5970,7 @@
         </p:nvSpPr>
         <p:spPr>
           <a:xfrm rot="18900000">
-            <a:off x="504038" y="717566"/>
+            <a:off x="505464" y="507145"/>
             <a:ext cx="363600" cy="215444"/>
           </a:xfrm>
           <a:prstGeom prst="rect">
@@ -5083,7 +6002,7 @@
       </p:sp>
       <p:sp>
         <p:nvSpPr>
-          <p:cNvPr id="90" name="TextBox 262">
+          <p:cNvPr id="31" name="TextBox 262">
             <a:extLst>
               <a:ext uri="{FF2B5EF4-FFF2-40B4-BE49-F238E27FC236}">
                 <a16:creationId xmlns:a16="http://schemas.microsoft.com/office/drawing/2014/main" id="{D22BC35C-D8BA-9C47-5E36-D7A2E39E7940}"/>
@@ -5095,7 +6014,7 @@
         </p:nvSpPr>
         <p:spPr>
           <a:xfrm rot="18900000">
-            <a:off x="876864" y="717566"/>
+            <a:off x="878290" y="507145"/>
             <a:ext cx="363600" cy="215444"/>
           </a:xfrm>
           <a:prstGeom prst="rect">
@@ -5127,7 +6046,7 @@
       </p:sp>
       <p:sp>
         <p:nvSpPr>
-          <p:cNvPr id="91" name="TextBox 263">
+          <p:cNvPr id="32" name="TextBox 263">
             <a:extLst>
               <a:ext uri="{FF2B5EF4-FFF2-40B4-BE49-F238E27FC236}">
                 <a16:creationId xmlns:a16="http://schemas.microsoft.com/office/drawing/2014/main" id="{2847A4E1-5D8A-BA47-5F8F-485D455DD114}"/>
@@ -5139,7 +6058,7 @@
         </p:nvSpPr>
         <p:spPr>
           <a:xfrm rot="18900000">
-            <a:off x="1808929" y="717566"/>
+            <a:off x="1810355" y="507145"/>
             <a:ext cx="363600" cy="215444"/>
           </a:xfrm>
           <a:prstGeom prst="rect">
@@ -5171,7 +6090,7 @@
       </p:sp>
       <p:sp>
         <p:nvSpPr>
-          <p:cNvPr id="92" name="TextBox 264">
+          <p:cNvPr id="33" name="TextBox 264">
             <a:extLst>
               <a:ext uri="{FF2B5EF4-FFF2-40B4-BE49-F238E27FC236}">
                 <a16:creationId xmlns:a16="http://schemas.microsoft.com/office/drawing/2014/main" id="{9A16AC1B-8EF3-92A4-CABD-D73AD244F75E}"/>
@@ -5183,7 +6102,7 @@
         </p:nvSpPr>
         <p:spPr>
           <a:xfrm rot="18900000">
-            <a:off x="2181755" y="717566"/>
+            <a:off x="2183181" y="507145"/>
             <a:ext cx="363600" cy="215444"/>
           </a:xfrm>
           <a:prstGeom prst="rect">
@@ -5215,7 +6134,7 @@
       </p:sp>
       <p:sp>
         <p:nvSpPr>
-          <p:cNvPr id="93" name="TextBox 92">
+          <p:cNvPr id="34" name="TextBox 33">
             <a:extLst>
               <a:ext uri="{FF2B5EF4-FFF2-40B4-BE49-F238E27FC236}">
                 <a16:creationId xmlns:a16="http://schemas.microsoft.com/office/drawing/2014/main" id="{15B66109-5EC0-175E-124D-C46996895CE7}"/>
@@ -5228,7 +6147,7 @@
         <p:spPr>
           <a:xfrm>
             <a:off x="-83151" y="-46338"/>
-            <a:ext cx="4042376" cy="584775"/>
+            <a:ext cx="4042376" cy="369332"/>
           </a:xfrm>
           <a:prstGeom prst="rect">
             <a:avLst/>
@@ -5242,75 +6161,33 @@
           <a:lstStyle/>
           <a:p>
             <a:r>
-              <a:rPr lang="en-US" sz="1200" b="1" dirty="0">
+              <a:rPr lang="en-US" sz="1000" b="1" dirty="0">
                 <a:solidFill>
                   <a:srgbClr val="333333"/>
                 </a:solidFill>
                 <a:latin typeface="Calibri" panose="020F0502020204030204" pitchFamily="34" charset="0"/>
                 <a:cs typeface="Calibri" panose="020F0502020204030204" pitchFamily="34" charset="0"/>
               </a:rPr>
-              <a:t>Feature variables for data-driven model </a:t>
-            </a:r>
-          </a:p>
-          <a:p>
-            <a:r>
-              <a:rPr lang="en-US" sz="1000" u="sng" dirty="0">
+              <a:t>Probability of rainfall exceeding the 1-year return period (ERA5-ecPoint) </a:t>
+            </a:r>
+          </a:p>
+          <a:p>
+            <a:r>
+              <a:rPr lang="en-US" sz="800" dirty="0">
                 <a:solidFill>
                   <a:srgbClr val="333333"/>
                 </a:solidFill>
                 <a:latin typeface="Calibri Light" panose="020F0302020204030204" pitchFamily="34" charset="0"/>
                 <a:cs typeface="Calibri Light" panose="020F0302020204030204" pitchFamily="34" charset="0"/>
               </a:rPr>
-              <a:t>Probability of rainfall exceeding the 50-year return period</a:t>
-            </a:r>
-            <a:r>
-              <a:rPr lang="en-US" sz="1000" dirty="0">
-                <a:solidFill>
-                  <a:srgbClr val="333333"/>
-                </a:solidFill>
-                <a:latin typeface="Calibri Light" panose="020F0302020204030204" pitchFamily="34" charset="0"/>
-                <a:cs typeface="Calibri Light" panose="020F0302020204030204" pitchFamily="34" charset="0"/>
-              </a:rPr>
-              <a:t> (ERA5-ecPoint)</a:t>
-            </a:r>
-            <a:r>
-              <a:rPr lang="en-US" sz="1000" u="sng" dirty="0">
-                <a:solidFill>
-                  <a:srgbClr val="333333"/>
-                </a:solidFill>
-                <a:latin typeface="Calibri Light" panose="020F0302020204030204" pitchFamily="34" charset="0"/>
-                <a:cs typeface="Calibri Light" panose="020F0302020204030204" pitchFamily="34" charset="0"/>
-              </a:rPr>
-              <a:t> </a:t>
-            </a:r>
-          </a:p>
-          <a:p>
-            <a:r>
-              <a:rPr lang="en-US" sz="1000">
-                <a:solidFill>
-                  <a:srgbClr val="333333"/>
-                </a:solidFill>
-                <a:latin typeface="Calibri Light" panose="020F0302020204030204" pitchFamily="34" charset="0"/>
-                <a:cs typeface="Calibri Light" panose="020F0302020204030204" pitchFamily="34" charset="0"/>
-              </a:rPr>
-              <a:t>Dynamic Fields </a:t>
-            </a:r>
-            <a:r>
-              <a:rPr lang="en-US" sz="1000" dirty="0">
-                <a:solidFill>
-                  <a:srgbClr val="333333"/>
-                </a:solidFill>
-                <a:latin typeface="Calibri Light" panose="020F0302020204030204" pitchFamily="34" charset="0"/>
-                <a:cs typeface="Calibri Light" panose="020F0302020204030204" pitchFamily="34" charset="0"/>
-              </a:rPr>
-              <a:t>(VT: 2021-09-02 at 00 UTC)</a:t>
-            </a:r>
-          </a:p>
-        </p:txBody>
-      </p:sp>
-      <p:sp>
-        <p:nvSpPr>
-          <p:cNvPr id="94" name="TextBox 93">
+              <a:t>Dynamic Fields (VT: from 2021-09-01 at 00 UTC to 2021-09-02 at 00 UTC)</a:t>
+            </a:r>
+          </a:p>
+        </p:txBody>
+      </p:sp>
+      <p:sp>
+        <p:nvSpPr>
+          <p:cNvPr id="35" name="TextBox 34">
             <a:extLst>
               <a:ext uri="{FF2B5EF4-FFF2-40B4-BE49-F238E27FC236}">
                 <a16:creationId xmlns:a16="http://schemas.microsoft.com/office/drawing/2014/main" id="{376BC6E3-86E2-3737-AB80-3B95CB16E8E3}"/>
@@ -5322,7 +6199,7 @@
         </p:nvSpPr>
         <p:spPr>
           <a:xfrm>
-            <a:off x="2124806" y="1090824"/>
+            <a:off x="2126232" y="880403"/>
             <a:ext cx="2124000" cy="215444"/>
           </a:xfrm>
           <a:prstGeom prst="rect">
@@ -5367,7 +6244,7 @@
       </p:sp>
       <p:sp>
         <p:nvSpPr>
-          <p:cNvPr id="95" name="TextBox 94">
+          <p:cNvPr id="36" name="TextBox 35">
             <a:extLst>
               <a:ext uri="{FF2B5EF4-FFF2-40B4-BE49-F238E27FC236}">
                 <a16:creationId xmlns:a16="http://schemas.microsoft.com/office/drawing/2014/main" id="{12D385A0-4768-7304-9AF2-9662B3618F45}"/>
@@ -5379,7 +6256,7 @@
         </p:nvSpPr>
         <p:spPr>
           <a:xfrm>
-            <a:off x="-71437" y="1090824"/>
+            <a:off x="-70011" y="880403"/>
             <a:ext cx="2124000" cy="215444"/>
           </a:xfrm>
           <a:prstGeom prst="rect">
@@ -5424,7 +6301,7 @@
       </p:sp>
       <p:sp>
         <p:nvSpPr>
-          <p:cNvPr id="96" name="TextBox 95">
+          <p:cNvPr id="37" name="TextBox 36">
             <a:extLst>
               <a:ext uri="{FF2B5EF4-FFF2-40B4-BE49-F238E27FC236}">
                 <a16:creationId xmlns:a16="http://schemas.microsoft.com/office/drawing/2014/main" id="{57E75AC1-1794-5E7F-F1C7-E3D46F9F3C6B}"/>
@@ -5436,7 +6313,7 @@
         </p:nvSpPr>
         <p:spPr>
           <a:xfrm>
-            <a:off x="-71437" y="2391879"/>
+            <a:off x="-70011" y="2181458"/>
             <a:ext cx="2124000" cy="215444"/>
           </a:xfrm>
           <a:prstGeom prst="rect">
@@ -5481,7 +6358,7 @@
       </p:sp>
       <p:sp>
         <p:nvSpPr>
-          <p:cNvPr id="97" name="TextBox 96">
+          <p:cNvPr id="38" name="TextBox 37">
             <a:extLst>
               <a:ext uri="{FF2B5EF4-FFF2-40B4-BE49-F238E27FC236}">
                 <a16:creationId xmlns:a16="http://schemas.microsoft.com/office/drawing/2014/main" id="{51966A53-077B-E857-FB56-6D8CABD214E0}"/>
@@ -5493,7 +6370,7 @@
         </p:nvSpPr>
         <p:spPr>
           <a:xfrm>
-            <a:off x="-71437" y="3702079"/>
+            <a:off x="-70011" y="3491658"/>
             <a:ext cx="2124000" cy="215444"/>
           </a:xfrm>
           <a:prstGeom prst="rect">
@@ -5538,7 +6415,7 @@
       </p:sp>
       <p:sp>
         <p:nvSpPr>
-          <p:cNvPr id="98" name="TextBox 97">
+          <p:cNvPr id="39" name="TextBox 38">
             <a:extLst>
               <a:ext uri="{FF2B5EF4-FFF2-40B4-BE49-F238E27FC236}">
                 <a16:creationId xmlns:a16="http://schemas.microsoft.com/office/drawing/2014/main" id="{35DD87AC-C1BC-2933-33E1-AC551ED331CE}"/>
@@ -5550,7 +6427,7 @@
         </p:nvSpPr>
         <p:spPr>
           <a:xfrm>
-            <a:off x="2124806" y="2389418"/>
+            <a:off x="2126232" y="2178997"/>
             <a:ext cx="2124000" cy="216000"/>
           </a:xfrm>
           <a:prstGeom prst="rect">
@@ -5595,7 +6472,7 @@
       </p:sp>
       <p:sp>
         <p:nvSpPr>
-          <p:cNvPr id="99" name="TextBox 98">
+          <p:cNvPr id="40" name="TextBox 39">
             <a:extLst>
               <a:ext uri="{FF2B5EF4-FFF2-40B4-BE49-F238E27FC236}">
                 <a16:creationId xmlns:a16="http://schemas.microsoft.com/office/drawing/2014/main" id="{75493878-E8E3-4B21-EDED-882FA025EE50}"/>
@@ -5607,7 +6484,7 @@
         </p:nvSpPr>
         <p:spPr>
           <a:xfrm>
-            <a:off x="2124806" y="3697157"/>
+            <a:off x="2126232" y="3486736"/>
             <a:ext cx="2124000" cy="216000"/>
           </a:xfrm>
           <a:prstGeom prst="rect">
@@ -5652,7 +6529,7 @@
       </p:sp>
       <p:sp>
         <p:nvSpPr>
-          <p:cNvPr id="100" name="TextBox 262">
+          <p:cNvPr id="41" name="TextBox 262">
             <a:extLst>
               <a:ext uri="{FF2B5EF4-FFF2-40B4-BE49-F238E27FC236}">
                 <a16:creationId xmlns:a16="http://schemas.microsoft.com/office/drawing/2014/main" id="{000021FB-3D9A-C671-5BD8-5FD3D4F57EAF}"/>
@@ -5664,7 +6541,7 @@
         </p:nvSpPr>
         <p:spPr>
           <a:xfrm>
-            <a:off x="1968457" y="534772"/>
+            <a:off x="1969883" y="324351"/>
             <a:ext cx="354154" cy="215444"/>
           </a:xfrm>
           <a:prstGeom prst="rect">
@@ -5697,7 +6574,7 @@
       </p:sp>
       <p:sp>
         <p:nvSpPr>
-          <p:cNvPr id="101" name="TextBox 251">
+          <p:cNvPr id="42" name="TextBox 251">
             <a:extLst>
               <a:ext uri="{FF2B5EF4-FFF2-40B4-BE49-F238E27FC236}">
                 <a16:creationId xmlns:a16="http://schemas.microsoft.com/office/drawing/2014/main" id="{1D9A1454-C5EC-EF96-9456-6EFA68D93F96}"/>
@@ -5709,7 +6586,7 @@
         </p:nvSpPr>
         <p:spPr>
           <a:xfrm>
-            <a:off x="-203709" y="2579465"/>
+            <a:off x="-202283" y="2369044"/>
             <a:ext cx="536815" cy="215444"/>
           </a:xfrm>
           <a:prstGeom prst="rect">
@@ -5759,7 +6636,7 @@
       </p:sp>
       <p:sp>
         <p:nvSpPr>
-          <p:cNvPr id="102" name="TextBox 252">
+          <p:cNvPr id="43" name="TextBox 252">
             <a:extLst>
               <a:ext uri="{FF2B5EF4-FFF2-40B4-BE49-F238E27FC236}">
                 <a16:creationId xmlns:a16="http://schemas.microsoft.com/office/drawing/2014/main" id="{CE3B5F6B-A16B-67FA-B1F3-40AF319AD7BD}"/>
@@ -5771,7 +6648,7 @@
         </p:nvSpPr>
         <p:spPr>
           <a:xfrm>
-            <a:off x="-203709" y="2972424"/>
+            <a:off x="-202283" y="2762003"/>
             <a:ext cx="536815" cy="215444"/>
           </a:xfrm>
           <a:prstGeom prst="rect">
@@ -5821,7 +6698,7 @@
       </p:sp>
       <p:sp>
         <p:nvSpPr>
-          <p:cNvPr id="103" name="TextBox 253">
+          <p:cNvPr id="44" name="TextBox 253">
             <a:extLst>
               <a:ext uri="{FF2B5EF4-FFF2-40B4-BE49-F238E27FC236}">
                 <a16:creationId xmlns:a16="http://schemas.microsoft.com/office/drawing/2014/main" id="{3FF0EAA4-2EF5-4F38-B6EC-35ED6BE230C8}"/>
@@ -5833,7 +6710,7 @@
         </p:nvSpPr>
         <p:spPr>
           <a:xfrm>
-            <a:off x="-203709" y="3305076"/>
+            <a:off x="-202283" y="3094655"/>
             <a:ext cx="536815" cy="215444"/>
           </a:xfrm>
           <a:prstGeom prst="rect">
@@ -5883,7 +6760,7 @@
       </p:sp>
       <p:sp>
         <p:nvSpPr>
-          <p:cNvPr id="104" name="TextBox 251">
+          <p:cNvPr id="45" name="TextBox 251">
             <a:extLst>
               <a:ext uri="{FF2B5EF4-FFF2-40B4-BE49-F238E27FC236}">
                 <a16:creationId xmlns:a16="http://schemas.microsoft.com/office/drawing/2014/main" id="{9C0BF0B8-9ECF-FB3A-55AD-9010A6D0C88A}"/>
@@ -5895,7 +6772,7 @@
         </p:nvSpPr>
         <p:spPr>
           <a:xfrm>
-            <a:off x="-203709" y="3888618"/>
+            <a:off x="-202283" y="3678197"/>
             <a:ext cx="536815" cy="215444"/>
           </a:xfrm>
           <a:prstGeom prst="rect">
@@ -5945,7 +6822,7 @@
       </p:sp>
       <p:sp>
         <p:nvSpPr>
-          <p:cNvPr id="105" name="TextBox 252">
+          <p:cNvPr id="46" name="TextBox 252">
             <a:extLst>
               <a:ext uri="{FF2B5EF4-FFF2-40B4-BE49-F238E27FC236}">
                 <a16:creationId xmlns:a16="http://schemas.microsoft.com/office/drawing/2014/main" id="{B4F89EAC-F5BE-5AB3-6D3A-51942411D6AC}"/>
@@ -5957,7 +6834,7 @@
         </p:nvSpPr>
         <p:spPr>
           <a:xfrm>
-            <a:off x="-203709" y="4276281"/>
+            <a:off x="-202283" y="4065860"/>
             <a:ext cx="536815" cy="215444"/>
           </a:xfrm>
           <a:prstGeom prst="rect">
@@ -6007,7 +6884,7 @@
       </p:sp>
       <p:sp>
         <p:nvSpPr>
-          <p:cNvPr id="106" name="TextBox 253">
+          <p:cNvPr id="47" name="TextBox 253">
             <a:extLst>
               <a:ext uri="{FF2B5EF4-FFF2-40B4-BE49-F238E27FC236}">
                 <a16:creationId xmlns:a16="http://schemas.microsoft.com/office/drawing/2014/main" id="{4B314188-7F22-6C36-D5F3-C79B9823CCF9}"/>
@@ -6019,7 +6896,7 @@
         </p:nvSpPr>
         <p:spPr>
           <a:xfrm>
-            <a:off x="-203709" y="4611583"/>
+            <a:off x="-202283" y="4401162"/>
             <a:ext cx="536815" cy="215444"/>
           </a:xfrm>
           <a:prstGeom prst="rect">
@@ -6069,7 +6946,7 @@
       </p:sp>
       <p:sp>
         <p:nvSpPr>
-          <p:cNvPr id="107" name="TextBox 254">
+          <p:cNvPr id="48" name="TextBox 254">
             <a:extLst>
               <a:ext uri="{FF2B5EF4-FFF2-40B4-BE49-F238E27FC236}">
                 <a16:creationId xmlns:a16="http://schemas.microsoft.com/office/drawing/2014/main" id="{445A7559-4D19-A6F6-DA0F-D756F483D299}"/>
@@ -6081,7 +6958,7 @@
         </p:nvSpPr>
         <p:spPr>
           <a:xfrm>
-            <a:off x="2224336" y="4913976"/>
+            <a:off x="2225762" y="4703555"/>
             <a:ext cx="536815" cy="215444"/>
           </a:xfrm>
           <a:prstGeom prst="rect">
@@ -6131,7 +7008,7 @@
       </p:sp>
       <p:sp>
         <p:nvSpPr>
-          <p:cNvPr id="108" name="TextBox 255">
+          <p:cNvPr id="49" name="TextBox 255">
             <a:extLst>
               <a:ext uri="{FF2B5EF4-FFF2-40B4-BE49-F238E27FC236}">
                 <a16:creationId xmlns:a16="http://schemas.microsoft.com/office/drawing/2014/main" id="{A4EE99A9-33C7-3773-9DEA-E39F625A5212}"/>
@@ -6143,7 +7020,7 @@
         </p:nvSpPr>
         <p:spPr>
           <a:xfrm>
-            <a:off x="2770340" y="4913976"/>
+            <a:off x="2771766" y="4703555"/>
             <a:ext cx="536815" cy="215444"/>
           </a:xfrm>
           <a:prstGeom prst="rect">
@@ -6193,7 +7070,7 @@
       </p:sp>
       <p:sp>
         <p:nvSpPr>
-          <p:cNvPr id="109" name="TextBox 256">
+          <p:cNvPr id="50" name="TextBox 256">
             <a:extLst>
               <a:ext uri="{FF2B5EF4-FFF2-40B4-BE49-F238E27FC236}">
                 <a16:creationId xmlns:a16="http://schemas.microsoft.com/office/drawing/2014/main" id="{D8B522E8-1814-1FE6-CF46-055B320030EF}"/>
@@ -6205,7 +7082,7 @@
         </p:nvSpPr>
         <p:spPr>
           <a:xfrm>
-            <a:off x="3318950" y="4913976"/>
+            <a:off x="3320376" y="4703555"/>
             <a:ext cx="536815" cy="215444"/>
           </a:xfrm>
           <a:prstGeom prst="rect">
@@ -6255,7 +7132,7 @@
       </p:sp>
       <p:sp>
         <p:nvSpPr>
-          <p:cNvPr id="110" name="TextBox 262">
+          <p:cNvPr id="51" name="TextBox 262">
             <a:extLst>
               <a:ext uri="{FF2B5EF4-FFF2-40B4-BE49-F238E27FC236}">
                 <a16:creationId xmlns:a16="http://schemas.microsoft.com/office/drawing/2014/main" id="{F0474377-B166-9FE7-F0CD-757289DF5B18}"/>
@@ -6267,7 +7144,7 @@
         </p:nvSpPr>
         <p:spPr>
           <a:xfrm rot="18900000">
-            <a:off x="1063277" y="717566"/>
+            <a:off x="1064703" y="507145"/>
             <a:ext cx="363600" cy="215444"/>
           </a:xfrm>
           <a:prstGeom prst="rect">
@@ -6299,7 +7176,7 @@
       </p:sp>
       <p:sp>
         <p:nvSpPr>
-          <p:cNvPr id="111" name="TextBox 262">
+          <p:cNvPr id="52" name="TextBox 262">
             <a:extLst>
               <a:ext uri="{FF2B5EF4-FFF2-40B4-BE49-F238E27FC236}">
                 <a16:creationId xmlns:a16="http://schemas.microsoft.com/office/drawing/2014/main" id="{2EC17A87-5F98-30A0-B0E4-2CF025030731}"/>
@@ -6311,7 +7188,7 @@
         </p:nvSpPr>
         <p:spPr>
           <a:xfrm rot="18900000">
-            <a:off x="1249690" y="717566"/>
+            <a:off x="1251116" y="507145"/>
             <a:ext cx="363600" cy="215444"/>
           </a:xfrm>
           <a:prstGeom prst="rect">
@@ -6343,7 +7220,7 @@
       </p:sp>
       <p:sp>
         <p:nvSpPr>
-          <p:cNvPr id="112" name="TextBox 262">
+          <p:cNvPr id="53" name="TextBox 262">
             <a:extLst>
               <a:ext uri="{FF2B5EF4-FFF2-40B4-BE49-F238E27FC236}">
                 <a16:creationId xmlns:a16="http://schemas.microsoft.com/office/drawing/2014/main" id="{B449B9DC-BC6D-3397-ECEA-E2B1A14A2A1D}"/>
@@ -6355,7 +7232,7 @@
         </p:nvSpPr>
         <p:spPr>
           <a:xfrm rot="18900000">
-            <a:off x="1436103" y="717566"/>
+            <a:off x="1437529" y="507145"/>
             <a:ext cx="363600" cy="215444"/>
           </a:xfrm>
           <a:prstGeom prst="rect">
@@ -6387,7 +7264,7 @@
       </p:sp>
       <p:sp>
         <p:nvSpPr>
-          <p:cNvPr id="113" name="TextBox 228">
+          <p:cNvPr id="54" name="TextBox 228">
             <a:extLst>
               <a:ext uri="{FF2B5EF4-FFF2-40B4-BE49-F238E27FC236}">
                 <a16:creationId xmlns:a16="http://schemas.microsoft.com/office/drawing/2014/main" id="{F931034A-7D6F-8EA8-77FA-38D23B11D246}"/>
@@ -6399,7 +7276,7 @@
         </p:nvSpPr>
         <p:spPr>
           <a:xfrm rot="18900000">
-            <a:off x="2554581" y="717566"/>
+            <a:off x="2556007" y="507145"/>
             <a:ext cx="363600" cy="215444"/>
           </a:xfrm>
           <a:prstGeom prst="rect">
@@ -6444,7 +7321,7 @@
       </p:sp>
       <p:sp>
         <p:nvSpPr>
-          <p:cNvPr id="114" name="TextBox 228">
+          <p:cNvPr id="55" name="TextBox 228">
             <a:extLst>
               <a:ext uri="{FF2B5EF4-FFF2-40B4-BE49-F238E27FC236}">
                 <a16:creationId xmlns:a16="http://schemas.microsoft.com/office/drawing/2014/main" id="{4E92A261-3F68-2130-689A-A1282F999C88}"/>
@@ -6456,7 +7333,7 @@
         </p:nvSpPr>
         <p:spPr>
           <a:xfrm rot="18900000">
-            <a:off x="2740994" y="717566"/>
+            <a:off x="2742420" y="507145"/>
             <a:ext cx="363600" cy="215444"/>
           </a:xfrm>
           <a:prstGeom prst="rect">
@@ -6501,7 +7378,7 @@
       </p:sp>
       <p:sp>
         <p:nvSpPr>
-          <p:cNvPr id="115" name="TextBox 228">
+          <p:cNvPr id="56" name="TextBox 228">
             <a:extLst>
               <a:ext uri="{FF2B5EF4-FFF2-40B4-BE49-F238E27FC236}">
                 <a16:creationId xmlns:a16="http://schemas.microsoft.com/office/drawing/2014/main" id="{13B4ED1F-BA20-584D-160D-E72FD57F6E94}"/>
@@ -6513,7 +7390,7 @@
         </p:nvSpPr>
         <p:spPr>
           <a:xfrm rot="18900000">
-            <a:off x="2927407" y="717566"/>
+            <a:off x="2928833" y="507145"/>
             <a:ext cx="363600" cy="215444"/>
           </a:xfrm>
           <a:prstGeom prst="rect">
@@ -6558,7 +7435,7 @@
       </p:sp>
       <p:sp>
         <p:nvSpPr>
-          <p:cNvPr id="116" name="TextBox 228">
+          <p:cNvPr id="57" name="TextBox 228">
             <a:extLst>
               <a:ext uri="{FF2B5EF4-FFF2-40B4-BE49-F238E27FC236}">
                 <a16:creationId xmlns:a16="http://schemas.microsoft.com/office/drawing/2014/main" id="{9E17B2EA-5075-2F32-48F1-B8F79DC14C38}"/>
@@ -6570,7 +7447,7 @@
         </p:nvSpPr>
         <p:spPr>
           <a:xfrm rot="18900000">
-            <a:off x="3113820" y="717566"/>
+            <a:off x="3115246" y="507145"/>
             <a:ext cx="363600" cy="215444"/>
           </a:xfrm>
           <a:prstGeom prst="rect">
@@ -6615,7 +7492,7 @@
       </p:sp>
       <p:sp>
         <p:nvSpPr>
-          <p:cNvPr id="117" name="TextBox 228">
+          <p:cNvPr id="58" name="TextBox 228">
             <a:extLst>
               <a:ext uri="{FF2B5EF4-FFF2-40B4-BE49-F238E27FC236}">
                 <a16:creationId xmlns:a16="http://schemas.microsoft.com/office/drawing/2014/main" id="{3C88EA91-CBB6-2923-84E8-958EAB03D695}"/>
@@ -6627,7 +7504,7 @@
         </p:nvSpPr>
         <p:spPr>
           <a:xfrm rot="18900000">
-            <a:off x="3300233" y="717566"/>
+            <a:off x="3301659" y="507145"/>
             <a:ext cx="363600" cy="215444"/>
           </a:xfrm>
           <a:prstGeom prst="rect">
@@ -6672,7 +7549,7 @@
       </p:sp>
       <p:sp>
         <p:nvSpPr>
-          <p:cNvPr id="118" name="TextBox 228">
+          <p:cNvPr id="59" name="TextBox 228">
             <a:extLst>
               <a:ext uri="{FF2B5EF4-FFF2-40B4-BE49-F238E27FC236}">
                 <a16:creationId xmlns:a16="http://schemas.microsoft.com/office/drawing/2014/main" id="{398D0DBF-C0BF-0EAB-70D2-6FAFBE8D8584}"/>
@@ -6684,7 +7561,7 @@
         </p:nvSpPr>
         <p:spPr>
           <a:xfrm rot="18900000">
-            <a:off x="3486646" y="717566"/>
+            <a:off x="3488072" y="507145"/>
             <a:ext cx="363600" cy="215444"/>
           </a:xfrm>
           <a:prstGeom prst="rect">
@@ -6729,7 +7606,7 @@
       </p:sp>
       <p:sp>
         <p:nvSpPr>
-          <p:cNvPr id="119" name="TextBox 228">
+          <p:cNvPr id="60" name="TextBox 228">
             <a:extLst>
               <a:ext uri="{FF2B5EF4-FFF2-40B4-BE49-F238E27FC236}">
                 <a16:creationId xmlns:a16="http://schemas.microsoft.com/office/drawing/2014/main" id="{BB947B23-D613-6274-5A1A-0612C9DDC7BA}"/>
@@ -6741,7 +7618,7 @@
         </p:nvSpPr>
         <p:spPr>
           <a:xfrm rot="18900000">
-            <a:off x="3673059" y="717566"/>
+            <a:off x="3674485" y="507145"/>
             <a:ext cx="363600" cy="215444"/>
           </a:xfrm>
           <a:prstGeom prst="rect">
@@ -6786,7 +7663,7 @@
       </p:sp>
       <p:sp>
         <p:nvSpPr>
-          <p:cNvPr id="120" name="TextBox 228">
+          <p:cNvPr id="61" name="TextBox 228">
             <a:extLst>
               <a:ext uri="{FF2B5EF4-FFF2-40B4-BE49-F238E27FC236}">
                 <a16:creationId xmlns:a16="http://schemas.microsoft.com/office/drawing/2014/main" id="{5B5E25C5-CF55-1AD6-2F46-56FF2C9AA072}"/>
@@ -6798,7 +7675,7 @@
         </p:nvSpPr>
         <p:spPr>
           <a:xfrm rot="18900000">
-            <a:off x="3859467" y="717566"/>
+            <a:off x="3860893" y="507145"/>
             <a:ext cx="363600" cy="215444"/>
           </a:xfrm>
           <a:prstGeom prst="rect">
@@ -6840,7 +7717,7 @@
       </p:sp>
       <p:sp>
         <p:nvSpPr>
-          <p:cNvPr id="121" name="Oval 120">
+          <p:cNvPr id="62" name="Oval 61">
             <a:extLst>
               <a:ext uri="{FF2B5EF4-FFF2-40B4-BE49-F238E27FC236}">
                 <a16:creationId xmlns:a16="http://schemas.microsoft.com/office/drawing/2014/main" id="{89D57BAF-EDF7-DFF3-25C8-DBF5CA7C01E8}"/>
@@ -6852,7 +7729,7 @@
         </p:nvSpPr>
         <p:spPr>
           <a:xfrm>
-            <a:off x="557315" y="1657350"/>
+            <a:off x="558741" y="1446929"/>
             <a:ext cx="504000" cy="504000"/>
           </a:xfrm>
           <a:prstGeom prst="ellipse">
@@ -6892,7 +7769,7 @@
       </p:sp>
       <p:sp>
         <p:nvSpPr>
-          <p:cNvPr id="122" name="Oval 121">
+          <p:cNvPr id="63" name="Oval 62">
             <a:extLst>
               <a:ext uri="{FF2B5EF4-FFF2-40B4-BE49-F238E27FC236}">
                 <a16:creationId xmlns:a16="http://schemas.microsoft.com/office/drawing/2014/main" id="{2A0340DF-C636-D189-A28F-EA34AB5D27EE}"/>
@@ -6904,7 +7781,7 @@
         </p:nvSpPr>
         <p:spPr>
           <a:xfrm>
-            <a:off x="1413180" y="1573586"/>
+            <a:off x="1414606" y="1363165"/>
             <a:ext cx="504681" cy="504000"/>
           </a:xfrm>
           <a:prstGeom prst="ellipse">
@@ -6948,7 +7825,7 @@
       </p:sp>
       <p:sp>
         <p:nvSpPr>
-          <p:cNvPr id="123" name="TextBox 262">
+          <p:cNvPr id="64" name="TextBox 262">
             <a:extLst>
               <a:ext uri="{FF2B5EF4-FFF2-40B4-BE49-F238E27FC236}">
                 <a16:creationId xmlns:a16="http://schemas.microsoft.com/office/drawing/2014/main" id="{12F38479-AB54-6B30-2D3C-FF8C0302CC0C}"/>
@@ -6960,7 +7837,7 @@
         </p:nvSpPr>
         <p:spPr>
           <a:xfrm>
-            <a:off x="304757" y="1322392"/>
+            <a:off x="306183" y="1111971"/>
             <a:ext cx="1043249" cy="338554"/>
           </a:xfrm>
           <a:prstGeom prst="rect">
@@ -6990,7 +7867,7 @@
       </p:sp>
       <p:sp>
         <p:nvSpPr>
-          <p:cNvPr id="124" name="TextBox 262">
+          <p:cNvPr id="65" name="TextBox 262">
             <a:extLst>
               <a:ext uri="{FF2B5EF4-FFF2-40B4-BE49-F238E27FC236}">
                 <a16:creationId xmlns:a16="http://schemas.microsoft.com/office/drawing/2014/main" id="{F814593F-D80C-3FAD-DC51-3489C5EF4A97}"/>
@@ -7002,7 +7879,7 @@
         </p:nvSpPr>
         <p:spPr>
           <a:xfrm>
-            <a:off x="1067453" y="1236817"/>
+            <a:off x="1068879" y="1026396"/>
             <a:ext cx="1215022" cy="338554"/>
           </a:xfrm>
           <a:prstGeom prst="rect">

</xml_diff>

<commit_message>
Removed the figures that have not been included anymore in the literature review. Also corrected the title of the figure in chapter 4 for the 50-year rp of rainfall
</commit_message>
<xml_diff>
--- a/chapter_04/figures/prob_tp_exceeding_50rp.pptx
+++ b/chapter_04/figures/prob_tp_exceeding_50rp.pptx
@@ -112,2051 +112,29 @@
 </p:presentation>
 </file>
 
-<file path=ppt/revisionInfo.xml><?xml version="1.0" encoding="utf-8"?>
-<p1510:revInfo xmlns:a="http://schemas.openxmlformats.org/drawingml/2006/main" xmlns:r="http://schemas.openxmlformats.org/officeDocument/2006/relationships" xmlns:p1510="http://schemas.microsoft.com/office/powerpoint/2015/10/main">
-  <p1510:revLst>
-    <p1510:client id="{B5DC09CA-6CD4-43F7-8607-5135DBD6D67A}" v="2" dt="2025-07-15T02:45:17.215"/>
-  </p1510:revLst>
-</p1510:revInfo>
-</file>
-
 <file path=ppt/changesInfos/changesInfo1.xml><?xml version="1.0" encoding="utf-8"?>
 <pc:chgInfo xmlns:a="http://schemas.openxmlformats.org/drawingml/2006/main" xmlns:r="http://schemas.openxmlformats.org/officeDocument/2006/relationships" xmlns:ac="http://schemas.microsoft.com/office/drawing/2013/main/command" xmlns:pc="http://schemas.microsoft.com/office/powerpoint/2013/main/command">
   <pc:docChgLst>
-    <pc:chgData name="Fatima Pillosu" userId="a6295d4dc9e22643" providerId="LiveId" clId="{B5DC09CA-6CD4-43F7-8607-5135DBD6D67A}"/>
-    <pc:docChg chg="undo custSel modSld">
-      <pc:chgData name="Fatima Pillosu" userId="a6295d4dc9e22643" providerId="LiveId" clId="{B5DC09CA-6CD4-43F7-8607-5135DBD6D67A}" dt="2025-07-15T02:45:25.851" v="19" actId="1036"/>
+    <pc:chgData name="Fatima Pillosu" userId="a6295d4dc9e22643" providerId="LiveId" clId="{87453732-75AC-4426-B5D3-B7C69C2D4F54}"/>
+    <pc:docChg chg="modSld">
+      <pc:chgData name="Fatima Pillosu" userId="a6295d4dc9e22643" providerId="LiveId" clId="{87453732-75AC-4426-B5D3-B7C69C2D4F54}" dt="2026-01-15T10:01:23.087" v="2" actId="20577"/>
       <pc:docMkLst>
         <pc:docMk/>
       </pc:docMkLst>
-      <pc:sldChg chg="addSp delSp modSp mod">
-        <pc:chgData name="Fatima Pillosu" userId="a6295d4dc9e22643" providerId="LiveId" clId="{B5DC09CA-6CD4-43F7-8607-5135DBD6D67A}" dt="2025-07-15T02:45:25.851" v="19" actId="1036"/>
+      <pc:sldChg chg="modSp mod">
+        <pc:chgData name="Fatima Pillosu" userId="a6295d4dc9e22643" providerId="LiveId" clId="{87453732-75AC-4426-B5D3-B7C69C2D4F54}" dt="2026-01-15T10:01:23.087" v="2" actId="20577"/>
         <pc:sldMkLst>
           <pc:docMk/>
           <pc:sldMk cId="1403429394" sldId="257"/>
         </pc:sldMkLst>
-        <pc:spChg chg="add del">
-          <ac:chgData name="Fatima Pillosu" userId="a6295d4dc9e22643" providerId="LiveId" clId="{B5DC09CA-6CD4-43F7-8607-5135DBD6D67A}" dt="2025-07-15T02:44:36.699" v="2" actId="22"/>
-          <ac:spMkLst>
-            <pc:docMk/>
-            <pc:sldMk cId="1403429394" sldId="257"/>
-            <ac:spMk id="3" creationId="{4BB9EFAB-D6FE-5B26-B821-0CA7E7C4B463}"/>
-          </ac:spMkLst>
-        </pc:spChg>
-        <pc:spChg chg="add mod">
-          <ac:chgData name="Fatima Pillosu" userId="a6295d4dc9e22643" providerId="LiveId" clId="{B5DC09CA-6CD4-43F7-8607-5135DBD6D67A}" dt="2025-07-15T02:45:25.851" v="19" actId="1036"/>
-          <ac:spMkLst>
-            <pc:docMk/>
-            <pc:sldMk cId="1403429394" sldId="257"/>
-            <ac:spMk id="17" creationId="{082CB828-3055-C01D-1D9B-34D32699459C}"/>
-          </ac:spMkLst>
-        </pc:spChg>
-        <pc:spChg chg="add mod">
-          <ac:chgData name="Fatima Pillosu" userId="a6295d4dc9e22643" providerId="LiveId" clId="{B5DC09CA-6CD4-43F7-8607-5135DBD6D67A}" dt="2025-07-15T02:45:25.851" v="19" actId="1036"/>
-          <ac:spMkLst>
-            <pc:docMk/>
-            <pc:sldMk cId="1403429394" sldId="257"/>
-            <ac:spMk id="18" creationId="{26462B98-3F43-7391-382E-5FA37001F70A}"/>
-          </ac:spMkLst>
-        </pc:spChg>
-        <pc:spChg chg="add mod">
-          <ac:chgData name="Fatima Pillosu" userId="a6295d4dc9e22643" providerId="LiveId" clId="{B5DC09CA-6CD4-43F7-8607-5135DBD6D67A}" dt="2025-07-15T02:45:25.851" v="19" actId="1036"/>
-          <ac:spMkLst>
-            <pc:docMk/>
-            <pc:sldMk cId="1403429394" sldId="257"/>
-            <ac:spMk id="19" creationId="{FB1D83BF-C5B8-0F42-ACF1-801724C77646}"/>
-          </ac:spMkLst>
-        </pc:spChg>
-        <pc:spChg chg="add mod">
-          <ac:chgData name="Fatima Pillosu" userId="a6295d4dc9e22643" providerId="LiveId" clId="{B5DC09CA-6CD4-43F7-8607-5135DBD6D67A}" dt="2025-07-15T02:45:25.851" v="19" actId="1036"/>
-          <ac:spMkLst>
-            <pc:docMk/>
-            <pc:sldMk cId="1403429394" sldId="257"/>
-            <ac:spMk id="20" creationId="{EFB51189-ED1C-9467-A21E-04098224201A}"/>
-          </ac:spMkLst>
-        </pc:spChg>
-        <pc:spChg chg="add mod">
-          <ac:chgData name="Fatima Pillosu" userId="a6295d4dc9e22643" providerId="LiveId" clId="{B5DC09CA-6CD4-43F7-8607-5135DBD6D67A}" dt="2025-07-15T02:45:25.851" v="19" actId="1036"/>
-          <ac:spMkLst>
-            <pc:docMk/>
-            <pc:sldMk cId="1403429394" sldId="257"/>
-            <ac:spMk id="21" creationId="{21C332B9-C99D-6C2F-F7A7-D75A6499E176}"/>
-          </ac:spMkLst>
-        </pc:spChg>
-        <pc:spChg chg="add mod">
-          <ac:chgData name="Fatima Pillosu" userId="a6295d4dc9e22643" providerId="LiveId" clId="{B5DC09CA-6CD4-43F7-8607-5135DBD6D67A}" dt="2025-07-15T02:45:25.851" v="19" actId="1036"/>
-          <ac:spMkLst>
-            <pc:docMk/>
-            <pc:sldMk cId="1403429394" sldId="257"/>
-            <ac:spMk id="22" creationId="{88809429-C163-FEA9-654A-C938A20C2ED1}"/>
-          </ac:spMkLst>
-        </pc:spChg>
-        <pc:spChg chg="add mod">
-          <ac:chgData name="Fatima Pillosu" userId="a6295d4dc9e22643" providerId="LiveId" clId="{B5DC09CA-6CD4-43F7-8607-5135DBD6D67A}" dt="2025-07-15T02:45:25.851" v="19" actId="1036"/>
-          <ac:spMkLst>
-            <pc:docMk/>
-            <pc:sldMk cId="1403429394" sldId="257"/>
-            <ac:spMk id="23" creationId="{64A6DF9F-4002-0BE8-0275-A7A7B18AE50E}"/>
-          </ac:spMkLst>
-        </pc:spChg>
-        <pc:spChg chg="add mod">
-          <ac:chgData name="Fatima Pillosu" userId="a6295d4dc9e22643" providerId="LiveId" clId="{B5DC09CA-6CD4-43F7-8607-5135DBD6D67A}" dt="2025-07-15T02:45:25.851" v="19" actId="1036"/>
-          <ac:spMkLst>
-            <pc:docMk/>
-            <pc:sldMk cId="1403429394" sldId="257"/>
-            <ac:spMk id="24" creationId="{FBF4F939-D8E0-4CA6-4395-BE2703ED47D3}"/>
-          </ac:spMkLst>
-        </pc:spChg>
-        <pc:spChg chg="add mod">
-          <ac:chgData name="Fatima Pillosu" userId="a6295d4dc9e22643" providerId="LiveId" clId="{B5DC09CA-6CD4-43F7-8607-5135DBD6D67A}" dt="2025-07-15T02:45:25.851" v="19" actId="1036"/>
-          <ac:spMkLst>
-            <pc:docMk/>
-            <pc:sldMk cId="1403429394" sldId="257"/>
-            <ac:spMk id="25" creationId="{9886A46A-5F0E-29C0-5553-F3C415C39030}"/>
-          </ac:spMkLst>
-        </pc:spChg>
-        <pc:spChg chg="add mod">
-          <ac:chgData name="Fatima Pillosu" userId="a6295d4dc9e22643" providerId="LiveId" clId="{B5DC09CA-6CD4-43F7-8607-5135DBD6D67A}" dt="2025-07-15T02:45:25.851" v="19" actId="1036"/>
-          <ac:spMkLst>
-            <pc:docMk/>
-            <pc:sldMk cId="1403429394" sldId="257"/>
-            <ac:spMk id="26" creationId="{DD731501-A656-7957-75AF-86B51CC75396}"/>
-          </ac:spMkLst>
-        </pc:spChg>
-        <pc:spChg chg="add mod">
-          <ac:chgData name="Fatima Pillosu" userId="a6295d4dc9e22643" providerId="LiveId" clId="{B5DC09CA-6CD4-43F7-8607-5135DBD6D67A}" dt="2025-07-15T02:45:25.851" v="19" actId="1036"/>
-          <ac:spMkLst>
-            <pc:docMk/>
-            <pc:sldMk cId="1403429394" sldId="257"/>
-            <ac:spMk id="27" creationId="{DE08B4AE-3720-60F1-D6B9-743C32AD6707}"/>
-          </ac:spMkLst>
-        </pc:spChg>
-        <pc:spChg chg="add mod">
-          <ac:chgData name="Fatima Pillosu" userId="a6295d4dc9e22643" providerId="LiveId" clId="{B5DC09CA-6CD4-43F7-8607-5135DBD6D67A}" dt="2025-07-15T02:45:25.851" v="19" actId="1036"/>
-          <ac:spMkLst>
-            <pc:docMk/>
-            <pc:sldMk cId="1403429394" sldId="257"/>
-            <ac:spMk id="28" creationId="{9C4F17D1-D949-02CB-0B46-48106B0B393C}"/>
-          </ac:spMkLst>
-        </pc:spChg>
-        <pc:spChg chg="add mod">
-          <ac:chgData name="Fatima Pillosu" userId="a6295d4dc9e22643" providerId="LiveId" clId="{B5DC09CA-6CD4-43F7-8607-5135DBD6D67A}" dt="2025-07-15T02:45:25.851" v="19" actId="1036"/>
-          <ac:spMkLst>
-            <pc:docMk/>
-            <pc:sldMk cId="1403429394" sldId="257"/>
-            <ac:spMk id="29" creationId="{455A54B8-5CD9-B620-BC08-5F6DA9DF0ED8}"/>
-          </ac:spMkLst>
-        </pc:spChg>
-        <pc:spChg chg="add mod">
-          <ac:chgData name="Fatima Pillosu" userId="a6295d4dc9e22643" providerId="LiveId" clId="{B5DC09CA-6CD4-43F7-8607-5135DBD6D67A}" dt="2025-07-15T02:45:25.851" v="19" actId="1036"/>
-          <ac:spMkLst>
-            <pc:docMk/>
-            <pc:sldMk cId="1403429394" sldId="257"/>
-            <ac:spMk id="30" creationId="{55890E00-81A3-E28D-C052-5E4FA9603339}"/>
-          </ac:spMkLst>
-        </pc:spChg>
-        <pc:spChg chg="add mod">
-          <ac:chgData name="Fatima Pillosu" userId="a6295d4dc9e22643" providerId="LiveId" clId="{B5DC09CA-6CD4-43F7-8607-5135DBD6D67A}" dt="2025-07-15T02:45:25.851" v="19" actId="1036"/>
-          <ac:spMkLst>
-            <pc:docMk/>
-            <pc:sldMk cId="1403429394" sldId="257"/>
-            <ac:spMk id="31" creationId="{D22BC35C-D8BA-9C47-5E36-D7A2E39E7940}"/>
-          </ac:spMkLst>
-        </pc:spChg>
-        <pc:spChg chg="add mod">
-          <ac:chgData name="Fatima Pillosu" userId="a6295d4dc9e22643" providerId="LiveId" clId="{B5DC09CA-6CD4-43F7-8607-5135DBD6D67A}" dt="2025-07-15T02:45:25.851" v="19" actId="1036"/>
-          <ac:spMkLst>
-            <pc:docMk/>
-            <pc:sldMk cId="1403429394" sldId="257"/>
-            <ac:spMk id="32" creationId="{2847A4E1-5D8A-BA47-5F8F-485D455DD114}"/>
-          </ac:spMkLst>
-        </pc:spChg>
-        <pc:spChg chg="add mod">
-          <ac:chgData name="Fatima Pillosu" userId="a6295d4dc9e22643" providerId="LiveId" clId="{B5DC09CA-6CD4-43F7-8607-5135DBD6D67A}" dt="2025-07-15T02:45:25.851" v="19" actId="1036"/>
-          <ac:spMkLst>
-            <pc:docMk/>
-            <pc:sldMk cId="1403429394" sldId="257"/>
-            <ac:spMk id="33" creationId="{9A16AC1B-8EF3-92A4-CABD-D73AD244F75E}"/>
-          </ac:spMkLst>
-        </pc:spChg>
-        <pc:spChg chg="add mod">
-          <ac:chgData name="Fatima Pillosu" userId="a6295d4dc9e22643" providerId="LiveId" clId="{B5DC09CA-6CD4-43F7-8607-5135DBD6D67A}" dt="2025-07-15T02:45:17.215" v="11"/>
+        <pc:spChg chg="mod">
+          <ac:chgData name="Fatima Pillosu" userId="a6295d4dc9e22643" providerId="LiveId" clId="{87453732-75AC-4426-B5D3-B7C69C2D4F54}" dt="2026-01-15T10:01:23.087" v="2" actId="20577"/>
           <ac:spMkLst>
             <pc:docMk/>
             <pc:sldMk cId="1403429394" sldId="257"/>
             <ac:spMk id="34" creationId="{15B66109-5EC0-175E-124D-C46996895CE7}"/>
           </ac:spMkLst>
         </pc:spChg>
-        <pc:spChg chg="add mod">
-          <ac:chgData name="Fatima Pillosu" userId="a6295d4dc9e22643" providerId="LiveId" clId="{B5DC09CA-6CD4-43F7-8607-5135DBD6D67A}" dt="2025-07-15T02:45:25.851" v="19" actId="1036"/>
-          <ac:spMkLst>
-            <pc:docMk/>
-            <pc:sldMk cId="1403429394" sldId="257"/>
-            <ac:spMk id="35" creationId="{376BC6E3-86E2-3737-AB80-3B95CB16E8E3}"/>
-          </ac:spMkLst>
-        </pc:spChg>
-        <pc:spChg chg="add mod">
-          <ac:chgData name="Fatima Pillosu" userId="a6295d4dc9e22643" providerId="LiveId" clId="{B5DC09CA-6CD4-43F7-8607-5135DBD6D67A}" dt="2025-07-15T02:45:25.851" v="19" actId="1036"/>
-          <ac:spMkLst>
-            <pc:docMk/>
-            <pc:sldMk cId="1403429394" sldId="257"/>
-            <ac:spMk id="36" creationId="{12D385A0-4768-7304-9AF2-9662B3618F45}"/>
-          </ac:spMkLst>
-        </pc:spChg>
-        <pc:spChg chg="add mod">
-          <ac:chgData name="Fatima Pillosu" userId="a6295d4dc9e22643" providerId="LiveId" clId="{B5DC09CA-6CD4-43F7-8607-5135DBD6D67A}" dt="2025-07-15T02:45:25.851" v="19" actId="1036"/>
-          <ac:spMkLst>
-            <pc:docMk/>
-            <pc:sldMk cId="1403429394" sldId="257"/>
-            <ac:spMk id="37" creationId="{57E75AC1-1794-5E7F-F1C7-E3D46F9F3C6B}"/>
-          </ac:spMkLst>
-        </pc:spChg>
-        <pc:spChg chg="add mod">
-          <ac:chgData name="Fatima Pillosu" userId="a6295d4dc9e22643" providerId="LiveId" clId="{B5DC09CA-6CD4-43F7-8607-5135DBD6D67A}" dt="2025-07-15T02:45:25.851" v="19" actId="1036"/>
-          <ac:spMkLst>
-            <pc:docMk/>
-            <pc:sldMk cId="1403429394" sldId="257"/>
-            <ac:spMk id="38" creationId="{51966A53-077B-E857-FB56-6D8CABD214E0}"/>
-          </ac:spMkLst>
-        </pc:spChg>
-        <pc:spChg chg="add mod">
-          <ac:chgData name="Fatima Pillosu" userId="a6295d4dc9e22643" providerId="LiveId" clId="{B5DC09CA-6CD4-43F7-8607-5135DBD6D67A}" dt="2025-07-15T02:45:25.851" v="19" actId="1036"/>
-          <ac:spMkLst>
-            <pc:docMk/>
-            <pc:sldMk cId="1403429394" sldId="257"/>
-            <ac:spMk id="39" creationId="{35DD87AC-C1BC-2933-33E1-AC551ED331CE}"/>
-          </ac:spMkLst>
-        </pc:spChg>
-        <pc:spChg chg="add mod">
-          <ac:chgData name="Fatima Pillosu" userId="a6295d4dc9e22643" providerId="LiveId" clId="{B5DC09CA-6CD4-43F7-8607-5135DBD6D67A}" dt="2025-07-15T02:45:25.851" v="19" actId="1036"/>
-          <ac:spMkLst>
-            <pc:docMk/>
-            <pc:sldMk cId="1403429394" sldId="257"/>
-            <ac:spMk id="40" creationId="{75493878-E8E3-4B21-EDED-882FA025EE50}"/>
-          </ac:spMkLst>
-        </pc:spChg>
-        <pc:spChg chg="add mod">
-          <ac:chgData name="Fatima Pillosu" userId="a6295d4dc9e22643" providerId="LiveId" clId="{B5DC09CA-6CD4-43F7-8607-5135DBD6D67A}" dt="2025-07-15T02:45:25.851" v="19" actId="1036"/>
-          <ac:spMkLst>
-            <pc:docMk/>
-            <pc:sldMk cId="1403429394" sldId="257"/>
-            <ac:spMk id="41" creationId="{000021FB-3D9A-C671-5BD8-5FD3D4F57EAF}"/>
-          </ac:spMkLst>
-        </pc:spChg>
-        <pc:spChg chg="add mod">
-          <ac:chgData name="Fatima Pillosu" userId="a6295d4dc9e22643" providerId="LiveId" clId="{B5DC09CA-6CD4-43F7-8607-5135DBD6D67A}" dt="2025-07-15T02:45:25.851" v="19" actId="1036"/>
-          <ac:spMkLst>
-            <pc:docMk/>
-            <pc:sldMk cId="1403429394" sldId="257"/>
-            <ac:spMk id="42" creationId="{1D9A1454-C5EC-EF96-9456-6EFA68D93F96}"/>
-          </ac:spMkLst>
-        </pc:spChg>
-        <pc:spChg chg="add mod">
-          <ac:chgData name="Fatima Pillosu" userId="a6295d4dc9e22643" providerId="LiveId" clId="{B5DC09CA-6CD4-43F7-8607-5135DBD6D67A}" dt="2025-07-15T02:45:25.851" v="19" actId="1036"/>
-          <ac:spMkLst>
-            <pc:docMk/>
-            <pc:sldMk cId="1403429394" sldId="257"/>
-            <ac:spMk id="43" creationId="{CE3B5F6B-A16B-67FA-B1F3-40AF319AD7BD}"/>
-          </ac:spMkLst>
-        </pc:spChg>
-        <pc:spChg chg="add mod">
-          <ac:chgData name="Fatima Pillosu" userId="a6295d4dc9e22643" providerId="LiveId" clId="{B5DC09CA-6CD4-43F7-8607-5135DBD6D67A}" dt="2025-07-15T02:45:25.851" v="19" actId="1036"/>
-          <ac:spMkLst>
-            <pc:docMk/>
-            <pc:sldMk cId="1403429394" sldId="257"/>
-            <ac:spMk id="44" creationId="{3FF0EAA4-2EF5-4F38-B6EC-35ED6BE230C8}"/>
-          </ac:spMkLst>
-        </pc:spChg>
-        <pc:spChg chg="add mod">
-          <ac:chgData name="Fatima Pillosu" userId="a6295d4dc9e22643" providerId="LiveId" clId="{B5DC09CA-6CD4-43F7-8607-5135DBD6D67A}" dt="2025-07-15T02:45:25.851" v="19" actId="1036"/>
-          <ac:spMkLst>
-            <pc:docMk/>
-            <pc:sldMk cId="1403429394" sldId="257"/>
-            <ac:spMk id="45" creationId="{9C0BF0B8-9ECF-FB3A-55AD-9010A6D0C88A}"/>
-          </ac:spMkLst>
-        </pc:spChg>
-        <pc:spChg chg="add mod">
-          <ac:chgData name="Fatima Pillosu" userId="a6295d4dc9e22643" providerId="LiveId" clId="{B5DC09CA-6CD4-43F7-8607-5135DBD6D67A}" dt="2025-07-15T02:45:25.851" v="19" actId="1036"/>
-          <ac:spMkLst>
-            <pc:docMk/>
-            <pc:sldMk cId="1403429394" sldId="257"/>
-            <ac:spMk id="46" creationId="{B4F89EAC-F5BE-5AB3-6D3A-51942411D6AC}"/>
-          </ac:spMkLst>
-        </pc:spChg>
-        <pc:spChg chg="add mod">
-          <ac:chgData name="Fatima Pillosu" userId="a6295d4dc9e22643" providerId="LiveId" clId="{B5DC09CA-6CD4-43F7-8607-5135DBD6D67A}" dt="2025-07-15T02:45:25.851" v="19" actId="1036"/>
-          <ac:spMkLst>
-            <pc:docMk/>
-            <pc:sldMk cId="1403429394" sldId="257"/>
-            <ac:spMk id="47" creationId="{4B314188-7F22-6C36-D5F3-C79B9823CCF9}"/>
-          </ac:spMkLst>
-        </pc:spChg>
-        <pc:spChg chg="add mod">
-          <ac:chgData name="Fatima Pillosu" userId="a6295d4dc9e22643" providerId="LiveId" clId="{B5DC09CA-6CD4-43F7-8607-5135DBD6D67A}" dt="2025-07-15T02:45:25.851" v="19" actId="1036"/>
-          <ac:spMkLst>
-            <pc:docMk/>
-            <pc:sldMk cId="1403429394" sldId="257"/>
-            <ac:spMk id="48" creationId="{445A7559-4D19-A6F6-DA0F-D756F483D299}"/>
-          </ac:spMkLst>
-        </pc:spChg>
-        <pc:spChg chg="add mod">
-          <ac:chgData name="Fatima Pillosu" userId="a6295d4dc9e22643" providerId="LiveId" clId="{B5DC09CA-6CD4-43F7-8607-5135DBD6D67A}" dt="2025-07-15T02:45:25.851" v="19" actId="1036"/>
-          <ac:spMkLst>
-            <pc:docMk/>
-            <pc:sldMk cId="1403429394" sldId="257"/>
-            <ac:spMk id="49" creationId="{A4EE99A9-33C7-3773-9DEA-E39F625A5212}"/>
-          </ac:spMkLst>
-        </pc:spChg>
-        <pc:spChg chg="add mod">
-          <ac:chgData name="Fatima Pillosu" userId="a6295d4dc9e22643" providerId="LiveId" clId="{B5DC09CA-6CD4-43F7-8607-5135DBD6D67A}" dt="2025-07-15T02:45:25.851" v="19" actId="1036"/>
-          <ac:spMkLst>
-            <pc:docMk/>
-            <pc:sldMk cId="1403429394" sldId="257"/>
-            <ac:spMk id="50" creationId="{D8B522E8-1814-1FE6-CF46-055B320030EF}"/>
-          </ac:spMkLst>
-        </pc:spChg>
-        <pc:spChg chg="add mod">
-          <ac:chgData name="Fatima Pillosu" userId="a6295d4dc9e22643" providerId="LiveId" clId="{B5DC09CA-6CD4-43F7-8607-5135DBD6D67A}" dt="2025-07-15T02:45:25.851" v="19" actId="1036"/>
-          <ac:spMkLst>
-            <pc:docMk/>
-            <pc:sldMk cId="1403429394" sldId="257"/>
-            <ac:spMk id="51" creationId="{F0474377-B166-9FE7-F0CD-757289DF5B18}"/>
-          </ac:spMkLst>
-        </pc:spChg>
-        <pc:spChg chg="add mod">
-          <ac:chgData name="Fatima Pillosu" userId="a6295d4dc9e22643" providerId="LiveId" clId="{B5DC09CA-6CD4-43F7-8607-5135DBD6D67A}" dt="2025-07-15T02:45:25.851" v="19" actId="1036"/>
-          <ac:spMkLst>
-            <pc:docMk/>
-            <pc:sldMk cId="1403429394" sldId="257"/>
-            <ac:spMk id="52" creationId="{2EC17A87-5F98-30A0-B0E4-2CF025030731}"/>
-          </ac:spMkLst>
-        </pc:spChg>
-        <pc:spChg chg="add mod">
-          <ac:chgData name="Fatima Pillosu" userId="a6295d4dc9e22643" providerId="LiveId" clId="{B5DC09CA-6CD4-43F7-8607-5135DBD6D67A}" dt="2025-07-15T02:45:25.851" v="19" actId="1036"/>
-          <ac:spMkLst>
-            <pc:docMk/>
-            <pc:sldMk cId="1403429394" sldId="257"/>
-            <ac:spMk id="53" creationId="{B449B9DC-BC6D-3397-ECEA-E2B1A14A2A1D}"/>
-          </ac:spMkLst>
-        </pc:spChg>
-        <pc:spChg chg="add mod">
-          <ac:chgData name="Fatima Pillosu" userId="a6295d4dc9e22643" providerId="LiveId" clId="{B5DC09CA-6CD4-43F7-8607-5135DBD6D67A}" dt="2025-07-15T02:45:25.851" v="19" actId="1036"/>
-          <ac:spMkLst>
-            <pc:docMk/>
-            <pc:sldMk cId="1403429394" sldId="257"/>
-            <ac:spMk id="54" creationId="{F931034A-7D6F-8EA8-77FA-38D23B11D246}"/>
-          </ac:spMkLst>
-        </pc:spChg>
-        <pc:spChg chg="add mod">
-          <ac:chgData name="Fatima Pillosu" userId="a6295d4dc9e22643" providerId="LiveId" clId="{B5DC09CA-6CD4-43F7-8607-5135DBD6D67A}" dt="2025-07-15T02:45:25.851" v="19" actId="1036"/>
-          <ac:spMkLst>
-            <pc:docMk/>
-            <pc:sldMk cId="1403429394" sldId="257"/>
-            <ac:spMk id="55" creationId="{4E92A261-3F68-2130-689A-A1282F999C88}"/>
-          </ac:spMkLst>
-        </pc:spChg>
-        <pc:spChg chg="add mod">
-          <ac:chgData name="Fatima Pillosu" userId="a6295d4dc9e22643" providerId="LiveId" clId="{B5DC09CA-6CD4-43F7-8607-5135DBD6D67A}" dt="2025-07-15T02:45:25.851" v="19" actId="1036"/>
-          <ac:spMkLst>
-            <pc:docMk/>
-            <pc:sldMk cId="1403429394" sldId="257"/>
-            <ac:spMk id="56" creationId="{13B4ED1F-BA20-584D-160D-E72FD57F6E94}"/>
-          </ac:spMkLst>
-        </pc:spChg>
-        <pc:spChg chg="add mod">
-          <ac:chgData name="Fatima Pillosu" userId="a6295d4dc9e22643" providerId="LiveId" clId="{B5DC09CA-6CD4-43F7-8607-5135DBD6D67A}" dt="2025-07-15T02:45:25.851" v="19" actId="1036"/>
-          <ac:spMkLst>
-            <pc:docMk/>
-            <pc:sldMk cId="1403429394" sldId="257"/>
-            <ac:spMk id="57" creationId="{9E17B2EA-5075-2F32-48F1-B8F79DC14C38}"/>
-          </ac:spMkLst>
-        </pc:spChg>
-        <pc:spChg chg="add mod">
-          <ac:chgData name="Fatima Pillosu" userId="a6295d4dc9e22643" providerId="LiveId" clId="{B5DC09CA-6CD4-43F7-8607-5135DBD6D67A}" dt="2025-07-15T02:45:25.851" v="19" actId="1036"/>
-          <ac:spMkLst>
-            <pc:docMk/>
-            <pc:sldMk cId="1403429394" sldId="257"/>
-            <ac:spMk id="58" creationId="{3C88EA91-CBB6-2923-84E8-958EAB03D695}"/>
-          </ac:spMkLst>
-        </pc:spChg>
-        <pc:spChg chg="add mod">
-          <ac:chgData name="Fatima Pillosu" userId="a6295d4dc9e22643" providerId="LiveId" clId="{B5DC09CA-6CD4-43F7-8607-5135DBD6D67A}" dt="2025-07-15T02:45:25.851" v="19" actId="1036"/>
-          <ac:spMkLst>
-            <pc:docMk/>
-            <pc:sldMk cId="1403429394" sldId="257"/>
-            <ac:spMk id="59" creationId="{398D0DBF-C0BF-0EAB-70D2-6FAFBE8D8584}"/>
-          </ac:spMkLst>
-        </pc:spChg>
-        <pc:spChg chg="add mod">
-          <ac:chgData name="Fatima Pillosu" userId="a6295d4dc9e22643" providerId="LiveId" clId="{B5DC09CA-6CD4-43F7-8607-5135DBD6D67A}" dt="2025-07-15T02:45:25.851" v="19" actId="1036"/>
-          <ac:spMkLst>
-            <pc:docMk/>
-            <pc:sldMk cId="1403429394" sldId="257"/>
-            <ac:spMk id="60" creationId="{BB947B23-D613-6274-5A1A-0612C9DDC7BA}"/>
-          </ac:spMkLst>
-        </pc:spChg>
-        <pc:spChg chg="add mod">
-          <ac:chgData name="Fatima Pillosu" userId="a6295d4dc9e22643" providerId="LiveId" clId="{B5DC09CA-6CD4-43F7-8607-5135DBD6D67A}" dt="2025-07-15T02:45:25.851" v="19" actId="1036"/>
-          <ac:spMkLst>
-            <pc:docMk/>
-            <pc:sldMk cId="1403429394" sldId="257"/>
-            <ac:spMk id="61" creationId="{5B5E25C5-CF55-1AD6-2F46-56FF2C9AA072}"/>
-          </ac:spMkLst>
-        </pc:spChg>
-        <pc:spChg chg="add mod">
-          <ac:chgData name="Fatima Pillosu" userId="a6295d4dc9e22643" providerId="LiveId" clId="{B5DC09CA-6CD4-43F7-8607-5135DBD6D67A}" dt="2025-07-15T02:45:25.851" v="19" actId="1036"/>
-          <ac:spMkLst>
-            <pc:docMk/>
-            <pc:sldMk cId="1403429394" sldId="257"/>
-            <ac:spMk id="62" creationId="{89D57BAF-EDF7-DFF3-25C8-DBF5CA7C01E8}"/>
-          </ac:spMkLst>
-        </pc:spChg>
-        <pc:spChg chg="add mod">
-          <ac:chgData name="Fatima Pillosu" userId="a6295d4dc9e22643" providerId="LiveId" clId="{B5DC09CA-6CD4-43F7-8607-5135DBD6D67A}" dt="2025-07-15T02:45:25.851" v="19" actId="1036"/>
-          <ac:spMkLst>
-            <pc:docMk/>
-            <pc:sldMk cId="1403429394" sldId="257"/>
-            <ac:spMk id="63" creationId="{2A0340DF-C636-D189-A28F-EA34AB5D27EE}"/>
-          </ac:spMkLst>
-        </pc:spChg>
-        <pc:spChg chg="add mod">
-          <ac:chgData name="Fatima Pillosu" userId="a6295d4dc9e22643" providerId="LiveId" clId="{B5DC09CA-6CD4-43F7-8607-5135DBD6D67A}" dt="2025-07-15T02:45:25.851" v="19" actId="1036"/>
-          <ac:spMkLst>
-            <pc:docMk/>
-            <pc:sldMk cId="1403429394" sldId="257"/>
-            <ac:spMk id="64" creationId="{12F38479-AB54-6B30-2D3C-FF8C0302CC0C}"/>
-          </ac:spMkLst>
-        </pc:spChg>
-        <pc:spChg chg="add mod">
-          <ac:chgData name="Fatima Pillosu" userId="a6295d4dc9e22643" providerId="LiveId" clId="{B5DC09CA-6CD4-43F7-8607-5135DBD6D67A}" dt="2025-07-15T02:45:25.851" v="19" actId="1036"/>
-          <ac:spMkLst>
-            <pc:docMk/>
-            <pc:sldMk cId="1403429394" sldId="257"/>
-            <ac:spMk id="65" creationId="{F814593F-D80C-3FAD-DC51-3489C5EF4A97}"/>
-          </ac:spMkLst>
-        </pc:spChg>
-        <pc:spChg chg="del mod">
-          <ac:chgData name="Fatima Pillosu" userId="a6295d4dc9e22643" providerId="LiveId" clId="{B5DC09CA-6CD4-43F7-8607-5135DBD6D67A}" dt="2025-07-15T02:45:05.956" v="10" actId="21"/>
-          <ac:spMkLst>
-            <pc:docMk/>
-            <pc:sldMk cId="1403429394" sldId="257"/>
-            <ac:spMk id="76" creationId="{082CB828-3055-C01D-1D9B-34D32699459C}"/>
-          </ac:spMkLst>
-        </pc:spChg>
-        <pc:spChg chg="del mod">
-          <ac:chgData name="Fatima Pillosu" userId="a6295d4dc9e22643" providerId="LiveId" clId="{B5DC09CA-6CD4-43F7-8607-5135DBD6D67A}" dt="2025-07-15T02:45:05.956" v="10" actId="21"/>
-          <ac:spMkLst>
-            <pc:docMk/>
-            <pc:sldMk cId="1403429394" sldId="257"/>
-            <ac:spMk id="77" creationId="{26462B98-3F43-7391-382E-5FA37001F70A}"/>
-          </ac:spMkLst>
-        </pc:spChg>
-        <pc:spChg chg="del mod">
-          <ac:chgData name="Fatima Pillosu" userId="a6295d4dc9e22643" providerId="LiveId" clId="{B5DC09CA-6CD4-43F7-8607-5135DBD6D67A}" dt="2025-07-15T02:45:05.956" v="10" actId="21"/>
-          <ac:spMkLst>
-            <pc:docMk/>
-            <pc:sldMk cId="1403429394" sldId="257"/>
-            <ac:spMk id="78" creationId="{FB1D83BF-C5B8-0F42-ACF1-801724C77646}"/>
-          </ac:spMkLst>
-        </pc:spChg>
-        <pc:spChg chg="del mod">
-          <ac:chgData name="Fatima Pillosu" userId="a6295d4dc9e22643" providerId="LiveId" clId="{B5DC09CA-6CD4-43F7-8607-5135DBD6D67A}" dt="2025-07-15T02:45:05.956" v="10" actId="21"/>
-          <ac:spMkLst>
-            <pc:docMk/>
-            <pc:sldMk cId="1403429394" sldId="257"/>
-            <ac:spMk id="79" creationId="{EFB51189-ED1C-9467-A21E-04098224201A}"/>
-          </ac:spMkLst>
-        </pc:spChg>
-        <pc:spChg chg="del mod">
-          <ac:chgData name="Fatima Pillosu" userId="a6295d4dc9e22643" providerId="LiveId" clId="{B5DC09CA-6CD4-43F7-8607-5135DBD6D67A}" dt="2025-07-15T02:45:05.956" v="10" actId="21"/>
-          <ac:spMkLst>
-            <pc:docMk/>
-            <pc:sldMk cId="1403429394" sldId="257"/>
-            <ac:spMk id="80" creationId="{21C332B9-C99D-6C2F-F7A7-D75A6499E176}"/>
-          </ac:spMkLst>
-        </pc:spChg>
-        <pc:spChg chg="del mod">
-          <ac:chgData name="Fatima Pillosu" userId="a6295d4dc9e22643" providerId="LiveId" clId="{B5DC09CA-6CD4-43F7-8607-5135DBD6D67A}" dt="2025-07-15T02:45:05.956" v="10" actId="21"/>
-          <ac:spMkLst>
-            <pc:docMk/>
-            <pc:sldMk cId="1403429394" sldId="257"/>
-            <ac:spMk id="81" creationId="{88809429-C163-FEA9-654A-C938A20C2ED1}"/>
-          </ac:spMkLst>
-        </pc:spChg>
-        <pc:spChg chg="del mod">
-          <ac:chgData name="Fatima Pillosu" userId="a6295d4dc9e22643" providerId="LiveId" clId="{B5DC09CA-6CD4-43F7-8607-5135DBD6D67A}" dt="2025-07-15T02:45:05.956" v="10" actId="21"/>
-          <ac:spMkLst>
-            <pc:docMk/>
-            <pc:sldMk cId="1403429394" sldId="257"/>
-            <ac:spMk id="82" creationId="{64A6DF9F-4002-0BE8-0275-A7A7B18AE50E}"/>
-          </ac:spMkLst>
-        </pc:spChg>
-        <pc:spChg chg="del mod">
-          <ac:chgData name="Fatima Pillosu" userId="a6295d4dc9e22643" providerId="LiveId" clId="{B5DC09CA-6CD4-43F7-8607-5135DBD6D67A}" dt="2025-07-15T02:45:05.956" v="10" actId="21"/>
-          <ac:spMkLst>
-            <pc:docMk/>
-            <pc:sldMk cId="1403429394" sldId="257"/>
-            <ac:spMk id="83" creationId="{FBF4F939-D8E0-4CA6-4395-BE2703ED47D3}"/>
-          </ac:spMkLst>
-        </pc:spChg>
-        <pc:spChg chg="del mod">
-          <ac:chgData name="Fatima Pillosu" userId="a6295d4dc9e22643" providerId="LiveId" clId="{B5DC09CA-6CD4-43F7-8607-5135DBD6D67A}" dt="2025-07-15T02:45:05.956" v="10" actId="21"/>
-          <ac:spMkLst>
-            <pc:docMk/>
-            <pc:sldMk cId="1403429394" sldId="257"/>
-            <ac:spMk id="84" creationId="{9886A46A-5F0E-29C0-5553-F3C415C39030}"/>
-          </ac:spMkLst>
-        </pc:spChg>
-        <pc:spChg chg="del mod">
-          <ac:chgData name="Fatima Pillosu" userId="a6295d4dc9e22643" providerId="LiveId" clId="{B5DC09CA-6CD4-43F7-8607-5135DBD6D67A}" dt="2025-07-15T02:45:05.956" v="10" actId="21"/>
-          <ac:spMkLst>
-            <pc:docMk/>
-            <pc:sldMk cId="1403429394" sldId="257"/>
-            <ac:spMk id="85" creationId="{DD731501-A656-7957-75AF-86B51CC75396}"/>
-          </ac:spMkLst>
-        </pc:spChg>
-        <pc:spChg chg="del mod">
-          <ac:chgData name="Fatima Pillosu" userId="a6295d4dc9e22643" providerId="LiveId" clId="{B5DC09CA-6CD4-43F7-8607-5135DBD6D67A}" dt="2025-07-15T02:45:05.956" v="10" actId="21"/>
-          <ac:spMkLst>
-            <pc:docMk/>
-            <pc:sldMk cId="1403429394" sldId="257"/>
-            <ac:spMk id="86" creationId="{DE08B4AE-3720-60F1-D6B9-743C32AD6707}"/>
-          </ac:spMkLst>
-        </pc:spChg>
-        <pc:spChg chg="del mod">
-          <ac:chgData name="Fatima Pillosu" userId="a6295d4dc9e22643" providerId="LiveId" clId="{B5DC09CA-6CD4-43F7-8607-5135DBD6D67A}" dt="2025-07-15T02:45:05.956" v="10" actId="21"/>
-          <ac:spMkLst>
-            <pc:docMk/>
-            <pc:sldMk cId="1403429394" sldId="257"/>
-            <ac:spMk id="87" creationId="{9C4F17D1-D949-02CB-0B46-48106B0B393C}"/>
-          </ac:spMkLst>
-        </pc:spChg>
-        <pc:spChg chg="del mod">
-          <ac:chgData name="Fatima Pillosu" userId="a6295d4dc9e22643" providerId="LiveId" clId="{B5DC09CA-6CD4-43F7-8607-5135DBD6D67A}" dt="2025-07-15T02:45:05.956" v="10" actId="21"/>
-          <ac:spMkLst>
-            <pc:docMk/>
-            <pc:sldMk cId="1403429394" sldId="257"/>
-            <ac:spMk id="88" creationId="{455A54B8-5CD9-B620-BC08-5F6DA9DF0ED8}"/>
-          </ac:spMkLst>
-        </pc:spChg>
-        <pc:spChg chg="del mod">
-          <ac:chgData name="Fatima Pillosu" userId="a6295d4dc9e22643" providerId="LiveId" clId="{B5DC09CA-6CD4-43F7-8607-5135DBD6D67A}" dt="2025-07-15T02:45:05.956" v="10" actId="21"/>
-          <ac:spMkLst>
-            <pc:docMk/>
-            <pc:sldMk cId="1403429394" sldId="257"/>
-            <ac:spMk id="89" creationId="{55890E00-81A3-E28D-C052-5E4FA9603339}"/>
-          </ac:spMkLst>
-        </pc:spChg>
-        <pc:spChg chg="del mod">
-          <ac:chgData name="Fatima Pillosu" userId="a6295d4dc9e22643" providerId="LiveId" clId="{B5DC09CA-6CD4-43F7-8607-5135DBD6D67A}" dt="2025-07-15T02:45:05.956" v="10" actId="21"/>
-          <ac:spMkLst>
-            <pc:docMk/>
-            <pc:sldMk cId="1403429394" sldId="257"/>
-            <ac:spMk id="90" creationId="{D22BC35C-D8BA-9C47-5E36-D7A2E39E7940}"/>
-          </ac:spMkLst>
-        </pc:spChg>
-        <pc:spChg chg="del mod">
-          <ac:chgData name="Fatima Pillosu" userId="a6295d4dc9e22643" providerId="LiveId" clId="{B5DC09CA-6CD4-43F7-8607-5135DBD6D67A}" dt="2025-07-15T02:45:05.956" v="10" actId="21"/>
-          <ac:spMkLst>
-            <pc:docMk/>
-            <pc:sldMk cId="1403429394" sldId="257"/>
-            <ac:spMk id="91" creationId="{2847A4E1-5D8A-BA47-5F8F-485D455DD114}"/>
-          </ac:spMkLst>
-        </pc:spChg>
-        <pc:spChg chg="del mod">
-          <ac:chgData name="Fatima Pillosu" userId="a6295d4dc9e22643" providerId="LiveId" clId="{B5DC09CA-6CD4-43F7-8607-5135DBD6D67A}" dt="2025-07-15T02:45:05.956" v="10" actId="21"/>
-          <ac:spMkLst>
-            <pc:docMk/>
-            <pc:sldMk cId="1403429394" sldId="257"/>
-            <ac:spMk id="92" creationId="{9A16AC1B-8EF3-92A4-CABD-D73AD244F75E}"/>
-          </ac:spMkLst>
-        </pc:spChg>
-        <pc:spChg chg="add del mod">
-          <ac:chgData name="Fatima Pillosu" userId="a6295d4dc9e22643" providerId="LiveId" clId="{B5DC09CA-6CD4-43F7-8607-5135DBD6D67A}" dt="2025-07-15T02:45:05.956" v="10" actId="21"/>
-          <ac:spMkLst>
-            <pc:docMk/>
-            <pc:sldMk cId="1403429394" sldId="257"/>
-            <ac:spMk id="93" creationId="{15B66109-5EC0-175E-124D-C46996895CE7}"/>
-          </ac:spMkLst>
-        </pc:spChg>
-        <pc:spChg chg="del mod">
-          <ac:chgData name="Fatima Pillosu" userId="a6295d4dc9e22643" providerId="LiveId" clId="{B5DC09CA-6CD4-43F7-8607-5135DBD6D67A}" dt="2025-07-15T02:45:05.956" v="10" actId="21"/>
-          <ac:spMkLst>
-            <pc:docMk/>
-            <pc:sldMk cId="1403429394" sldId="257"/>
-            <ac:spMk id="94" creationId="{376BC6E3-86E2-3737-AB80-3B95CB16E8E3}"/>
-          </ac:spMkLst>
-        </pc:spChg>
-        <pc:spChg chg="del mod">
-          <ac:chgData name="Fatima Pillosu" userId="a6295d4dc9e22643" providerId="LiveId" clId="{B5DC09CA-6CD4-43F7-8607-5135DBD6D67A}" dt="2025-07-15T02:45:05.956" v="10" actId="21"/>
-          <ac:spMkLst>
-            <pc:docMk/>
-            <pc:sldMk cId="1403429394" sldId="257"/>
-            <ac:spMk id="95" creationId="{12D385A0-4768-7304-9AF2-9662B3618F45}"/>
-          </ac:spMkLst>
-        </pc:spChg>
-        <pc:spChg chg="del mod">
-          <ac:chgData name="Fatima Pillosu" userId="a6295d4dc9e22643" providerId="LiveId" clId="{B5DC09CA-6CD4-43F7-8607-5135DBD6D67A}" dt="2025-07-15T02:45:05.956" v="10" actId="21"/>
-          <ac:spMkLst>
-            <pc:docMk/>
-            <pc:sldMk cId="1403429394" sldId="257"/>
-            <ac:spMk id="96" creationId="{57E75AC1-1794-5E7F-F1C7-E3D46F9F3C6B}"/>
-          </ac:spMkLst>
-        </pc:spChg>
-        <pc:spChg chg="del mod">
-          <ac:chgData name="Fatima Pillosu" userId="a6295d4dc9e22643" providerId="LiveId" clId="{B5DC09CA-6CD4-43F7-8607-5135DBD6D67A}" dt="2025-07-15T02:45:05.956" v="10" actId="21"/>
-          <ac:spMkLst>
-            <pc:docMk/>
-            <pc:sldMk cId="1403429394" sldId="257"/>
-            <ac:spMk id="97" creationId="{51966A53-077B-E857-FB56-6D8CABD214E0}"/>
-          </ac:spMkLst>
-        </pc:spChg>
-        <pc:spChg chg="del mod">
-          <ac:chgData name="Fatima Pillosu" userId="a6295d4dc9e22643" providerId="LiveId" clId="{B5DC09CA-6CD4-43F7-8607-5135DBD6D67A}" dt="2025-07-15T02:45:05.956" v="10" actId="21"/>
-          <ac:spMkLst>
-            <pc:docMk/>
-            <pc:sldMk cId="1403429394" sldId="257"/>
-            <ac:spMk id="98" creationId="{35DD87AC-C1BC-2933-33E1-AC551ED331CE}"/>
-          </ac:spMkLst>
-        </pc:spChg>
-        <pc:spChg chg="del mod">
-          <ac:chgData name="Fatima Pillosu" userId="a6295d4dc9e22643" providerId="LiveId" clId="{B5DC09CA-6CD4-43F7-8607-5135DBD6D67A}" dt="2025-07-15T02:45:05.956" v="10" actId="21"/>
-          <ac:spMkLst>
-            <pc:docMk/>
-            <pc:sldMk cId="1403429394" sldId="257"/>
-            <ac:spMk id="99" creationId="{75493878-E8E3-4B21-EDED-882FA025EE50}"/>
-          </ac:spMkLst>
-        </pc:spChg>
-        <pc:spChg chg="del mod">
-          <ac:chgData name="Fatima Pillosu" userId="a6295d4dc9e22643" providerId="LiveId" clId="{B5DC09CA-6CD4-43F7-8607-5135DBD6D67A}" dt="2025-07-15T02:45:05.956" v="10" actId="21"/>
-          <ac:spMkLst>
-            <pc:docMk/>
-            <pc:sldMk cId="1403429394" sldId="257"/>
-            <ac:spMk id="100" creationId="{000021FB-3D9A-C671-5BD8-5FD3D4F57EAF}"/>
-          </ac:spMkLst>
-        </pc:spChg>
-        <pc:spChg chg="del mod">
-          <ac:chgData name="Fatima Pillosu" userId="a6295d4dc9e22643" providerId="LiveId" clId="{B5DC09CA-6CD4-43F7-8607-5135DBD6D67A}" dt="2025-07-15T02:45:05.956" v="10" actId="21"/>
-          <ac:spMkLst>
-            <pc:docMk/>
-            <pc:sldMk cId="1403429394" sldId="257"/>
-            <ac:spMk id="101" creationId="{1D9A1454-C5EC-EF96-9456-6EFA68D93F96}"/>
-          </ac:spMkLst>
-        </pc:spChg>
-        <pc:spChg chg="del mod">
-          <ac:chgData name="Fatima Pillosu" userId="a6295d4dc9e22643" providerId="LiveId" clId="{B5DC09CA-6CD4-43F7-8607-5135DBD6D67A}" dt="2025-07-15T02:45:05.956" v="10" actId="21"/>
-          <ac:spMkLst>
-            <pc:docMk/>
-            <pc:sldMk cId="1403429394" sldId="257"/>
-            <ac:spMk id="102" creationId="{CE3B5F6B-A16B-67FA-B1F3-40AF319AD7BD}"/>
-          </ac:spMkLst>
-        </pc:spChg>
-        <pc:spChg chg="del mod">
-          <ac:chgData name="Fatima Pillosu" userId="a6295d4dc9e22643" providerId="LiveId" clId="{B5DC09CA-6CD4-43F7-8607-5135DBD6D67A}" dt="2025-07-15T02:45:05.956" v="10" actId="21"/>
-          <ac:spMkLst>
-            <pc:docMk/>
-            <pc:sldMk cId="1403429394" sldId="257"/>
-            <ac:spMk id="103" creationId="{3FF0EAA4-2EF5-4F38-B6EC-35ED6BE230C8}"/>
-          </ac:spMkLst>
-        </pc:spChg>
-        <pc:spChg chg="del mod">
-          <ac:chgData name="Fatima Pillosu" userId="a6295d4dc9e22643" providerId="LiveId" clId="{B5DC09CA-6CD4-43F7-8607-5135DBD6D67A}" dt="2025-07-15T02:45:05.956" v="10" actId="21"/>
-          <ac:spMkLst>
-            <pc:docMk/>
-            <pc:sldMk cId="1403429394" sldId="257"/>
-            <ac:spMk id="104" creationId="{9C0BF0B8-9ECF-FB3A-55AD-9010A6D0C88A}"/>
-          </ac:spMkLst>
-        </pc:spChg>
-        <pc:spChg chg="del mod">
-          <ac:chgData name="Fatima Pillosu" userId="a6295d4dc9e22643" providerId="LiveId" clId="{B5DC09CA-6CD4-43F7-8607-5135DBD6D67A}" dt="2025-07-15T02:45:05.956" v="10" actId="21"/>
-          <ac:spMkLst>
-            <pc:docMk/>
-            <pc:sldMk cId="1403429394" sldId="257"/>
-            <ac:spMk id="105" creationId="{B4F89EAC-F5BE-5AB3-6D3A-51942411D6AC}"/>
-          </ac:spMkLst>
-        </pc:spChg>
-        <pc:spChg chg="del mod">
-          <ac:chgData name="Fatima Pillosu" userId="a6295d4dc9e22643" providerId="LiveId" clId="{B5DC09CA-6CD4-43F7-8607-5135DBD6D67A}" dt="2025-07-15T02:45:05.956" v="10" actId="21"/>
-          <ac:spMkLst>
-            <pc:docMk/>
-            <pc:sldMk cId="1403429394" sldId="257"/>
-            <ac:spMk id="106" creationId="{4B314188-7F22-6C36-D5F3-C79B9823CCF9}"/>
-          </ac:spMkLst>
-        </pc:spChg>
-        <pc:spChg chg="del mod">
-          <ac:chgData name="Fatima Pillosu" userId="a6295d4dc9e22643" providerId="LiveId" clId="{B5DC09CA-6CD4-43F7-8607-5135DBD6D67A}" dt="2025-07-15T02:45:05.956" v="10" actId="21"/>
-          <ac:spMkLst>
-            <pc:docMk/>
-            <pc:sldMk cId="1403429394" sldId="257"/>
-            <ac:spMk id="107" creationId="{445A7559-4D19-A6F6-DA0F-D756F483D299}"/>
-          </ac:spMkLst>
-        </pc:spChg>
-        <pc:spChg chg="del mod">
-          <ac:chgData name="Fatima Pillosu" userId="a6295d4dc9e22643" providerId="LiveId" clId="{B5DC09CA-6CD4-43F7-8607-5135DBD6D67A}" dt="2025-07-15T02:45:05.956" v="10" actId="21"/>
-          <ac:spMkLst>
-            <pc:docMk/>
-            <pc:sldMk cId="1403429394" sldId="257"/>
-            <ac:spMk id="108" creationId="{A4EE99A9-33C7-3773-9DEA-E39F625A5212}"/>
-          </ac:spMkLst>
-        </pc:spChg>
-        <pc:spChg chg="del mod">
-          <ac:chgData name="Fatima Pillosu" userId="a6295d4dc9e22643" providerId="LiveId" clId="{B5DC09CA-6CD4-43F7-8607-5135DBD6D67A}" dt="2025-07-15T02:45:05.956" v="10" actId="21"/>
-          <ac:spMkLst>
-            <pc:docMk/>
-            <pc:sldMk cId="1403429394" sldId="257"/>
-            <ac:spMk id="109" creationId="{D8B522E8-1814-1FE6-CF46-055B320030EF}"/>
-          </ac:spMkLst>
-        </pc:spChg>
-        <pc:spChg chg="del mod">
-          <ac:chgData name="Fatima Pillosu" userId="a6295d4dc9e22643" providerId="LiveId" clId="{B5DC09CA-6CD4-43F7-8607-5135DBD6D67A}" dt="2025-07-15T02:45:05.956" v="10" actId="21"/>
-          <ac:spMkLst>
-            <pc:docMk/>
-            <pc:sldMk cId="1403429394" sldId="257"/>
-            <ac:spMk id="110" creationId="{F0474377-B166-9FE7-F0CD-757289DF5B18}"/>
-          </ac:spMkLst>
-        </pc:spChg>
-        <pc:spChg chg="del mod">
-          <ac:chgData name="Fatima Pillosu" userId="a6295d4dc9e22643" providerId="LiveId" clId="{B5DC09CA-6CD4-43F7-8607-5135DBD6D67A}" dt="2025-07-15T02:45:05.956" v="10" actId="21"/>
-          <ac:spMkLst>
-            <pc:docMk/>
-            <pc:sldMk cId="1403429394" sldId="257"/>
-            <ac:spMk id="111" creationId="{2EC17A87-5F98-30A0-B0E4-2CF025030731}"/>
-          </ac:spMkLst>
-        </pc:spChg>
-        <pc:spChg chg="del mod">
-          <ac:chgData name="Fatima Pillosu" userId="a6295d4dc9e22643" providerId="LiveId" clId="{B5DC09CA-6CD4-43F7-8607-5135DBD6D67A}" dt="2025-07-15T02:45:05.956" v="10" actId="21"/>
-          <ac:spMkLst>
-            <pc:docMk/>
-            <pc:sldMk cId="1403429394" sldId="257"/>
-            <ac:spMk id="112" creationId="{B449B9DC-BC6D-3397-ECEA-E2B1A14A2A1D}"/>
-          </ac:spMkLst>
-        </pc:spChg>
-        <pc:spChg chg="del mod">
-          <ac:chgData name="Fatima Pillosu" userId="a6295d4dc9e22643" providerId="LiveId" clId="{B5DC09CA-6CD4-43F7-8607-5135DBD6D67A}" dt="2025-07-15T02:45:05.956" v="10" actId="21"/>
-          <ac:spMkLst>
-            <pc:docMk/>
-            <pc:sldMk cId="1403429394" sldId="257"/>
-            <ac:spMk id="113" creationId="{F931034A-7D6F-8EA8-77FA-38D23B11D246}"/>
-          </ac:spMkLst>
-        </pc:spChg>
-        <pc:spChg chg="del mod">
-          <ac:chgData name="Fatima Pillosu" userId="a6295d4dc9e22643" providerId="LiveId" clId="{B5DC09CA-6CD4-43F7-8607-5135DBD6D67A}" dt="2025-07-15T02:45:05.956" v="10" actId="21"/>
-          <ac:spMkLst>
-            <pc:docMk/>
-            <pc:sldMk cId="1403429394" sldId="257"/>
-            <ac:spMk id="114" creationId="{4E92A261-3F68-2130-689A-A1282F999C88}"/>
-          </ac:spMkLst>
-        </pc:spChg>
-        <pc:spChg chg="del mod">
-          <ac:chgData name="Fatima Pillosu" userId="a6295d4dc9e22643" providerId="LiveId" clId="{B5DC09CA-6CD4-43F7-8607-5135DBD6D67A}" dt="2025-07-15T02:45:05.956" v="10" actId="21"/>
-          <ac:spMkLst>
-            <pc:docMk/>
-            <pc:sldMk cId="1403429394" sldId="257"/>
-            <ac:spMk id="115" creationId="{13B4ED1F-BA20-584D-160D-E72FD57F6E94}"/>
-          </ac:spMkLst>
-        </pc:spChg>
-        <pc:spChg chg="del mod">
-          <ac:chgData name="Fatima Pillosu" userId="a6295d4dc9e22643" providerId="LiveId" clId="{B5DC09CA-6CD4-43F7-8607-5135DBD6D67A}" dt="2025-07-15T02:45:05.956" v="10" actId="21"/>
-          <ac:spMkLst>
-            <pc:docMk/>
-            <pc:sldMk cId="1403429394" sldId="257"/>
-            <ac:spMk id="116" creationId="{9E17B2EA-5075-2F32-48F1-B8F79DC14C38}"/>
-          </ac:spMkLst>
-        </pc:spChg>
-        <pc:spChg chg="del mod">
-          <ac:chgData name="Fatima Pillosu" userId="a6295d4dc9e22643" providerId="LiveId" clId="{B5DC09CA-6CD4-43F7-8607-5135DBD6D67A}" dt="2025-07-15T02:45:05.956" v="10" actId="21"/>
-          <ac:spMkLst>
-            <pc:docMk/>
-            <pc:sldMk cId="1403429394" sldId="257"/>
-            <ac:spMk id="117" creationId="{3C88EA91-CBB6-2923-84E8-958EAB03D695}"/>
-          </ac:spMkLst>
-        </pc:spChg>
-        <pc:spChg chg="del mod">
-          <ac:chgData name="Fatima Pillosu" userId="a6295d4dc9e22643" providerId="LiveId" clId="{B5DC09CA-6CD4-43F7-8607-5135DBD6D67A}" dt="2025-07-15T02:45:05.956" v="10" actId="21"/>
-          <ac:spMkLst>
-            <pc:docMk/>
-            <pc:sldMk cId="1403429394" sldId="257"/>
-            <ac:spMk id="118" creationId="{398D0DBF-C0BF-0EAB-70D2-6FAFBE8D8584}"/>
-          </ac:spMkLst>
-        </pc:spChg>
-        <pc:spChg chg="del mod">
-          <ac:chgData name="Fatima Pillosu" userId="a6295d4dc9e22643" providerId="LiveId" clId="{B5DC09CA-6CD4-43F7-8607-5135DBD6D67A}" dt="2025-07-15T02:45:05.956" v="10" actId="21"/>
-          <ac:spMkLst>
-            <pc:docMk/>
-            <pc:sldMk cId="1403429394" sldId="257"/>
-            <ac:spMk id="119" creationId="{BB947B23-D613-6274-5A1A-0612C9DDC7BA}"/>
-          </ac:spMkLst>
-        </pc:spChg>
-        <pc:spChg chg="del mod">
-          <ac:chgData name="Fatima Pillosu" userId="a6295d4dc9e22643" providerId="LiveId" clId="{B5DC09CA-6CD4-43F7-8607-5135DBD6D67A}" dt="2025-07-15T02:45:05.956" v="10" actId="21"/>
-          <ac:spMkLst>
-            <pc:docMk/>
-            <pc:sldMk cId="1403429394" sldId="257"/>
-            <ac:spMk id="120" creationId="{5B5E25C5-CF55-1AD6-2F46-56FF2C9AA072}"/>
-          </ac:spMkLst>
-        </pc:spChg>
-        <pc:spChg chg="del mod">
-          <ac:chgData name="Fatima Pillosu" userId="a6295d4dc9e22643" providerId="LiveId" clId="{B5DC09CA-6CD4-43F7-8607-5135DBD6D67A}" dt="2025-07-15T02:45:05.956" v="10" actId="21"/>
-          <ac:spMkLst>
-            <pc:docMk/>
-            <pc:sldMk cId="1403429394" sldId="257"/>
-            <ac:spMk id="121" creationId="{89D57BAF-EDF7-DFF3-25C8-DBF5CA7C01E8}"/>
-          </ac:spMkLst>
-        </pc:spChg>
-        <pc:spChg chg="del mod">
-          <ac:chgData name="Fatima Pillosu" userId="a6295d4dc9e22643" providerId="LiveId" clId="{B5DC09CA-6CD4-43F7-8607-5135DBD6D67A}" dt="2025-07-15T02:45:05.956" v="10" actId="21"/>
-          <ac:spMkLst>
-            <pc:docMk/>
-            <pc:sldMk cId="1403429394" sldId="257"/>
-            <ac:spMk id="122" creationId="{2A0340DF-C636-D189-A28F-EA34AB5D27EE}"/>
-          </ac:spMkLst>
-        </pc:spChg>
-        <pc:spChg chg="del mod">
-          <ac:chgData name="Fatima Pillosu" userId="a6295d4dc9e22643" providerId="LiveId" clId="{B5DC09CA-6CD4-43F7-8607-5135DBD6D67A}" dt="2025-07-15T02:45:05.956" v="10" actId="21"/>
-          <ac:spMkLst>
-            <pc:docMk/>
-            <pc:sldMk cId="1403429394" sldId="257"/>
-            <ac:spMk id="123" creationId="{12F38479-AB54-6B30-2D3C-FF8C0302CC0C}"/>
-          </ac:spMkLst>
-        </pc:spChg>
-        <pc:spChg chg="del mod">
-          <ac:chgData name="Fatima Pillosu" userId="a6295d4dc9e22643" providerId="LiveId" clId="{B5DC09CA-6CD4-43F7-8607-5135DBD6D67A}" dt="2025-07-15T02:45:05.956" v="10" actId="21"/>
-          <ac:spMkLst>
-            <pc:docMk/>
-            <pc:sldMk cId="1403429394" sldId="257"/>
-            <ac:spMk id="124" creationId="{F814593F-D80C-3FAD-DC51-3489C5EF4A97}"/>
-          </ac:spMkLst>
-        </pc:spChg>
-        <pc:picChg chg="add mod">
-          <ac:chgData name="Fatima Pillosu" userId="a6295d4dc9e22643" providerId="LiveId" clId="{B5DC09CA-6CD4-43F7-8607-5135DBD6D67A}" dt="2025-07-15T02:45:25.851" v="19" actId="1036"/>
-          <ac:picMkLst>
-            <pc:docMk/>
-            <pc:sldMk cId="1403429394" sldId="257"/>
-            <ac:picMk id="4" creationId="{4188A312-931C-A96B-9DBB-485DE2DA9003}"/>
-          </ac:picMkLst>
-        </pc:picChg>
-        <pc:picChg chg="del mod">
-          <ac:chgData name="Fatima Pillosu" userId="a6295d4dc9e22643" providerId="LiveId" clId="{B5DC09CA-6CD4-43F7-8607-5135DBD6D67A}" dt="2025-07-15T02:45:05.956" v="10" actId="21"/>
-          <ac:picMkLst>
-            <pc:docMk/>
-            <pc:sldMk cId="1403429394" sldId="257"/>
-            <ac:picMk id="5" creationId="{4188A312-931C-A96B-9DBB-485DE2DA9003}"/>
-          </ac:picMkLst>
-        </pc:picChg>
-        <pc:picChg chg="add mod">
-          <ac:chgData name="Fatima Pillosu" userId="a6295d4dc9e22643" providerId="LiveId" clId="{B5DC09CA-6CD4-43F7-8607-5135DBD6D67A}" dt="2025-07-15T02:45:25.851" v="19" actId="1036"/>
-          <ac:picMkLst>
-            <pc:docMk/>
-            <pc:sldMk cId="1403429394" sldId="257"/>
-            <ac:picMk id="6" creationId="{7A99A4F9-239E-6C7F-B1CE-EE9C66D59500}"/>
-          </ac:picMkLst>
-        </pc:picChg>
-        <pc:picChg chg="del mod">
-          <ac:chgData name="Fatima Pillosu" userId="a6295d4dc9e22643" providerId="LiveId" clId="{B5DC09CA-6CD4-43F7-8607-5135DBD6D67A}" dt="2025-07-15T02:45:05.956" v="10" actId="21"/>
-          <ac:picMkLst>
-            <pc:docMk/>
-            <pc:sldMk cId="1403429394" sldId="257"/>
-            <ac:picMk id="7" creationId="{7A99A4F9-239E-6C7F-B1CE-EE9C66D59500}"/>
-          </ac:picMkLst>
-        </pc:picChg>
-        <pc:picChg chg="add mod">
-          <ac:chgData name="Fatima Pillosu" userId="a6295d4dc9e22643" providerId="LiveId" clId="{B5DC09CA-6CD4-43F7-8607-5135DBD6D67A}" dt="2025-07-15T02:45:25.851" v="19" actId="1036"/>
-          <ac:picMkLst>
-            <pc:docMk/>
-            <pc:sldMk cId="1403429394" sldId="257"/>
-            <ac:picMk id="8" creationId="{FD73FFD3-BDBE-202C-40CA-4F1E3FA747C9}"/>
-          </ac:picMkLst>
-        </pc:picChg>
-        <pc:picChg chg="del mod">
-          <ac:chgData name="Fatima Pillosu" userId="a6295d4dc9e22643" providerId="LiveId" clId="{B5DC09CA-6CD4-43F7-8607-5135DBD6D67A}" dt="2025-07-15T02:45:05.956" v="10" actId="21"/>
-          <ac:picMkLst>
-            <pc:docMk/>
-            <pc:sldMk cId="1403429394" sldId="257"/>
-            <ac:picMk id="9" creationId="{FD73FFD3-BDBE-202C-40CA-4F1E3FA747C9}"/>
-          </ac:picMkLst>
-        </pc:picChg>
-        <pc:picChg chg="add mod">
-          <ac:chgData name="Fatima Pillosu" userId="a6295d4dc9e22643" providerId="LiveId" clId="{B5DC09CA-6CD4-43F7-8607-5135DBD6D67A}" dt="2025-07-15T02:45:25.851" v="19" actId="1036"/>
-          <ac:picMkLst>
-            <pc:docMk/>
-            <pc:sldMk cId="1403429394" sldId="257"/>
-            <ac:picMk id="10" creationId="{1E8DAAC5-8433-D72E-639E-5B9BA3EDE766}"/>
-          </ac:picMkLst>
-        </pc:picChg>
-        <pc:picChg chg="del mod">
-          <ac:chgData name="Fatima Pillosu" userId="a6295d4dc9e22643" providerId="LiveId" clId="{B5DC09CA-6CD4-43F7-8607-5135DBD6D67A}" dt="2025-07-15T02:45:05.956" v="10" actId="21"/>
-          <ac:picMkLst>
-            <pc:docMk/>
-            <pc:sldMk cId="1403429394" sldId="257"/>
-            <ac:picMk id="11" creationId="{1E8DAAC5-8433-D72E-639E-5B9BA3EDE766}"/>
-          </ac:picMkLst>
-        </pc:picChg>
-        <pc:picChg chg="add mod">
-          <ac:chgData name="Fatima Pillosu" userId="a6295d4dc9e22643" providerId="LiveId" clId="{B5DC09CA-6CD4-43F7-8607-5135DBD6D67A}" dt="2025-07-15T02:45:25.851" v="19" actId="1036"/>
-          <ac:picMkLst>
-            <pc:docMk/>
-            <pc:sldMk cId="1403429394" sldId="257"/>
-            <ac:picMk id="12" creationId="{585070D7-CA3A-502D-4DA3-91F14EC700AB}"/>
-          </ac:picMkLst>
-        </pc:picChg>
-        <pc:picChg chg="del mod">
-          <ac:chgData name="Fatima Pillosu" userId="a6295d4dc9e22643" providerId="LiveId" clId="{B5DC09CA-6CD4-43F7-8607-5135DBD6D67A}" dt="2025-07-15T02:45:05.956" v="10" actId="21"/>
-          <ac:picMkLst>
-            <pc:docMk/>
-            <pc:sldMk cId="1403429394" sldId="257"/>
-            <ac:picMk id="13" creationId="{585070D7-CA3A-502D-4DA3-91F14EC700AB}"/>
-          </ac:picMkLst>
-        </pc:picChg>
-        <pc:picChg chg="add mod">
-          <ac:chgData name="Fatima Pillosu" userId="a6295d4dc9e22643" providerId="LiveId" clId="{B5DC09CA-6CD4-43F7-8607-5135DBD6D67A}" dt="2025-07-15T02:45:25.851" v="19" actId="1036"/>
-          <ac:picMkLst>
-            <pc:docMk/>
-            <pc:sldMk cId="1403429394" sldId="257"/>
-            <ac:picMk id="14" creationId="{4F9EDECB-B740-CAEE-DF03-9FF71FFF59EA}"/>
-          </ac:picMkLst>
-        </pc:picChg>
-        <pc:picChg chg="del mod">
-          <ac:chgData name="Fatima Pillosu" userId="a6295d4dc9e22643" providerId="LiveId" clId="{B5DC09CA-6CD4-43F7-8607-5135DBD6D67A}" dt="2025-07-15T02:45:05.956" v="10" actId="21"/>
-          <ac:picMkLst>
-            <pc:docMk/>
-            <pc:sldMk cId="1403429394" sldId="257"/>
-            <ac:picMk id="15" creationId="{4F9EDECB-B740-CAEE-DF03-9FF71FFF59EA}"/>
-          </ac:picMkLst>
-        </pc:picChg>
-        <pc:picChg chg="add mod">
-          <ac:chgData name="Fatima Pillosu" userId="a6295d4dc9e22643" providerId="LiveId" clId="{B5DC09CA-6CD4-43F7-8607-5135DBD6D67A}" dt="2025-07-15T02:45:25.851" v="19" actId="1036"/>
-          <ac:picMkLst>
-            <pc:docMk/>
-            <pc:sldMk cId="1403429394" sldId="257"/>
-            <ac:picMk id="16" creationId="{5A07DFD8-3E71-3163-27C2-16BEB825E58F}"/>
-          </ac:picMkLst>
-        </pc:picChg>
-        <pc:picChg chg="del mod">
-          <ac:chgData name="Fatima Pillosu" userId="a6295d4dc9e22643" providerId="LiveId" clId="{B5DC09CA-6CD4-43F7-8607-5135DBD6D67A}" dt="2025-07-15T02:45:05.956" v="10" actId="21"/>
-          <ac:picMkLst>
-            <pc:docMk/>
-            <pc:sldMk cId="1403429394" sldId="257"/>
-            <ac:picMk id="69" creationId="{5A07DFD8-3E71-3163-27C2-16BEB825E58F}"/>
-          </ac:picMkLst>
-        </pc:picChg>
-      </pc:sldChg>
-    </pc:docChg>
-  </pc:docChgLst>
-  <pc:docChgLst>
-    <pc:chgData name="Fatima Pillosu" userId="a6295d4dc9e22643" providerId="LiveId" clId="{9A2B42D9-F292-4BF4-BB93-D16CACD71501}"/>
-    <pc:docChg chg="custSel delSld modSld">
-      <pc:chgData name="Fatima Pillosu" userId="a6295d4dc9e22643" providerId="LiveId" clId="{9A2B42D9-F292-4BF4-BB93-D16CACD71501}" dt="2025-06-10T16:09:00.221" v="13" actId="47"/>
-      <pc:docMkLst>
-        <pc:docMk/>
-      </pc:docMkLst>
-      <pc:sldChg chg="del">
-        <pc:chgData name="Fatima Pillosu" userId="a6295d4dc9e22643" providerId="LiveId" clId="{9A2B42D9-F292-4BF4-BB93-D16CACD71501}" dt="2025-06-10T16:09:00.221" v="13" actId="47"/>
-        <pc:sldMkLst>
-          <pc:docMk/>
-          <pc:sldMk cId="605037563" sldId="256"/>
-        </pc:sldMkLst>
-      </pc:sldChg>
-      <pc:sldChg chg="addSp delSp modSp mod">
-        <pc:chgData name="Fatima Pillosu" userId="a6295d4dc9e22643" providerId="LiveId" clId="{9A2B42D9-F292-4BF4-BB93-D16CACD71501}" dt="2025-06-10T16:04:27.750" v="12" actId="554"/>
-        <pc:sldMkLst>
-          <pc:docMk/>
-          <pc:sldMk cId="1403429394" sldId="257"/>
-        </pc:sldMkLst>
-        <pc:spChg chg="del">
-          <ac:chgData name="Fatima Pillosu" userId="a6295d4dc9e22643" providerId="LiveId" clId="{9A2B42D9-F292-4BF4-BB93-D16CACD71501}" dt="2025-06-10T16:03:05.604" v="3" actId="21"/>
-          <ac:spMkLst>
-            <pc:docMk/>
-            <pc:sldMk cId="1403429394" sldId="257"/>
-            <ac:spMk id="5" creationId="{082CB828-3055-C01D-1D9B-34D32699459C}"/>
-          </ac:spMkLst>
-        </pc:spChg>
-        <pc:spChg chg="del">
-          <ac:chgData name="Fatima Pillosu" userId="a6295d4dc9e22643" providerId="LiveId" clId="{9A2B42D9-F292-4BF4-BB93-D16CACD71501}" dt="2025-06-10T16:03:05.604" v="3" actId="21"/>
-          <ac:spMkLst>
-            <pc:docMk/>
-            <pc:sldMk cId="1403429394" sldId="257"/>
-            <ac:spMk id="6" creationId="{26462B98-3F43-7391-382E-5FA37001F70A}"/>
-          </ac:spMkLst>
-        </pc:spChg>
-        <pc:spChg chg="del">
-          <ac:chgData name="Fatima Pillosu" userId="a6295d4dc9e22643" providerId="LiveId" clId="{9A2B42D9-F292-4BF4-BB93-D16CACD71501}" dt="2025-06-10T16:03:05.604" v="3" actId="21"/>
-          <ac:spMkLst>
-            <pc:docMk/>
-            <pc:sldMk cId="1403429394" sldId="257"/>
-            <ac:spMk id="7" creationId="{FB1D83BF-C5B8-0F42-ACF1-801724C77646}"/>
-          </ac:spMkLst>
-        </pc:spChg>
-        <pc:spChg chg="del">
-          <ac:chgData name="Fatima Pillosu" userId="a6295d4dc9e22643" providerId="LiveId" clId="{9A2B42D9-F292-4BF4-BB93-D16CACD71501}" dt="2025-06-10T16:03:05.604" v="3" actId="21"/>
-          <ac:spMkLst>
-            <pc:docMk/>
-            <pc:sldMk cId="1403429394" sldId="257"/>
-            <ac:spMk id="8" creationId="{EFB51189-ED1C-9467-A21E-04098224201A}"/>
-          </ac:spMkLst>
-        </pc:spChg>
-        <pc:spChg chg="del">
-          <ac:chgData name="Fatima Pillosu" userId="a6295d4dc9e22643" providerId="LiveId" clId="{9A2B42D9-F292-4BF4-BB93-D16CACD71501}" dt="2025-06-10T16:03:05.604" v="3" actId="21"/>
-          <ac:spMkLst>
-            <pc:docMk/>
-            <pc:sldMk cId="1403429394" sldId="257"/>
-            <ac:spMk id="9" creationId="{21C332B9-C99D-6C2F-F7A7-D75A6499E176}"/>
-          </ac:spMkLst>
-        </pc:spChg>
-        <pc:spChg chg="del">
-          <ac:chgData name="Fatima Pillosu" userId="a6295d4dc9e22643" providerId="LiveId" clId="{9A2B42D9-F292-4BF4-BB93-D16CACD71501}" dt="2025-06-10T16:03:05.604" v="3" actId="21"/>
-          <ac:spMkLst>
-            <pc:docMk/>
-            <pc:sldMk cId="1403429394" sldId="257"/>
-            <ac:spMk id="10" creationId="{88809429-C163-FEA9-654A-C938A20C2ED1}"/>
-          </ac:spMkLst>
-        </pc:spChg>
-        <pc:spChg chg="del">
-          <ac:chgData name="Fatima Pillosu" userId="a6295d4dc9e22643" providerId="LiveId" clId="{9A2B42D9-F292-4BF4-BB93-D16CACD71501}" dt="2025-06-10T16:03:05.604" v="3" actId="21"/>
-          <ac:spMkLst>
-            <pc:docMk/>
-            <pc:sldMk cId="1403429394" sldId="257"/>
-            <ac:spMk id="11" creationId="{64A6DF9F-4002-0BE8-0275-A7A7B18AE50E}"/>
-          </ac:spMkLst>
-        </pc:spChg>
-        <pc:spChg chg="del">
-          <ac:chgData name="Fatima Pillosu" userId="a6295d4dc9e22643" providerId="LiveId" clId="{9A2B42D9-F292-4BF4-BB93-D16CACD71501}" dt="2025-06-10T16:03:05.604" v="3" actId="21"/>
-          <ac:spMkLst>
-            <pc:docMk/>
-            <pc:sldMk cId="1403429394" sldId="257"/>
-            <ac:spMk id="12" creationId="{FBF4F939-D8E0-4CA6-4395-BE2703ED47D3}"/>
-          </ac:spMkLst>
-        </pc:spChg>
-        <pc:spChg chg="del">
-          <ac:chgData name="Fatima Pillosu" userId="a6295d4dc9e22643" providerId="LiveId" clId="{9A2B42D9-F292-4BF4-BB93-D16CACD71501}" dt="2025-06-10T16:03:05.604" v="3" actId="21"/>
-          <ac:spMkLst>
-            <pc:docMk/>
-            <pc:sldMk cId="1403429394" sldId="257"/>
-            <ac:spMk id="13" creationId="{9886A46A-5F0E-29C0-5553-F3C415C39030}"/>
-          </ac:spMkLst>
-        </pc:spChg>
-        <pc:spChg chg="del">
-          <ac:chgData name="Fatima Pillosu" userId="a6295d4dc9e22643" providerId="LiveId" clId="{9A2B42D9-F292-4BF4-BB93-D16CACD71501}" dt="2025-06-10T16:03:05.604" v="3" actId="21"/>
-          <ac:spMkLst>
-            <pc:docMk/>
-            <pc:sldMk cId="1403429394" sldId="257"/>
-            <ac:spMk id="14" creationId="{DD731501-A656-7957-75AF-86B51CC75396}"/>
-          </ac:spMkLst>
-        </pc:spChg>
-        <pc:spChg chg="del">
-          <ac:chgData name="Fatima Pillosu" userId="a6295d4dc9e22643" providerId="LiveId" clId="{9A2B42D9-F292-4BF4-BB93-D16CACD71501}" dt="2025-06-10T16:03:05.604" v="3" actId="21"/>
-          <ac:spMkLst>
-            <pc:docMk/>
-            <pc:sldMk cId="1403429394" sldId="257"/>
-            <ac:spMk id="15" creationId="{DE08B4AE-3720-60F1-D6B9-743C32AD6707}"/>
-          </ac:spMkLst>
-        </pc:spChg>
-        <pc:spChg chg="del">
-          <ac:chgData name="Fatima Pillosu" userId="a6295d4dc9e22643" providerId="LiveId" clId="{9A2B42D9-F292-4BF4-BB93-D16CACD71501}" dt="2025-06-10T16:03:05.604" v="3" actId="21"/>
-          <ac:spMkLst>
-            <pc:docMk/>
-            <pc:sldMk cId="1403429394" sldId="257"/>
-            <ac:spMk id="16" creationId="{9C4F17D1-D949-02CB-0B46-48106B0B393C}"/>
-          </ac:spMkLst>
-        </pc:spChg>
-        <pc:spChg chg="del">
-          <ac:chgData name="Fatima Pillosu" userId="a6295d4dc9e22643" providerId="LiveId" clId="{9A2B42D9-F292-4BF4-BB93-D16CACD71501}" dt="2025-06-10T16:03:05.604" v="3" actId="21"/>
-          <ac:spMkLst>
-            <pc:docMk/>
-            <pc:sldMk cId="1403429394" sldId="257"/>
-            <ac:spMk id="17" creationId="{455A54B8-5CD9-B620-BC08-5F6DA9DF0ED8}"/>
-          </ac:spMkLst>
-        </pc:spChg>
-        <pc:spChg chg="del">
-          <ac:chgData name="Fatima Pillosu" userId="a6295d4dc9e22643" providerId="LiveId" clId="{9A2B42D9-F292-4BF4-BB93-D16CACD71501}" dt="2025-06-10T16:03:05.604" v="3" actId="21"/>
-          <ac:spMkLst>
-            <pc:docMk/>
-            <pc:sldMk cId="1403429394" sldId="257"/>
-            <ac:spMk id="18" creationId="{55890E00-81A3-E28D-C052-5E4FA9603339}"/>
-          </ac:spMkLst>
-        </pc:spChg>
-        <pc:spChg chg="del">
-          <ac:chgData name="Fatima Pillosu" userId="a6295d4dc9e22643" providerId="LiveId" clId="{9A2B42D9-F292-4BF4-BB93-D16CACD71501}" dt="2025-06-10T16:03:05.604" v="3" actId="21"/>
-          <ac:spMkLst>
-            <pc:docMk/>
-            <pc:sldMk cId="1403429394" sldId="257"/>
-            <ac:spMk id="19" creationId="{D22BC35C-D8BA-9C47-5E36-D7A2E39E7940}"/>
-          </ac:spMkLst>
-        </pc:spChg>
-        <pc:spChg chg="del">
-          <ac:chgData name="Fatima Pillosu" userId="a6295d4dc9e22643" providerId="LiveId" clId="{9A2B42D9-F292-4BF4-BB93-D16CACD71501}" dt="2025-06-10T16:03:05.604" v="3" actId="21"/>
-          <ac:spMkLst>
-            <pc:docMk/>
-            <pc:sldMk cId="1403429394" sldId="257"/>
-            <ac:spMk id="20" creationId="{2847A4E1-5D8A-BA47-5F8F-485D455DD114}"/>
-          </ac:spMkLst>
-        </pc:spChg>
-        <pc:spChg chg="del">
-          <ac:chgData name="Fatima Pillosu" userId="a6295d4dc9e22643" providerId="LiveId" clId="{9A2B42D9-F292-4BF4-BB93-D16CACD71501}" dt="2025-06-10T16:03:05.604" v="3" actId="21"/>
-          <ac:spMkLst>
-            <pc:docMk/>
-            <pc:sldMk cId="1403429394" sldId="257"/>
-            <ac:spMk id="21" creationId="{9A16AC1B-8EF3-92A4-CABD-D73AD244F75E}"/>
-          </ac:spMkLst>
-        </pc:spChg>
-        <pc:spChg chg="del mod">
-          <ac:chgData name="Fatima Pillosu" userId="a6295d4dc9e22643" providerId="LiveId" clId="{9A2B42D9-F292-4BF4-BB93-D16CACD71501}" dt="2025-06-10T16:03:05.604" v="3" actId="21"/>
-          <ac:spMkLst>
-            <pc:docMk/>
-            <pc:sldMk cId="1403429394" sldId="257"/>
-            <ac:spMk id="22" creationId="{15B66109-5EC0-175E-124D-C46996895CE7}"/>
-          </ac:spMkLst>
-        </pc:spChg>
-        <pc:spChg chg="del">
-          <ac:chgData name="Fatima Pillosu" userId="a6295d4dc9e22643" providerId="LiveId" clId="{9A2B42D9-F292-4BF4-BB93-D16CACD71501}" dt="2025-06-10T16:03:05.604" v="3" actId="21"/>
-          <ac:spMkLst>
-            <pc:docMk/>
-            <pc:sldMk cId="1403429394" sldId="257"/>
-            <ac:spMk id="23" creationId="{376BC6E3-86E2-3737-AB80-3B95CB16E8E3}"/>
-          </ac:spMkLst>
-        </pc:spChg>
-        <pc:spChg chg="del">
-          <ac:chgData name="Fatima Pillosu" userId="a6295d4dc9e22643" providerId="LiveId" clId="{9A2B42D9-F292-4BF4-BB93-D16CACD71501}" dt="2025-06-10T16:03:05.604" v="3" actId="21"/>
-          <ac:spMkLst>
-            <pc:docMk/>
-            <pc:sldMk cId="1403429394" sldId="257"/>
-            <ac:spMk id="24" creationId="{12D385A0-4768-7304-9AF2-9662B3618F45}"/>
-          </ac:spMkLst>
-        </pc:spChg>
-        <pc:spChg chg="del">
-          <ac:chgData name="Fatima Pillosu" userId="a6295d4dc9e22643" providerId="LiveId" clId="{9A2B42D9-F292-4BF4-BB93-D16CACD71501}" dt="2025-06-10T16:03:05.604" v="3" actId="21"/>
-          <ac:spMkLst>
-            <pc:docMk/>
-            <pc:sldMk cId="1403429394" sldId="257"/>
-            <ac:spMk id="25" creationId="{57E75AC1-1794-5E7F-F1C7-E3D46F9F3C6B}"/>
-          </ac:spMkLst>
-        </pc:spChg>
-        <pc:spChg chg="del">
-          <ac:chgData name="Fatima Pillosu" userId="a6295d4dc9e22643" providerId="LiveId" clId="{9A2B42D9-F292-4BF4-BB93-D16CACD71501}" dt="2025-06-10T16:03:05.604" v="3" actId="21"/>
-          <ac:spMkLst>
-            <pc:docMk/>
-            <pc:sldMk cId="1403429394" sldId="257"/>
-            <ac:spMk id="26" creationId="{51966A53-077B-E857-FB56-6D8CABD214E0}"/>
-          </ac:spMkLst>
-        </pc:spChg>
-        <pc:spChg chg="del">
-          <ac:chgData name="Fatima Pillosu" userId="a6295d4dc9e22643" providerId="LiveId" clId="{9A2B42D9-F292-4BF4-BB93-D16CACD71501}" dt="2025-06-10T16:03:05.604" v="3" actId="21"/>
-          <ac:spMkLst>
-            <pc:docMk/>
-            <pc:sldMk cId="1403429394" sldId="257"/>
-            <ac:spMk id="27" creationId="{35DD87AC-C1BC-2933-33E1-AC551ED331CE}"/>
-          </ac:spMkLst>
-        </pc:spChg>
-        <pc:spChg chg="del">
-          <ac:chgData name="Fatima Pillosu" userId="a6295d4dc9e22643" providerId="LiveId" clId="{9A2B42D9-F292-4BF4-BB93-D16CACD71501}" dt="2025-06-10T16:03:05.604" v="3" actId="21"/>
-          <ac:spMkLst>
-            <pc:docMk/>
-            <pc:sldMk cId="1403429394" sldId="257"/>
-            <ac:spMk id="28" creationId="{75493878-E8E3-4B21-EDED-882FA025EE50}"/>
-          </ac:spMkLst>
-        </pc:spChg>
-        <pc:spChg chg="del">
-          <ac:chgData name="Fatima Pillosu" userId="a6295d4dc9e22643" providerId="LiveId" clId="{9A2B42D9-F292-4BF4-BB93-D16CACD71501}" dt="2025-06-10T16:03:05.604" v="3" actId="21"/>
-          <ac:spMkLst>
-            <pc:docMk/>
-            <pc:sldMk cId="1403429394" sldId="257"/>
-            <ac:spMk id="29" creationId="{000021FB-3D9A-C671-5BD8-5FD3D4F57EAF}"/>
-          </ac:spMkLst>
-        </pc:spChg>
-        <pc:spChg chg="del">
-          <ac:chgData name="Fatima Pillosu" userId="a6295d4dc9e22643" providerId="LiveId" clId="{9A2B42D9-F292-4BF4-BB93-D16CACD71501}" dt="2025-06-10T16:03:05.604" v="3" actId="21"/>
-          <ac:spMkLst>
-            <pc:docMk/>
-            <pc:sldMk cId="1403429394" sldId="257"/>
-            <ac:spMk id="36" creationId="{1D9A1454-C5EC-EF96-9456-6EFA68D93F96}"/>
-          </ac:spMkLst>
-        </pc:spChg>
-        <pc:spChg chg="del">
-          <ac:chgData name="Fatima Pillosu" userId="a6295d4dc9e22643" providerId="LiveId" clId="{9A2B42D9-F292-4BF4-BB93-D16CACD71501}" dt="2025-06-10T16:03:05.604" v="3" actId="21"/>
-          <ac:spMkLst>
-            <pc:docMk/>
-            <pc:sldMk cId="1403429394" sldId="257"/>
-            <ac:spMk id="37" creationId="{CE3B5F6B-A16B-67FA-B1F3-40AF319AD7BD}"/>
-          </ac:spMkLst>
-        </pc:spChg>
-        <pc:spChg chg="del">
-          <ac:chgData name="Fatima Pillosu" userId="a6295d4dc9e22643" providerId="LiveId" clId="{9A2B42D9-F292-4BF4-BB93-D16CACD71501}" dt="2025-06-10T16:03:05.604" v="3" actId="21"/>
-          <ac:spMkLst>
-            <pc:docMk/>
-            <pc:sldMk cId="1403429394" sldId="257"/>
-            <ac:spMk id="38" creationId="{3FF0EAA4-2EF5-4F38-B6EC-35ED6BE230C8}"/>
-          </ac:spMkLst>
-        </pc:spChg>
-        <pc:spChg chg="del">
-          <ac:chgData name="Fatima Pillosu" userId="a6295d4dc9e22643" providerId="LiveId" clId="{9A2B42D9-F292-4BF4-BB93-D16CACD71501}" dt="2025-06-10T16:03:05.604" v="3" actId="21"/>
-          <ac:spMkLst>
-            <pc:docMk/>
-            <pc:sldMk cId="1403429394" sldId="257"/>
-            <ac:spMk id="39" creationId="{9C0BF0B8-9ECF-FB3A-55AD-9010A6D0C88A}"/>
-          </ac:spMkLst>
-        </pc:spChg>
-        <pc:spChg chg="del">
-          <ac:chgData name="Fatima Pillosu" userId="a6295d4dc9e22643" providerId="LiveId" clId="{9A2B42D9-F292-4BF4-BB93-D16CACD71501}" dt="2025-06-10T16:03:05.604" v="3" actId="21"/>
-          <ac:spMkLst>
-            <pc:docMk/>
-            <pc:sldMk cId="1403429394" sldId="257"/>
-            <ac:spMk id="40" creationId="{B4F89EAC-F5BE-5AB3-6D3A-51942411D6AC}"/>
-          </ac:spMkLst>
-        </pc:spChg>
-        <pc:spChg chg="del">
-          <ac:chgData name="Fatima Pillosu" userId="a6295d4dc9e22643" providerId="LiveId" clId="{9A2B42D9-F292-4BF4-BB93-D16CACD71501}" dt="2025-06-10T16:03:05.604" v="3" actId="21"/>
-          <ac:spMkLst>
-            <pc:docMk/>
-            <pc:sldMk cId="1403429394" sldId="257"/>
-            <ac:spMk id="41" creationId="{4B314188-7F22-6C36-D5F3-C79B9823CCF9}"/>
-          </ac:spMkLst>
-        </pc:spChg>
-        <pc:spChg chg="del">
-          <ac:chgData name="Fatima Pillosu" userId="a6295d4dc9e22643" providerId="LiveId" clId="{9A2B42D9-F292-4BF4-BB93-D16CACD71501}" dt="2025-06-10T16:03:05.604" v="3" actId="21"/>
-          <ac:spMkLst>
-            <pc:docMk/>
-            <pc:sldMk cId="1403429394" sldId="257"/>
-            <ac:spMk id="42" creationId="{445A7559-4D19-A6F6-DA0F-D756F483D299}"/>
-          </ac:spMkLst>
-        </pc:spChg>
-        <pc:spChg chg="del">
-          <ac:chgData name="Fatima Pillosu" userId="a6295d4dc9e22643" providerId="LiveId" clId="{9A2B42D9-F292-4BF4-BB93-D16CACD71501}" dt="2025-06-10T16:03:05.604" v="3" actId="21"/>
-          <ac:spMkLst>
-            <pc:docMk/>
-            <pc:sldMk cId="1403429394" sldId="257"/>
-            <ac:spMk id="43" creationId="{A4EE99A9-33C7-3773-9DEA-E39F625A5212}"/>
-          </ac:spMkLst>
-        </pc:spChg>
-        <pc:spChg chg="del">
-          <ac:chgData name="Fatima Pillosu" userId="a6295d4dc9e22643" providerId="LiveId" clId="{9A2B42D9-F292-4BF4-BB93-D16CACD71501}" dt="2025-06-10T16:03:05.604" v="3" actId="21"/>
-          <ac:spMkLst>
-            <pc:docMk/>
-            <pc:sldMk cId="1403429394" sldId="257"/>
-            <ac:spMk id="44" creationId="{D8B522E8-1814-1FE6-CF46-055B320030EF}"/>
-          </ac:spMkLst>
-        </pc:spChg>
-        <pc:spChg chg="del">
-          <ac:chgData name="Fatima Pillosu" userId="a6295d4dc9e22643" providerId="LiveId" clId="{9A2B42D9-F292-4BF4-BB93-D16CACD71501}" dt="2025-06-10T16:03:05.604" v="3" actId="21"/>
-          <ac:spMkLst>
-            <pc:docMk/>
-            <pc:sldMk cId="1403429394" sldId="257"/>
-            <ac:spMk id="53" creationId="{F0474377-B166-9FE7-F0CD-757289DF5B18}"/>
-          </ac:spMkLst>
-        </pc:spChg>
-        <pc:spChg chg="del">
-          <ac:chgData name="Fatima Pillosu" userId="a6295d4dc9e22643" providerId="LiveId" clId="{9A2B42D9-F292-4BF4-BB93-D16CACD71501}" dt="2025-06-10T16:03:05.604" v="3" actId="21"/>
-          <ac:spMkLst>
-            <pc:docMk/>
-            <pc:sldMk cId="1403429394" sldId="257"/>
-            <ac:spMk id="54" creationId="{2EC17A87-5F98-30A0-B0E4-2CF025030731}"/>
-          </ac:spMkLst>
-        </pc:spChg>
-        <pc:spChg chg="del">
-          <ac:chgData name="Fatima Pillosu" userId="a6295d4dc9e22643" providerId="LiveId" clId="{9A2B42D9-F292-4BF4-BB93-D16CACD71501}" dt="2025-06-10T16:03:05.604" v="3" actId="21"/>
-          <ac:spMkLst>
-            <pc:docMk/>
-            <pc:sldMk cId="1403429394" sldId="257"/>
-            <ac:spMk id="55" creationId="{B449B9DC-BC6D-3397-ECEA-E2B1A14A2A1D}"/>
-          </ac:spMkLst>
-        </pc:spChg>
-        <pc:spChg chg="del">
-          <ac:chgData name="Fatima Pillosu" userId="a6295d4dc9e22643" providerId="LiveId" clId="{9A2B42D9-F292-4BF4-BB93-D16CACD71501}" dt="2025-06-10T16:03:05.604" v="3" actId="21"/>
-          <ac:spMkLst>
-            <pc:docMk/>
-            <pc:sldMk cId="1403429394" sldId="257"/>
-            <ac:spMk id="56" creationId="{F931034A-7D6F-8EA8-77FA-38D23B11D246}"/>
-          </ac:spMkLst>
-        </pc:spChg>
-        <pc:spChg chg="del">
-          <ac:chgData name="Fatima Pillosu" userId="a6295d4dc9e22643" providerId="LiveId" clId="{9A2B42D9-F292-4BF4-BB93-D16CACD71501}" dt="2025-06-10T16:03:05.604" v="3" actId="21"/>
-          <ac:spMkLst>
-            <pc:docMk/>
-            <pc:sldMk cId="1403429394" sldId="257"/>
-            <ac:spMk id="57" creationId="{4E92A261-3F68-2130-689A-A1282F999C88}"/>
-          </ac:spMkLst>
-        </pc:spChg>
-        <pc:spChg chg="del">
-          <ac:chgData name="Fatima Pillosu" userId="a6295d4dc9e22643" providerId="LiveId" clId="{9A2B42D9-F292-4BF4-BB93-D16CACD71501}" dt="2025-06-10T16:03:05.604" v="3" actId="21"/>
-          <ac:spMkLst>
-            <pc:docMk/>
-            <pc:sldMk cId="1403429394" sldId="257"/>
-            <ac:spMk id="58" creationId="{13B4ED1F-BA20-584D-160D-E72FD57F6E94}"/>
-          </ac:spMkLst>
-        </pc:spChg>
-        <pc:spChg chg="del">
-          <ac:chgData name="Fatima Pillosu" userId="a6295d4dc9e22643" providerId="LiveId" clId="{9A2B42D9-F292-4BF4-BB93-D16CACD71501}" dt="2025-06-10T16:03:05.604" v="3" actId="21"/>
-          <ac:spMkLst>
-            <pc:docMk/>
-            <pc:sldMk cId="1403429394" sldId="257"/>
-            <ac:spMk id="59" creationId="{9E17B2EA-5075-2F32-48F1-B8F79DC14C38}"/>
-          </ac:spMkLst>
-        </pc:spChg>
-        <pc:spChg chg="del">
-          <ac:chgData name="Fatima Pillosu" userId="a6295d4dc9e22643" providerId="LiveId" clId="{9A2B42D9-F292-4BF4-BB93-D16CACD71501}" dt="2025-06-10T16:03:05.604" v="3" actId="21"/>
-          <ac:spMkLst>
-            <pc:docMk/>
-            <pc:sldMk cId="1403429394" sldId="257"/>
-            <ac:spMk id="60" creationId="{3C88EA91-CBB6-2923-84E8-958EAB03D695}"/>
-          </ac:spMkLst>
-        </pc:spChg>
-        <pc:spChg chg="del">
-          <ac:chgData name="Fatima Pillosu" userId="a6295d4dc9e22643" providerId="LiveId" clId="{9A2B42D9-F292-4BF4-BB93-D16CACD71501}" dt="2025-06-10T16:03:05.604" v="3" actId="21"/>
-          <ac:spMkLst>
-            <pc:docMk/>
-            <pc:sldMk cId="1403429394" sldId="257"/>
-            <ac:spMk id="61" creationId="{398D0DBF-C0BF-0EAB-70D2-6FAFBE8D8584}"/>
-          </ac:spMkLst>
-        </pc:spChg>
-        <pc:spChg chg="del">
-          <ac:chgData name="Fatima Pillosu" userId="a6295d4dc9e22643" providerId="LiveId" clId="{9A2B42D9-F292-4BF4-BB93-D16CACD71501}" dt="2025-06-10T16:03:05.604" v="3" actId="21"/>
-          <ac:spMkLst>
-            <pc:docMk/>
-            <pc:sldMk cId="1403429394" sldId="257"/>
-            <ac:spMk id="62" creationId="{BB947B23-D613-6274-5A1A-0612C9DDC7BA}"/>
-          </ac:spMkLst>
-        </pc:spChg>
-        <pc:spChg chg="del">
-          <ac:chgData name="Fatima Pillosu" userId="a6295d4dc9e22643" providerId="LiveId" clId="{9A2B42D9-F292-4BF4-BB93-D16CACD71501}" dt="2025-06-10T16:03:05.604" v="3" actId="21"/>
-          <ac:spMkLst>
-            <pc:docMk/>
-            <pc:sldMk cId="1403429394" sldId="257"/>
-            <ac:spMk id="63" creationId="{5B5E25C5-CF55-1AD6-2F46-56FF2C9AA072}"/>
-          </ac:spMkLst>
-        </pc:spChg>
-        <pc:spChg chg="del">
-          <ac:chgData name="Fatima Pillosu" userId="a6295d4dc9e22643" providerId="LiveId" clId="{9A2B42D9-F292-4BF4-BB93-D16CACD71501}" dt="2025-06-10T16:03:05.604" v="3" actId="21"/>
-          <ac:spMkLst>
-            <pc:docMk/>
-            <pc:sldMk cId="1403429394" sldId="257"/>
-            <ac:spMk id="64" creationId="{89D57BAF-EDF7-DFF3-25C8-DBF5CA7C01E8}"/>
-          </ac:spMkLst>
-        </pc:spChg>
-        <pc:spChg chg="del">
-          <ac:chgData name="Fatima Pillosu" userId="a6295d4dc9e22643" providerId="LiveId" clId="{9A2B42D9-F292-4BF4-BB93-D16CACD71501}" dt="2025-06-10T16:03:05.604" v="3" actId="21"/>
-          <ac:spMkLst>
-            <pc:docMk/>
-            <pc:sldMk cId="1403429394" sldId="257"/>
-            <ac:spMk id="65" creationId="{2A0340DF-C636-D189-A28F-EA34AB5D27EE}"/>
-          </ac:spMkLst>
-        </pc:spChg>
-        <pc:spChg chg="del">
-          <ac:chgData name="Fatima Pillosu" userId="a6295d4dc9e22643" providerId="LiveId" clId="{9A2B42D9-F292-4BF4-BB93-D16CACD71501}" dt="2025-06-10T16:03:05.604" v="3" actId="21"/>
-          <ac:spMkLst>
-            <pc:docMk/>
-            <pc:sldMk cId="1403429394" sldId="257"/>
-            <ac:spMk id="66" creationId="{12F38479-AB54-6B30-2D3C-FF8C0302CC0C}"/>
-          </ac:spMkLst>
-        </pc:spChg>
-        <pc:spChg chg="del">
-          <ac:chgData name="Fatima Pillosu" userId="a6295d4dc9e22643" providerId="LiveId" clId="{9A2B42D9-F292-4BF4-BB93-D16CACD71501}" dt="2025-06-10T16:03:05.604" v="3" actId="21"/>
-          <ac:spMkLst>
-            <pc:docMk/>
-            <pc:sldMk cId="1403429394" sldId="257"/>
-            <ac:spMk id="67" creationId="{F814593F-D80C-3FAD-DC51-3489C5EF4A97}"/>
-          </ac:spMkLst>
-        </pc:spChg>
-        <pc:spChg chg="add del">
-          <ac:chgData name="Fatima Pillosu" userId="a6295d4dc9e22643" providerId="LiveId" clId="{9A2B42D9-F292-4BF4-BB93-D16CACD71501}" dt="2025-06-10T16:03:04.292" v="2" actId="478"/>
-          <ac:spMkLst>
-            <pc:docMk/>
-            <pc:sldMk cId="1403429394" sldId="257"/>
-            <ac:spMk id="68" creationId="{08C61BD4-2FFA-BC91-976B-8234946552F3}"/>
-          </ac:spMkLst>
-        </pc:spChg>
-        <pc:spChg chg="add mod">
-          <ac:chgData name="Fatima Pillosu" userId="a6295d4dc9e22643" providerId="LiveId" clId="{9A2B42D9-F292-4BF4-BB93-D16CACD71501}" dt="2025-06-10T16:03:48.280" v="7" actId="1036"/>
-          <ac:spMkLst>
-            <pc:docMk/>
-            <pc:sldMk cId="1403429394" sldId="257"/>
-            <ac:spMk id="76" creationId="{082CB828-3055-C01D-1D9B-34D32699459C}"/>
-          </ac:spMkLst>
-        </pc:spChg>
-        <pc:spChg chg="add mod">
-          <ac:chgData name="Fatima Pillosu" userId="a6295d4dc9e22643" providerId="LiveId" clId="{9A2B42D9-F292-4BF4-BB93-D16CACD71501}" dt="2025-06-10T16:03:48.280" v="7" actId="1036"/>
-          <ac:spMkLst>
-            <pc:docMk/>
-            <pc:sldMk cId="1403429394" sldId="257"/>
-            <ac:spMk id="77" creationId="{26462B98-3F43-7391-382E-5FA37001F70A}"/>
-          </ac:spMkLst>
-        </pc:spChg>
-        <pc:spChg chg="add mod">
-          <ac:chgData name="Fatima Pillosu" userId="a6295d4dc9e22643" providerId="LiveId" clId="{9A2B42D9-F292-4BF4-BB93-D16CACD71501}" dt="2025-06-10T16:03:48.280" v="7" actId="1036"/>
-          <ac:spMkLst>
-            <pc:docMk/>
-            <pc:sldMk cId="1403429394" sldId="257"/>
-            <ac:spMk id="78" creationId="{FB1D83BF-C5B8-0F42-ACF1-801724C77646}"/>
-          </ac:spMkLst>
-        </pc:spChg>
-        <pc:spChg chg="add mod">
-          <ac:chgData name="Fatima Pillosu" userId="a6295d4dc9e22643" providerId="LiveId" clId="{9A2B42D9-F292-4BF4-BB93-D16CACD71501}" dt="2025-06-10T16:03:48.280" v="7" actId="1036"/>
-          <ac:spMkLst>
-            <pc:docMk/>
-            <pc:sldMk cId="1403429394" sldId="257"/>
-            <ac:spMk id="79" creationId="{EFB51189-ED1C-9467-A21E-04098224201A}"/>
-          </ac:spMkLst>
-        </pc:spChg>
-        <pc:spChg chg="add mod">
-          <ac:chgData name="Fatima Pillosu" userId="a6295d4dc9e22643" providerId="LiveId" clId="{9A2B42D9-F292-4BF4-BB93-D16CACD71501}" dt="2025-06-10T16:03:48.280" v="7" actId="1036"/>
-          <ac:spMkLst>
-            <pc:docMk/>
-            <pc:sldMk cId="1403429394" sldId="257"/>
-            <ac:spMk id="80" creationId="{21C332B9-C99D-6C2F-F7A7-D75A6499E176}"/>
-          </ac:spMkLst>
-        </pc:spChg>
-        <pc:spChg chg="add mod">
-          <ac:chgData name="Fatima Pillosu" userId="a6295d4dc9e22643" providerId="LiveId" clId="{9A2B42D9-F292-4BF4-BB93-D16CACD71501}" dt="2025-06-10T16:03:48.280" v="7" actId="1036"/>
-          <ac:spMkLst>
-            <pc:docMk/>
-            <pc:sldMk cId="1403429394" sldId="257"/>
-            <ac:spMk id="81" creationId="{88809429-C163-FEA9-654A-C938A20C2ED1}"/>
-          </ac:spMkLst>
-        </pc:spChg>
-        <pc:spChg chg="add mod">
-          <ac:chgData name="Fatima Pillosu" userId="a6295d4dc9e22643" providerId="LiveId" clId="{9A2B42D9-F292-4BF4-BB93-D16CACD71501}" dt="2025-06-10T16:03:48.280" v="7" actId="1036"/>
-          <ac:spMkLst>
-            <pc:docMk/>
-            <pc:sldMk cId="1403429394" sldId="257"/>
-            <ac:spMk id="82" creationId="{64A6DF9F-4002-0BE8-0275-A7A7B18AE50E}"/>
-          </ac:spMkLst>
-        </pc:spChg>
-        <pc:spChg chg="add mod">
-          <ac:chgData name="Fatima Pillosu" userId="a6295d4dc9e22643" providerId="LiveId" clId="{9A2B42D9-F292-4BF4-BB93-D16CACD71501}" dt="2025-06-10T16:03:48.280" v="7" actId="1036"/>
-          <ac:spMkLst>
-            <pc:docMk/>
-            <pc:sldMk cId="1403429394" sldId="257"/>
-            <ac:spMk id="83" creationId="{FBF4F939-D8E0-4CA6-4395-BE2703ED47D3}"/>
-          </ac:spMkLst>
-        </pc:spChg>
-        <pc:spChg chg="add mod">
-          <ac:chgData name="Fatima Pillosu" userId="a6295d4dc9e22643" providerId="LiveId" clId="{9A2B42D9-F292-4BF4-BB93-D16CACD71501}" dt="2025-06-10T16:03:48.280" v="7" actId="1036"/>
-          <ac:spMkLst>
-            <pc:docMk/>
-            <pc:sldMk cId="1403429394" sldId="257"/>
-            <ac:spMk id="84" creationId="{9886A46A-5F0E-29C0-5553-F3C415C39030}"/>
-          </ac:spMkLst>
-        </pc:spChg>
-        <pc:spChg chg="add mod">
-          <ac:chgData name="Fatima Pillosu" userId="a6295d4dc9e22643" providerId="LiveId" clId="{9A2B42D9-F292-4BF4-BB93-D16CACD71501}" dt="2025-06-10T16:03:48.280" v="7" actId="1036"/>
-          <ac:spMkLst>
-            <pc:docMk/>
-            <pc:sldMk cId="1403429394" sldId="257"/>
-            <ac:spMk id="85" creationId="{DD731501-A656-7957-75AF-86B51CC75396}"/>
-          </ac:spMkLst>
-        </pc:spChg>
-        <pc:spChg chg="add mod">
-          <ac:chgData name="Fatima Pillosu" userId="a6295d4dc9e22643" providerId="LiveId" clId="{9A2B42D9-F292-4BF4-BB93-D16CACD71501}" dt="2025-06-10T16:03:48.280" v="7" actId="1036"/>
-          <ac:spMkLst>
-            <pc:docMk/>
-            <pc:sldMk cId="1403429394" sldId="257"/>
-            <ac:spMk id="86" creationId="{DE08B4AE-3720-60F1-D6B9-743C32AD6707}"/>
-          </ac:spMkLst>
-        </pc:spChg>
-        <pc:spChg chg="add mod">
-          <ac:chgData name="Fatima Pillosu" userId="a6295d4dc9e22643" providerId="LiveId" clId="{9A2B42D9-F292-4BF4-BB93-D16CACD71501}" dt="2025-06-10T16:03:48.280" v="7" actId="1036"/>
-          <ac:spMkLst>
-            <pc:docMk/>
-            <pc:sldMk cId="1403429394" sldId="257"/>
-            <ac:spMk id="87" creationId="{9C4F17D1-D949-02CB-0B46-48106B0B393C}"/>
-          </ac:spMkLst>
-        </pc:spChg>
-        <pc:spChg chg="add mod">
-          <ac:chgData name="Fatima Pillosu" userId="a6295d4dc9e22643" providerId="LiveId" clId="{9A2B42D9-F292-4BF4-BB93-D16CACD71501}" dt="2025-06-10T16:03:48.280" v="7" actId="1036"/>
-          <ac:spMkLst>
-            <pc:docMk/>
-            <pc:sldMk cId="1403429394" sldId="257"/>
-            <ac:spMk id="88" creationId="{455A54B8-5CD9-B620-BC08-5F6DA9DF0ED8}"/>
-          </ac:spMkLst>
-        </pc:spChg>
-        <pc:spChg chg="add mod">
-          <ac:chgData name="Fatima Pillosu" userId="a6295d4dc9e22643" providerId="LiveId" clId="{9A2B42D9-F292-4BF4-BB93-D16CACD71501}" dt="2025-06-10T16:03:48.280" v="7" actId="1036"/>
-          <ac:spMkLst>
-            <pc:docMk/>
-            <pc:sldMk cId="1403429394" sldId="257"/>
-            <ac:spMk id="89" creationId="{55890E00-81A3-E28D-C052-5E4FA9603339}"/>
-          </ac:spMkLst>
-        </pc:spChg>
-        <pc:spChg chg="add mod">
-          <ac:chgData name="Fatima Pillosu" userId="a6295d4dc9e22643" providerId="LiveId" clId="{9A2B42D9-F292-4BF4-BB93-D16CACD71501}" dt="2025-06-10T16:03:48.280" v="7" actId="1036"/>
-          <ac:spMkLst>
-            <pc:docMk/>
-            <pc:sldMk cId="1403429394" sldId="257"/>
-            <ac:spMk id="90" creationId="{D22BC35C-D8BA-9C47-5E36-D7A2E39E7940}"/>
-          </ac:spMkLst>
-        </pc:spChg>
-        <pc:spChg chg="add mod">
-          <ac:chgData name="Fatima Pillosu" userId="a6295d4dc9e22643" providerId="LiveId" clId="{9A2B42D9-F292-4BF4-BB93-D16CACD71501}" dt="2025-06-10T16:03:48.280" v="7" actId="1036"/>
-          <ac:spMkLst>
-            <pc:docMk/>
-            <pc:sldMk cId="1403429394" sldId="257"/>
-            <ac:spMk id="91" creationId="{2847A4E1-5D8A-BA47-5F8F-485D455DD114}"/>
-          </ac:spMkLst>
-        </pc:spChg>
-        <pc:spChg chg="add mod">
-          <ac:chgData name="Fatima Pillosu" userId="a6295d4dc9e22643" providerId="LiveId" clId="{9A2B42D9-F292-4BF4-BB93-D16CACD71501}" dt="2025-06-10T16:03:48.280" v="7" actId="1036"/>
-          <ac:spMkLst>
-            <pc:docMk/>
-            <pc:sldMk cId="1403429394" sldId="257"/>
-            <ac:spMk id="92" creationId="{9A16AC1B-8EF3-92A4-CABD-D73AD244F75E}"/>
-          </ac:spMkLst>
-        </pc:spChg>
-        <pc:spChg chg="add mod">
-          <ac:chgData name="Fatima Pillosu" userId="a6295d4dc9e22643" providerId="LiveId" clId="{9A2B42D9-F292-4BF4-BB93-D16CACD71501}" dt="2025-06-10T16:03:48.280" v="7" actId="1036"/>
-          <ac:spMkLst>
-            <pc:docMk/>
-            <pc:sldMk cId="1403429394" sldId="257"/>
-            <ac:spMk id="93" creationId="{15B66109-5EC0-175E-124D-C46996895CE7}"/>
-          </ac:spMkLst>
-        </pc:spChg>
-        <pc:spChg chg="add mod">
-          <ac:chgData name="Fatima Pillosu" userId="a6295d4dc9e22643" providerId="LiveId" clId="{9A2B42D9-F292-4BF4-BB93-D16CACD71501}" dt="2025-06-10T16:03:48.280" v="7" actId="1036"/>
-          <ac:spMkLst>
-            <pc:docMk/>
-            <pc:sldMk cId="1403429394" sldId="257"/>
-            <ac:spMk id="94" creationId="{376BC6E3-86E2-3737-AB80-3B95CB16E8E3}"/>
-          </ac:spMkLst>
-        </pc:spChg>
-        <pc:spChg chg="add mod">
-          <ac:chgData name="Fatima Pillosu" userId="a6295d4dc9e22643" providerId="LiveId" clId="{9A2B42D9-F292-4BF4-BB93-D16CACD71501}" dt="2025-06-10T16:03:48.280" v="7" actId="1036"/>
-          <ac:spMkLst>
-            <pc:docMk/>
-            <pc:sldMk cId="1403429394" sldId="257"/>
-            <ac:spMk id="95" creationId="{12D385A0-4768-7304-9AF2-9662B3618F45}"/>
-          </ac:spMkLst>
-        </pc:spChg>
-        <pc:spChg chg="add mod">
-          <ac:chgData name="Fatima Pillosu" userId="a6295d4dc9e22643" providerId="LiveId" clId="{9A2B42D9-F292-4BF4-BB93-D16CACD71501}" dt="2025-06-10T16:03:48.280" v="7" actId="1036"/>
-          <ac:spMkLst>
-            <pc:docMk/>
-            <pc:sldMk cId="1403429394" sldId="257"/>
-            <ac:spMk id="96" creationId="{57E75AC1-1794-5E7F-F1C7-E3D46F9F3C6B}"/>
-          </ac:spMkLst>
-        </pc:spChg>
-        <pc:spChg chg="add mod">
-          <ac:chgData name="Fatima Pillosu" userId="a6295d4dc9e22643" providerId="LiveId" clId="{9A2B42D9-F292-4BF4-BB93-D16CACD71501}" dt="2025-06-10T16:03:48.280" v="7" actId="1036"/>
-          <ac:spMkLst>
-            <pc:docMk/>
-            <pc:sldMk cId="1403429394" sldId="257"/>
-            <ac:spMk id="97" creationId="{51966A53-077B-E857-FB56-6D8CABD214E0}"/>
-          </ac:spMkLst>
-        </pc:spChg>
-        <pc:spChg chg="add mod">
-          <ac:chgData name="Fatima Pillosu" userId="a6295d4dc9e22643" providerId="LiveId" clId="{9A2B42D9-F292-4BF4-BB93-D16CACD71501}" dt="2025-06-10T16:03:48.280" v="7" actId="1036"/>
-          <ac:spMkLst>
-            <pc:docMk/>
-            <pc:sldMk cId="1403429394" sldId="257"/>
-            <ac:spMk id="98" creationId="{35DD87AC-C1BC-2933-33E1-AC551ED331CE}"/>
-          </ac:spMkLst>
-        </pc:spChg>
-        <pc:spChg chg="add mod">
-          <ac:chgData name="Fatima Pillosu" userId="a6295d4dc9e22643" providerId="LiveId" clId="{9A2B42D9-F292-4BF4-BB93-D16CACD71501}" dt="2025-06-10T16:03:48.280" v="7" actId="1036"/>
-          <ac:spMkLst>
-            <pc:docMk/>
-            <pc:sldMk cId="1403429394" sldId="257"/>
-            <ac:spMk id="99" creationId="{75493878-E8E3-4B21-EDED-882FA025EE50}"/>
-          </ac:spMkLst>
-        </pc:spChg>
-        <pc:spChg chg="add mod">
-          <ac:chgData name="Fatima Pillosu" userId="a6295d4dc9e22643" providerId="LiveId" clId="{9A2B42D9-F292-4BF4-BB93-D16CACD71501}" dt="2025-06-10T16:03:48.280" v="7" actId="1036"/>
-          <ac:spMkLst>
-            <pc:docMk/>
-            <pc:sldMk cId="1403429394" sldId="257"/>
-            <ac:spMk id="100" creationId="{000021FB-3D9A-C671-5BD8-5FD3D4F57EAF}"/>
-          </ac:spMkLst>
-        </pc:spChg>
-        <pc:spChg chg="add mod">
-          <ac:chgData name="Fatima Pillosu" userId="a6295d4dc9e22643" providerId="LiveId" clId="{9A2B42D9-F292-4BF4-BB93-D16CACD71501}" dt="2025-06-10T16:03:48.280" v="7" actId="1036"/>
-          <ac:spMkLst>
-            <pc:docMk/>
-            <pc:sldMk cId="1403429394" sldId="257"/>
-            <ac:spMk id="101" creationId="{1D9A1454-C5EC-EF96-9456-6EFA68D93F96}"/>
-          </ac:spMkLst>
-        </pc:spChg>
-        <pc:spChg chg="add mod">
-          <ac:chgData name="Fatima Pillosu" userId="a6295d4dc9e22643" providerId="LiveId" clId="{9A2B42D9-F292-4BF4-BB93-D16CACD71501}" dt="2025-06-10T16:03:48.280" v="7" actId="1036"/>
-          <ac:spMkLst>
-            <pc:docMk/>
-            <pc:sldMk cId="1403429394" sldId="257"/>
-            <ac:spMk id="102" creationId="{CE3B5F6B-A16B-67FA-B1F3-40AF319AD7BD}"/>
-          </ac:spMkLst>
-        </pc:spChg>
-        <pc:spChg chg="add mod">
-          <ac:chgData name="Fatima Pillosu" userId="a6295d4dc9e22643" providerId="LiveId" clId="{9A2B42D9-F292-4BF4-BB93-D16CACD71501}" dt="2025-06-10T16:03:48.280" v="7" actId="1036"/>
-          <ac:spMkLst>
-            <pc:docMk/>
-            <pc:sldMk cId="1403429394" sldId="257"/>
-            <ac:spMk id="103" creationId="{3FF0EAA4-2EF5-4F38-B6EC-35ED6BE230C8}"/>
-          </ac:spMkLst>
-        </pc:spChg>
-        <pc:spChg chg="add mod">
-          <ac:chgData name="Fatima Pillosu" userId="a6295d4dc9e22643" providerId="LiveId" clId="{9A2B42D9-F292-4BF4-BB93-D16CACD71501}" dt="2025-06-10T16:03:48.280" v="7" actId="1036"/>
-          <ac:spMkLst>
-            <pc:docMk/>
-            <pc:sldMk cId="1403429394" sldId="257"/>
-            <ac:spMk id="104" creationId="{9C0BF0B8-9ECF-FB3A-55AD-9010A6D0C88A}"/>
-          </ac:spMkLst>
-        </pc:spChg>
-        <pc:spChg chg="add mod">
-          <ac:chgData name="Fatima Pillosu" userId="a6295d4dc9e22643" providerId="LiveId" clId="{9A2B42D9-F292-4BF4-BB93-D16CACD71501}" dt="2025-06-10T16:03:48.280" v="7" actId="1036"/>
-          <ac:spMkLst>
-            <pc:docMk/>
-            <pc:sldMk cId="1403429394" sldId="257"/>
-            <ac:spMk id="105" creationId="{B4F89EAC-F5BE-5AB3-6D3A-51942411D6AC}"/>
-          </ac:spMkLst>
-        </pc:spChg>
-        <pc:spChg chg="add mod">
-          <ac:chgData name="Fatima Pillosu" userId="a6295d4dc9e22643" providerId="LiveId" clId="{9A2B42D9-F292-4BF4-BB93-D16CACD71501}" dt="2025-06-10T16:03:48.280" v="7" actId="1036"/>
-          <ac:spMkLst>
-            <pc:docMk/>
-            <pc:sldMk cId="1403429394" sldId="257"/>
-            <ac:spMk id="106" creationId="{4B314188-7F22-6C36-D5F3-C79B9823CCF9}"/>
-          </ac:spMkLst>
-        </pc:spChg>
-        <pc:spChg chg="add mod">
-          <ac:chgData name="Fatima Pillosu" userId="a6295d4dc9e22643" providerId="LiveId" clId="{9A2B42D9-F292-4BF4-BB93-D16CACD71501}" dt="2025-06-10T16:03:48.280" v="7" actId="1036"/>
-          <ac:spMkLst>
-            <pc:docMk/>
-            <pc:sldMk cId="1403429394" sldId="257"/>
-            <ac:spMk id="107" creationId="{445A7559-4D19-A6F6-DA0F-D756F483D299}"/>
-          </ac:spMkLst>
-        </pc:spChg>
-        <pc:spChg chg="add mod">
-          <ac:chgData name="Fatima Pillosu" userId="a6295d4dc9e22643" providerId="LiveId" clId="{9A2B42D9-F292-4BF4-BB93-D16CACD71501}" dt="2025-06-10T16:03:48.280" v="7" actId="1036"/>
-          <ac:spMkLst>
-            <pc:docMk/>
-            <pc:sldMk cId="1403429394" sldId="257"/>
-            <ac:spMk id="108" creationId="{A4EE99A9-33C7-3773-9DEA-E39F625A5212}"/>
-          </ac:spMkLst>
-        </pc:spChg>
-        <pc:spChg chg="add mod">
-          <ac:chgData name="Fatima Pillosu" userId="a6295d4dc9e22643" providerId="LiveId" clId="{9A2B42D9-F292-4BF4-BB93-D16CACD71501}" dt="2025-06-10T16:03:48.280" v="7" actId="1036"/>
-          <ac:spMkLst>
-            <pc:docMk/>
-            <pc:sldMk cId="1403429394" sldId="257"/>
-            <ac:spMk id="109" creationId="{D8B522E8-1814-1FE6-CF46-055B320030EF}"/>
-          </ac:spMkLst>
-        </pc:spChg>
-        <pc:spChg chg="add mod">
-          <ac:chgData name="Fatima Pillosu" userId="a6295d4dc9e22643" providerId="LiveId" clId="{9A2B42D9-F292-4BF4-BB93-D16CACD71501}" dt="2025-06-10T16:03:48.280" v="7" actId="1036"/>
-          <ac:spMkLst>
-            <pc:docMk/>
-            <pc:sldMk cId="1403429394" sldId="257"/>
-            <ac:spMk id="110" creationId="{F0474377-B166-9FE7-F0CD-757289DF5B18}"/>
-          </ac:spMkLst>
-        </pc:spChg>
-        <pc:spChg chg="add mod">
-          <ac:chgData name="Fatima Pillosu" userId="a6295d4dc9e22643" providerId="LiveId" clId="{9A2B42D9-F292-4BF4-BB93-D16CACD71501}" dt="2025-06-10T16:03:48.280" v="7" actId="1036"/>
-          <ac:spMkLst>
-            <pc:docMk/>
-            <pc:sldMk cId="1403429394" sldId="257"/>
-            <ac:spMk id="111" creationId="{2EC17A87-5F98-30A0-B0E4-2CF025030731}"/>
-          </ac:spMkLst>
-        </pc:spChg>
-        <pc:spChg chg="add mod">
-          <ac:chgData name="Fatima Pillosu" userId="a6295d4dc9e22643" providerId="LiveId" clId="{9A2B42D9-F292-4BF4-BB93-D16CACD71501}" dt="2025-06-10T16:03:48.280" v="7" actId="1036"/>
-          <ac:spMkLst>
-            <pc:docMk/>
-            <pc:sldMk cId="1403429394" sldId="257"/>
-            <ac:spMk id="112" creationId="{B449B9DC-BC6D-3397-ECEA-E2B1A14A2A1D}"/>
-          </ac:spMkLst>
-        </pc:spChg>
-        <pc:spChg chg="add mod">
-          <ac:chgData name="Fatima Pillosu" userId="a6295d4dc9e22643" providerId="LiveId" clId="{9A2B42D9-F292-4BF4-BB93-D16CACD71501}" dt="2025-06-10T16:03:48.280" v="7" actId="1036"/>
-          <ac:spMkLst>
-            <pc:docMk/>
-            <pc:sldMk cId="1403429394" sldId="257"/>
-            <ac:spMk id="113" creationId="{F931034A-7D6F-8EA8-77FA-38D23B11D246}"/>
-          </ac:spMkLst>
-        </pc:spChg>
-        <pc:spChg chg="add mod">
-          <ac:chgData name="Fatima Pillosu" userId="a6295d4dc9e22643" providerId="LiveId" clId="{9A2B42D9-F292-4BF4-BB93-D16CACD71501}" dt="2025-06-10T16:03:48.280" v="7" actId="1036"/>
-          <ac:spMkLst>
-            <pc:docMk/>
-            <pc:sldMk cId="1403429394" sldId="257"/>
-            <ac:spMk id="114" creationId="{4E92A261-3F68-2130-689A-A1282F999C88}"/>
-          </ac:spMkLst>
-        </pc:spChg>
-        <pc:spChg chg="add mod">
-          <ac:chgData name="Fatima Pillosu" userId="a6295d4dc9e22643" providerId="LiveId" clId="{9A2B42D9-F292-4BF4-BB93-D16CACD71501}" dt="2025-06-10T16:03:48.280" v="7" actId="1036"/>
-          <ac:spMkLst>
-            <pc:docMk/>
-            <pc:sldMk cId="1403429394" sldId="257"/>
-            <ac:spMk id="115" creationId="{13B4ED1F-BA20-584D-160D-E72FD57F6E94}"/>
-          </ac:spMkLst>
-        </pc:spChg>
-        <pc:spChg chg="add mod">
-          <ac:chgData name="Fatima Pillosu" userId="a6295d4dc9e22643" providerId="LiveId" clId="{9A2B42D9-F292-4BF4-BB93-D16CACD71501}" dt="2025-06-10T16:03:48.280" v="7" actId="1036"/>
-          <ac:spMkLst>
-            <pc:docMk/>
-            <pc:sldMk cId="1403429394" sldId="257"/>
-            <ac:spMk id="116" creationId="{9E17B2EA-5075-2F32-48F1-B8F79DC14C38}"/>
-          </ac:spMkLst>
-        </pc:spChg>
-        <pc:spChg chg="add mod">
-          <ac:chgData name="Fatima Pillosu" userId="a6295d4dc9e22643" providerId="LiveId" clId="{9A2B42D9-F292-4BF4-BB93-D16CACD71501}" dt="2025-06-10T16:03:48.280" v="7" actId="1036"/>
-          <ac:spMkLst>
-            <pc:docMk/>
-            <pc:sldMk cId="1403429394" sldId="257"/>
-            <ac:spMk id="117" creationId="{3C88EA91-CBB6-2923-84E8-958EAB03D695}"/>
-          </ac:spMkLst>
-        </pc:spChg>
-        <pc:spChg chg="add mod">
-          <ac:chgData name="Fatima Pillosu" userId="a6295d4dc9e22643" providerId="LiveId" clId="{9A2B42D9-F292-4BF4-BB93-D16CACD71501}" dt="2025-06-10T16:03:48.280" v="7" actId="1036"/>
-          <ac:spMkLst>
-            <pc:docMk/>
-            <pc:sldMk cId="1403429394" sldId="257"/>
-            <ac:spMk id="118" creationId="{398D0DBF-C0BF-0EAB-70D2-6FAFBE8D8584}"/>
-          </ac:spMkLst>
-        </pc:spChg>
-        <pc:spChg chg="add mod">
-          <ac:chgData name="Fatima Pillosu" userId="a6295d4dc9e22643" providerId="LiveId" clId="{9A2B42D9-F292-4BF4-BB93-D16CACD71501}" dt="2025-06-10T16:03:48.280" v="7" actId="1036"/>
-          <ac:spMkLst>
-            <pc:docMk/>
-            <pc:sldMk cId="1403429394" sldId="257"/>
-            <ac:spMk id="119" creationId="{BB947B23-D613-6274-5A1A-0612C9DDC7BA}"/>
-          </ac:spMkLst>
-        </pc:spChg>
-        <pc:spChg chg="add mod">
-          <ac:chgData name="Fatima Pillosu" userId="a6295d4dc9e22643" providerId="LiveId" clId="{9A2B42D9-F292-4BF4-BB93-D16CACD71501}" dt="2025-06-10T16:03:48.280" v="7" actId="1036"/>
-          <ac:spMkLst>
-            <pc:docMk/>
-            <pc:sldMk cId="1403429394" sldId="257"/>
-            <ac:spMk id="120" creationId="{5B5E25C5-CF55-1AD6-2F46-56FF2C9AA072}"/>
-          </ac:spMkLst>
-        </pc:spChg>
-        <pc:spChg chg="add mod">
-          <ac:chgData name="Fatima Pillosu" userId="a6295d4dc9e22643" providerId="LiveId" clId="{9A2B42D9-F292-4BF4-BB93-D16CACD71501}" dt="2025-06-10T16:03:48.280" v="7" actId="1036"/>
-          <ac:spMkLst>
-            <pc:docMk/>
-            <pc:sldMk cId="1403429394" sldId="257"/>
-            <ac:spMk id="121" creationId="{89D57BAF-EDF7-DFF3-25C8-DBF5CA7C01E8}"/>
-          </ac:spMkLst>
-        </pc:spChg>
-        <pc:spChg chg="add mod">
-          <ac:chgData name="Fatima Pillosu" userId="a6295d4dc9e22643" providerId="LiveId" clId="{9A2B42D9-F292-4BF4-BB93-D16CACD71501}" dt="2025-06-10T16:03:48.280" v="7" actId="1036"/>
-          <ac:spMkLst>
-            <pc:docMk/>
-            <pc:sldMk cId="1403429394" sldId="257"/>
-            <ac:spMk id="122" creationId="{2A0340DF-C636-D189-A28F-EA34AB5D27EE}"/>
-          </ac:spMkLst>
-        </pc:spChg>
-        <pc:spChg chg="add mod">
-          <ac:chgData name="Fatima Pillosu" userId="a6295d4dc9e22643" providerId="LiveId" clId="{9A2B42D9-F292-4BF4-BB93-D16CACD71501}" dt="2025-06-10T16:03:48.280" v="7" actId="1036"/>
-          <ac:spMkLst>
-            <pc:docMk/>
-            <pc:sldMk cId="1403429394" sldId="257"/>
-            <ac:spMk id="123" creationId="{12F38479-AB54-6B30-2D3C-FF8C0302CC0C}"/>
-          </ac:spMkLst>
-        </pc:spChg>
-        <pc:spChg chg="add mod">
-          <ac:chgData name="Fatima Pillosu" userId="a6295d4dc9e22643" providerId="LiveId" clId="{9A2B42D9-F292-4BF4-BB93-D16CACD71501}" dt="2025-06-10T16:03:48.280" v="7" actId="1036"/>
-          <ac:spMkLst>
-            <pc:docMk/>
-            <pc:sldMk cId="1403429394" sldId="257"/>
-            <ac:spMk id="124" creationId="{F814593F-D80C-3FAD-DC51-3489C5EF4A97}"/>
-          </ac:spMkLst>
-        </pc:spChg>
-        <pc:picChg chg="del">
-          <ac:chgData name="Fatima Pillosu" userId="a6295d4dc9e22643" providerId="LiveId" clId="{9A2B42D9-F292-4BF4-BB93-D16CACD71501}" dt="2025-06-10T16:03:05.604" v="3" actId="21"/>
-          <ac:picMkLst>
-            <pc:docMk/>
-            <pc:sldMk cId="1403429394" sldId="257"/>
-            <ac:picMk id="46" creationId="{6A2A8283-3849-D659-06C6-D6DE70F64B08}"/>
-          </ac:picMkLst>
-        </pc:picChg>
-        <pc:picChg chg="del">
-          <ac:chgData name="Fatima Pillosu" userId="a6295d4dc9e22643" providerId="LiveId" clId="{9A2B42D9-F292-4BF4-BB93-D16CACD71501}" dt="2025-06-10T16:03:05.604" v="3" actId="21"/>
-          <ac:picMkLst>
-            <pc:docMk/>
-            <pc:sldMk cId="1403429394" sldId="257"/>
-            <ac:picMk id="47" creationId="{A849A0A4-BAEA-683E-A6CC-B09F2F3D3040}"/>
-          </ac:picMkLst>
-        </pc:picChg>
-        <pc:picChg chg="del">
-          <ac:chgData name="Fatima Pillosu" userId="a6295d4dc9e22643" providerId="LiveId" clId="{9A2B42D9-F292-4BF4-BB93-D16CACD71501}" dt="2025-06-10T16:03:05.604" v="3" actId="21"/>
-          <ac:picMkLst>
-            <pc:docMk/>
-            <pc:sldMk cId="1403429394" sldId="257"/>
-            <ac:picMk id="48" creationId="{88979825-A594-A92A-E303-4E1684B4F59A}"/>
-          </ac:picMkLst>
-        </pc:picChg>
-        <pc:picChg chg="del">
-          <ac:chgData name="Fatima Pillosu" userId="a6295d4dc9e22643" providerId="LiveId" clId="{9A2B42D9-F292-4BF4-BB93-D16CACD71501}" dt="2025-06-10T16:03:05.604" v="3" actId="21"/>
-          <ac:picMkLst>
-            <pc:docMk/>
-            <pc:sldMk cId="1403429394" sldId="257"/>
-            <ac:picMk id="49" creationId="{F5CB678F-2B18-E524-16FF-2733AA5FC3AC}"/>
-          </ac:picMkLst>
-        </pc:picChg>
-        <pc:picChg chg="del">
-          <ac:chgData name="Fatima Pillosu" userId="a6295d4dc9e22643" providerId="LiveId" clId="{9A2B42D9-F292-4BF4-BB93-D16CACD71501}" dt="2025-06-10T16:03:05.604" v="3" actId="21"/>
-          <ac:picMkLst>
-            <pc:docMk/>
-            <pc:sldMk cId="1403429394" sldId="257"/>
-            <ac:picMk id="50" creationId="{F29DE699-E00F-06FD-D469-3B660ECA9711}"/>
-          </ac:picMkLst>
-        </pc:picChg>
-        <pc:picChg chg="del">
-          <ac:chgData name="Fatima Pillosu" userId="a6295d4dc9e22643" providerId="LiveId" clId="{9A2B42D9-F292-4BF4-BB93-D16CACD71501}" dt="2025-06-10T16:03:05.604" v="3" actId="21"/>
-          <ac:picMkLst>
-            <pc:docMk/>
-            <pc:sldMk cId="1403429394" sldId="257"/>
-            <ac:picMk id="51" creationId="{F18EEFB6-1319-D84D-0B25-D0CF3452267F}"/>
-          </ac:picMkLst>
-        </pc:picChg>
-        <pc:picChg chg="del">
-          <ac:chgData name="Fatima Pillosu" userId="a6295d4dc9e22643" providerId="LiveId" clId="{9A2B42D9-F292-4BF4-BB93-D16CACD71501}" dt="2025-06-10T16:03:05.604" v="3" actId="21"/>
-          <ac:picMkLst>
-            <pc:docMk/>
-            <pc:sldMk cId="1403429394" sldId="257"/>
-            <ac:picMk id="52" creationId="{5A07DFD8-3E71-3163-27C2-16BEB825E58F}"/>
-          </ac:picMkLst>
-        </pc:picChg>
-        <pc:picChg chg="add mod">
-          <ac:chgData name="Fatima Pillosu" userId="a6295d4dc9e22643" providerId="LiveId" clId="{9A2B42D9-F292-4BF4-BB93-D16CACD71501}" dt="2025-06-10T16:03:48.280" v="7" actId="1036"/>
-          <ac:picMkLst>
-            <pc:docMk/>
-            <pc:sldMk cId="1403429394" sldId="257"/>
-            <ac:picMk id="69" creationId="{5A07DFD8-3E71-3163-27C2-16BEB825E58F}"/>
-          </ac:picMkLst>
-        </pc:picChg>
-        <pc:picChg chg="add mod">
-          <ac:chgData name="Fatima Pillosu" userId="a6295d4dc9e22643" providerId="LiveId" clId="{9A2B42D9-F292-4BF4-BB93-D16CACD71501}" dt="2025-06-10T16:04:16.138" v="10" actId="554"/>
-          <ac:picMkLst>
-            <pc:docMk/>
-            <pc:sldMk cId="1403429394" sldId="257"/>
-            <ac:picMk id="70" creationId="{6A2A8283-3849-D659-06C6-D6DE70F64B08}"/>
-          </ac:picMkLst>
-        </pc:picChg>
-        <pc:picChg chg="add mod">
-          <ac:chgData name="Fatima Pillosu" userId="a6295d4dc9e22643" providerId="LiveId" clId="{9A2B42D9-F292-4BF4-BB93-D16CACD71501}" dt="2025-06-10T16:04:16.138" v="10" actId="554"/>
-          <ac:picMkLst>
-            <pc:docMk/>
-            <pc:sldMk cId="1403429394" sldId="257"/>
-            <ac:picMk id="71" creationId="{A849A0A4-BAEA-683E-A6CC-B09F2F3D3040}"/>
-          </ac:picMkLst>
-        </pc:picChg>
-        <pc:picChg chg="add mod">
-          <ac:chgData name="Fatima Pillosu" userId="a6295d4dc9e22643" providerId="LiveId" clId="{9A2B42D9-F292-4BF4-BB93-D16CACD71501}" dt="2025-06-10T16:04:22.942" v="11" actId="554"/>
-          <ac:picMkLst>
-            <pc:docMk/>
-            <pc:sldMk cId="1403429394" sldId="257"/>
-            <ac:picMk id="72" creationId="{88979825-A594-A92A-E303-4E1684B4F59A}"/>
-          </ac:picMkLst>
-        </pc:picChg>
-        <pc:picChg chg="add mod">
-          <ac:chgData name="Fatima Pillosu" userId="a6295d4dc9e22643" providerId="LiveId" clId="{9A2B42D9-F292-4BF4-BB93-D16CACD71501}" dt="2025-06-10T16:04:22.942" v="11" actId="554"/>
-          <ac:picMkLst>
-            <pc:docMk/>
-            <pc:sldMk cId="1403429394" sldId="257"/>
-            <ac:picMk id="73" creationId="{F5CB678F-2B18-E524-16FF-2733AA5FC3AC}"/>
-          </ac:picMkLst>
-        </pc:picChg>
-        <pc:picChg chg="add mod">
-          <ac:chgData name="Fatima Pillosu" userId="a6295d4dc9e22643" providerId="LiveId" clId="{9A2B42D9-F292-4BF4-BB93-D16CACD71501}" dt="2025-06-10T16:04:27.750" v="12" actId="554"/>
-          <ac:picMkLst>
-            <pc:docMk/>
-            <pc:sldMk cId="1403429394" sldId="257"/>
-            <ac:picMk id="74" creationId="{F29DE699-E00F-06FD-D469-3B660ECA9711}"/>
-          </ac:picMkLst>
-        </pc:picChg>
-        <pc:picChg chg="add mod">
-          <ac:chgData name="Fatima Pillosu" userId="a6295d4dc9e22643" providerId="LiveId" clId="{9A2B42D9-F292-4BF4-BB93-D16CACD71501}" dt="2025-06-10T16:04:27.750" v="12" actId="554"/>
-          <ac:picMkLst>
-            <pc:docMk/>
-            <pc:sldMk cId="1403429394" sldId="257"/>
-            <ac:picMk id="75" creationId="{F18EEFB6-1319-D84D-0B25-D0CF3452267F}"/>
-          </ac:picMkLst>
-        </pc:picChg>
-      </pc:sldChg>
-    </pc:docChg>
-  </pc:docChgLst>
-  <pc:docChgLst>
-    <pc:chgData name="Fatima Pillosu" userId="a6295d4dc9e22643" providerId="LiveId" clId="{B9A31C07-789E-48D4-B2E6-C80B6605FE08}"/>
-    <pc:docChg chg="custSel addSld delSld modSld">
-      <pc:chgData name="Fatima Pillosu" userId="a6295d4dc9e22643" providerId="LiveId" clId="{B9A31C07-789E-48D4-B2E6-C80B6605FE08}" dt="2025-06-10T21:40:28.264" v="99" actId="20577"/>
-      <pc:docMkLst>
-        <pc:docMk/>
-      </pc:docMkLst>
-      <pc:sldChg chg="addSp delSp modSp mod">
-        <pc:chgData name="Fatima Pillosu" userId="a6295d4dc9e22643" providerId="LiveId" clId="{B9A31C07-789E-48D4-B2E6-C80B6605FE08}" dt="2025-06-10T21:40:28.264" v="99" actId="20577"/>
-        <pc:sldMkLst>
-          <pc:docMk/>
-          <pc:sldMk cId="1403429394" sldId="257"/>
-        </pc:sldMkLst>
-        <pc:spChg chg="mod">
-          <ac:chgData name="Fatima Pillosu" userId="a6295d4dc9e22643" providerId="LiveId" clId="{B9A31C07-789E-48D4-B2E6-C80B6605FE08}" dt="2025-06-10T21:40:28.264" v="99" actId="20577"/>
-          <ac:spMkLst>
-            <pc:docMk/>
-            <pc:sldMk cId="1403429394" sldId="257"/>
-            <ac:spMk id="93" creationId="{15B66109-5EC0-175E-124D-C46996895CE7}"/>
-          </ac:spMkLst>
-        </pc:spChg>
-        <pc:picChg chg="add mod ord">
-          <ac:chgData name="Fatima Pillosu" userId="a6295d4dc9e22643" providerId="LiveId" clId="{B9A31C07-789E-48D4-B2E6-C80B6605FE08}" dt="2025-06-10T16:16:10.710" v="91" actId="554"/>
-          <ac:picMkLst>
-            <pc:docMk/>
-            <pc:sldMk cId="1403429394" sldId="257"/>
-            <ac:picMk id="5" creationId="{4188A312-931C-A96B-9DBB-485DE2DA9003}"/>
-          </ac:picMkLst>
-        </pc:picChg>
-        <pc:picChg chg="add mod ord">
-          <ac:chgData name="Fatima Pillosu" userId="a6295d4dc9e22643" providerId="LiveId" clId="{B9A31C07-789E-48D4-B2E6-C80B6605FE08}" dt="2025-06-10T16:16:10.710" v="91" actId="554"/>
-          <ac:picMkLst>
-            <pc:docMk/>
-            <pc:sldMk cId="1403429394" sldId="257"/>
-            <ac:picMk id="7" creationId="{7A99A4F9-239E-6C7F-B1CE-EE9C66D59500}"/>
-          </ac:picMkLst>
-        </pc:picChg>
-        <pc:picChg chg="add mod ord">
-          <ac:chgData name="Fatima Pillosu" userId="a6295d4dc9e22643" providerId="LiveId" clId="{B9A31C07-789E-48D4-B2E6-C80B6605FE08}" dt="2025-06-10T16:16:15.246" v="92" actId="554"/>
-          <ac:picMkLst>
-            <pc:docMk/>
-            <pc:sldMk cId="1403429394" sldId="257"/>
-            <ac:picMk id="9" creationId="{FD73FFD3-BDBE-202C-40CA-4F1E3FA747C9}"/>
-          </ac:picMkLst>
-        </pc:picChg>
-        <pc:picChg chg="add mod ord">
-          <ac:chgData name="Fatima Pillosu" userId="a6295d4dc9e22643" providerId="LiveId" clId="{B9A31C07-789E-48D4-B2E6-C80B6605FE08}" dt="2025-06-10T16:16:15.246" v="92" actId="554"/>
-          <ac:picMkLst>
-            <pc:docMk/>
-            <pc:sldMk cId="1403429394" sldId="257"/>
-            <ac:picMk id="11" creationId="{1E8DAAC5-8433-D72E-639E-5B9BA3EDE766}"/>
-          </ac:picMkLst>
-        </pc:picChg>
-        <pc:picChg chg="add mod ord">
-          <ac:chgData name="Fatima Pillosu" userId="a6295d4dc9e22643" providerId="LiveId" clId="{B9A31C07-789E-48D4-B2E6-C80B6605FE08}" dt="2025-06-10T16:16:20.132" v="93" actId="554"/>
-          <ac:picMkLst>
-            <pc:docMk/>
-            <pc:sldMk cId="1403429394" sldId="257"/>
-            <ac:picMk id="13" creationId="{585070D7-CA3A-502D-4DA3-91F14EC700AB}"/>
-          </ac:picMkLst>
-        </pc:picChg>
-        <pc:picChg chg="add mod ord">
-          <ac:chgData name="Fatima Pillosu" userId="a6295d4dc9e22643" providerId="LiveId" clId="{B9A31C07-789E-48D4-B2E6-C80B6605FE08}" dt="2025-06-10T16:16:20.132" v="93" actId="554"/>
-          <ac:picMkLst>
-            <pc:docMk/>
-            <pc:sldMk cId="1403429394" sldId="257"/>
-            <ac:picMk id="15" creationId="{4F9EDECB-B740-CAEE-DF03-9FF71FFF59EA}"/>
-          </ac:picMkLst>
-        </pc:picChg>
-        <pc:picChg chg="del mod">
-          <ac:chgData name="Fatima Pillosu" userId="a6295d4dc9e22643" providerId="LiveId" clId="{B9A31C07-789E-48D4-B2E6-C80B6605FE08}" dt="2025-06-10T16:15:41.433" v="84" actId="478"/>
-          <ac:picMkLst>
-            <pc:docMk/>
-            <pc:sldMk cId="1403429394" sldId="257"/>
-            <ac:picMk id="70" creationId="{6A2A8283-3849-D659-06C6-D6DE70F64B08}"/>
-          </ac:picMkLst>
-        </pc:picChg>
-        <pc:picChg chg="del mod">
-          <ac:chgData name="Fatima Pillosu" userId="a6295d4dc9e22643" providerId="LiveId" clId="{B9A31C07-789E-48D4-B2E6-C80B6605FE08}" dt="2025-06-10T16:15:40.350" v="83" actId="478"/>
-          <ac:picMkLst>
-            <pc:docMk/>
-            <pc:sldMk cId="1403429394" sldId="257"/>
-            <ac:picMk id="71" creationId="{A849A0A4-BAEA-683E-A6CC-B09F2F3D3040}"/>
-          </ac:picMkLst>
-        </pc:picChg>
-        <pc:picChg chg="del mod">
-          <ac:chgData name="Fatima Pillosu" userId="a6295d4dc9e22643" providerId="LiveId" clId="{B9A31C07-789E-48D4-B2E6-C80B6605FE08}" dt="2025-06-10T16:15:42.892" v="85" actId="478"/>
-          <ac:picMkLst>
-            <pc:docMk/>
-            <pc:sldMk cId="1403429394" sldId="257"/>
-            <ac:picMk id="72" creationId="{88979825-A594-A92A-E303-4E1684B4F59A}"/>
-          </ac:picMkLst>
-        </pc:picChg>
-        <pc:picChg chg="del mod">
-          <ac:chgData name="Fatima Pillosu" userId="a6295d4dc9e22643" providerId="LiveId" clId="{B9A31C07-789E-48D4-B2E6-C80B6605FE08}" dt="2025-06-10T16:15:43.771" v="86" actId="478"/>
-          <ac:picMkLst>
-            <pc:docMk/>
-            <pc:sldMk cId="1403429394" sldId="257"/>
-            <ac:picMk id="73" creationId="{F5CB678F-2B18-E524-16FF-2733AA5FC3AC}"/>
-          </ac:picMkLst>
-        </pc:picChg>
-        <pc:picChg chg="del mod">
-          <ac:chgData name="Fatima Pillosu" userId="a6295d4dc9e22643" providerId="LiveId" clId="{B9A31C07-789E-48D4-B2E6-C80B6605FE08}" dt="2025-06-10T16:15:44.987" v="88" actId="478"/>
-          <ac:picMkLst>
-            <pc:docMk/>
-            <pc:sldMk cId="1403429394" sldId="257"/>
-            <ac:picMk id="74" creationId="{F29DE699-E00F-06FD-D469-3B660ECA9711}"/>
-          </ac:picMkLst>
-        </pc:picChg>
-        <pc:picChg chg="del mod">
-          <ac:chgData name="Fatima Pillosu" userId="a6295d4dc9e22643" providerId="LiveId" clId="{B9A31C07-789E-48D4-B2E6-C80B6605FE08}" dt="2025-06-10T16:15:44.375" v="87" actId="478"/>
-          <ac:picMkLst>
-            <pc:docMk/>
-            <pc:sldMk cId="1403429394" sldId="257"/>
-            <ac:picMk id="75" creationId="{F18EEFB6-1319-D84D-0B25-D0CF3452267F}"/>
-          </ac:picMkLst>
-        </pc:picChg>
-      </pc:sldChg>
-      <pc:sldChg chg="addSp delSp modSp new del mod">
-        <pc:chgData name="Fatima Pillosu" userId="a6295d4dc9e22643" providerId="LiveId" clId="{B9A31C07-789E-48D4-B2E6-C80B6605FE08}" dt="2025-06-10T16:16:39.516" v="94" actId="47"/>
-        <pc:sldMkLst>
-          <pc:docMk/>
-          <pc:sldMk cId="266204001" sldId="258"/>
-        </pc:sldMkLst>
-        <pc:spChg chg="del">
-          <ac:chgData name="Fatima Pillosu" userId="a6295d4dc9e22643" providerId="LiveId" clId="{B9A31C07-789E-48D4-B2E6-C80B6605FE08}" dt="2025-06-10T16:11:11.990" v="5" actId="478"/>
-          <ac:spMkLst>
-            <pc:docMk/>
-            <pc:sldMk cId="266204001" sldId="258"/>
-            <ac:spMk id="2" creationId="{385879F8-7009-F396-A693-D0FC3D82097C}"/>
-          </ac:spMkLst>
-        </pc:spChg>
-        <pc:spChg chg="del">
-          <ac:chgData name="Fatima Pillosu" userId="a6295d4dc9e22643" providerId="LiveId" clId="{B9A31C07-789E-48D4-B2E6-C80B6605FE08}" dt="2025-06-10T16:11:10.851" v="4" actId="478"/>
-          <ac:spMkLst>
-            <pc:docMk/>
-            <pc:sldMk cId="266204001" sldId="258"/>
-            <ac:spMk id="3" creationId="{A370CD33-840B-1033-77D9-6F0F0F13F000}"/>
-          </ac:spMkLst>
-        </pc:spChg>
-        <pc:picChg chg="add del mod modCrop">
-          <ac:chgData name="Fatima Pillosu" userId="a6295d4dc9e22643" providerId="LiveId" clId="{B9A31C07-789E-48D4-B2E6-C80B6605FE08}" dt="2025-06-10T16:14:08.582" v="54" actId="21"/>
-          <ac:picMkLst>
-            <pc:docMk/>
-            <pc:sldMk cId="266204001" sldId="258"/>
-            <ac:picMk id="5" creationId="{4188A312-931C-A96B-9DBB-485DE2DA9003}"/>
-          </ac:picMkLst>
-        </pc:picChg>
-        <pc:picChg chg="add del mod modCrop">
-          <ac:chgData name="Fatima Pillosu" userId="a6295d4dc9e22643" providerId="LiveId" clId="{B9A31C07-789E-48D4-B2E6-C80B6605FE08}" dt="2025-06-10T16:14:22.315" v="58" actId="21"/>
-          <ac:picMkLst>
-            <pc:docMk/>
-            <pc:sldMk cId="266204001" sldId="258"/>
-            <ac:picMk id="7" creationId="{7A99A4F9-239E-6C7F-B1CE-EE9C66D59500}"/>
-          </ac:picMkLst>
-        </pc:picChg>
-        <pc:picChg chg="add del mod modCrop">
-          <ac:chgData name="Fatima Pillosu" userId="a6295d4dc9e22643" providerId="LiveId" clId="{B9A31C07-789E-48D4-B2E6-C80B6605FE08}" dt="2025-06-10T16:14:38.576" v="62" actId="21"/>
-          <ac:picMkLst>
-            <pc:docMk/>
-            <pc:sldMk cId="266204001" sldId="258"/>
-            <ac:picMk id="9" creationId="{FD73FFD3-BDBE-202C-40CA-4F1E3FA747C9}"/>
-          </ac:picMkLst>
-        </pc:picChg>
-        <pc:picChg chg="add del mod modCrop">
-          <ac:chgData name="Fatima Pillosu" userId="a6295d4dc9e22643" providerId="LiveId" clId="{B9A31C07-789E-48D4-B2E6-C80B6605FE08}" dt="2025-06-10T16:14:51.899" v="67" actId="21"/>
-          <ac:picMkLst>
-            <pc:docMk/>
-            <pc:sldMk cId="266204001" sldId="258"/>
-            <ac:picMk id="11" creationId="{1E8DAAC5-8433-D72E-639E-5B9BA3EDE766}"/>
-          </ac:picMkLst>
-        </pc:picChg>
-        <pc:picChg chg="add del mod modCrop">
-          <ac:chgData name="Fatima Pillosu" userId="a6295d4dc9e22643" providerId="LiveId" clId="{B9A31C07-789E-48D4-B2E6-C80B6605FE08}" dt="2025-06-10T16:15:06.686" v="72" actId="21"/>
-          <ac:picMkLst>
-            <pc:docMk/>
-            <pc:sldMk cId="266204001" sldId="258"/>
-            <ac:picMk id="13" creationId="{585070D7-CA3A-502D-4DA3-91F14EC700AB}"/>
-          </ac:picMkLst>
-        </pc:picChg>
-        <pc:picChg chg="add del mod modCrop">
-          <ac:chgData name="Fatima Pillosu" userId="a6295d4dc9e22643" providerId="LiveId" clId="{B9A31C07-789E-48D4-B2E6-C80B6605FE08}" dt="2025-06-10T16:15:19.822" v="77" actId="21"/>
-          <ac:picMkLst>
-            <pc:docMk/>
-            <pc:sldMk cId="266204001" sldId="258"/>
-            <ac:picMk id="15" creationId="{4F9EDECB-B740-CAEE-DF03-9FF71FFF59EA}"/>
-          </ac:picMkLst>
-        </pc:picChg>
       </pc:sldChg>
     </pc:docChg>
   </pc:docChgLst>
@@ -2294,7 +272,7 @@
           <a:p>
             <a:fld id="{ED515D41-4DB4-46CC-BF5F-4F1657FD0E85}" type="datetimeFigureOut">
               <a:rPr lang="en-GB" smtClean="0"/>
-              <a:t>15/07/2025</a:t>
+              <a:t>15/01/2026</a:t>
             </a:fld>
             <a:endParaRPr lang="en-GB"/>
           </a:p>
@@ -2464,7 +442,7 @@
           <a:p>
             <a:fld id="{ED515D41-4DB4-46CC-BF5F-4F1657FD0E85}" type="datetimeFigureOut">
               <a:rPr lang="en-GB" smtClean="0"/>
-              <a:t>15/07/2025</a:t>
+              <a:t>15/01/2026</a:t>
             </a:fld>
             <a:endParaRPr lang="en-GB"/>
           </a:p>
@@ -2644,7 +622,7 @@
           <a:p>
             <a:fld id="{ED515D41-4DB4-46CC-BF5F-4F1657FD0E85}" type="datetimeFigureOut">
               <a:rPr lang="en-GB" smtClean="0"/>
-              <a:t>15/07/2025</a:t>
+              <a:t>15/01/2026</a:t>
             </a:fld>
             <a:endParaRPr lang="en-GB"/>
           </a:p>
@@ -2814,7 +792,7 @@
           <a:p>
             <a:fld id="{ED515D41-4DB4-46CC-BF5F-4F1657FD0E85}" type="datetimeFigureOut">
               <a:rPr lang="en-GB" smtClean="0"/>
-              <a:t>15/07/2025</a:t>
+              <a:t>15/01/2026</a:t>
             </a:fld>
             <a:endParaRPr lang="en-GB"/>
           </a:p>
@@ -3060,7 +1038,7 @@
           <a:p>
             <a:fld id="{ED515D41-4DB4-46CC-BF5F-4F1657FD0E85}" type="datetimeFigureOut">
               <a:rPr lang="en-GB" smtClean="0"/>
-              <a:t>15/07/2025</a:t>
+              <a:t>15/01/2026</a:t>
             </a:fld>
             <a:endParaRPr lang="en-GB"/>
           </a:p>
@@ -3292,7 +1270,7 @@
           <a:p>
             <a:fld id="{ED515D41-4DB4-46CC-BF5F-4F1657FD0E85}" type="datetimeFigureOut">
               <a:rPr lang="en-GB" smtClean="0"/>
-              <a:t>15/07/2025</a:t>
+              <a:t>15/01/2026</a:t>
             </a:fld>
             <a:endParaRPr lang="en-GB"/>
           </a:p>
@@ -3659,7 +1637,7 @@
           <a:p>
             <a:fld id="{ED515D41-4DB4-46CC-BF5F-4F1657FD0E85}" type="datetimeFigureOut">
               <a:rPr lang="en-GB" smtClean="0"/>
-              <a:t>15/07/2025</a:t>
+              <a:t>15/01/2026</a:t>
             </a:fld>
             <a:endParaRPr lang="en-GB"/>
           </a:p>
@@ -3777,7 +1755,7 @@
           <a:p>
             <a:fld id="{ED515D41-4DB4-46CC-BF5F-4F1657FD0E85}" type="datetimeFigureOut">
               <a:rPr lang="en-GB" smtClean="0"/>
-              <a:t>15/07/2025</a:t>
+              <a:t>15/01/2026</a:t>
             </a:fld>
             <a:endParaRPr lang="en-GB"/>
           </a:p>
@@ -3872,7 +1850,7 @@
           <a:p>
             <a:fld id="{ED515D41-4DB4-46CC-BF5F-4F1657FD0E85}" type="datetimeFigureOut">
               <a:rPr lang="en-GB" smtClean="0"/>
-              <a:t>15/07/2025</a:t>
+              <a:t>15/01/2026</a:t>
             </a:fld>
             <a:endParaRPr lang="en-GB"/>
           </a:p>
@@ -4149,7 +2127,7 @@
           <a:p>
             <a:fld id="{ED515D41-4DB4-46CC-BF5F-4F1657FD0E85}" type="datetimeFigureOut">
               <a:rPr lang="en-GB" smtClean="0"/>
-              <a:t>15/07/2025</a:t>
+              <a:t>15/01/2026</a:t>
             </a:fld>
             <a:endParaRPr lang="en-GB"/>
           </a:p>
@@ -4406,7 +2384,7 @@
           <a:p>
             <a:fld id="{ED515D41-4DB4-46CC-BF5F-4F1657FD0E85}" type="datetimeFigureOut">
               <a:rPr lang="en-GB" smtClean="0"/>
-              <a:t>15/07/2025</a:t>
+              <a:t>15/01/2026</a:t>
             </a:fld>
             <a:endParaRPr lang="en-GB"/>
           </a:p>
@@ -4619,7 +2597,7 @@
           <a:p>
             <a:fld id="{ED515D41-4DB4-46CC-BF5F-4F1657FD0E85}" type="datetimeFigureOut">
               <a:rPr lang="en-GB" smtClean="0"/>
-              <a:t>15/07/2025</a:t>
+              <a:t>15/01/2026</a:t>
             </a:fld>
             <a:endParaRPr lang="en-GB"/>
           </a:p>
@@ -6168,7 +4146,27 @@
                 <a:latin typeface="Calibri" panose="020F0502020204030204" pitchFamily="34" charset="0"/>
                 <a:cs typeface="Calibri" panose="020F0502020204030204" pitchFamily="34" charset="0"/>
               </a:rPr>
-              <a:t>Probability of rainfall exceeding the 1-year return period (ERA5-ecPoint) </a:t>
+              <a:t>Probability of rainfall exceeding </a:t>
+            </a:r>
+            <a:r>
+              <a:rPr lang="en-US" sz="1000" b="1">
+                <a:solidFill>
+                  <a:srgbClr val="333333"/>
+                </a:solidFill>
+                <a:latin typeface="Calibri" panose="020F0502020204030204" pitchFamily="34" charset="0"/>
+                <a:cs typeface="Calibri" panose="020F0502020204030204" pitchFamily="34" charset="0"/>
+              </a:rPr>
+              <a:t>the 50-year </a:t>
+            </a:r>
+            <a:r>
+              <a:rPr lang="en-US" sz="1000" b="1" dirty="0">
+                <a:solidFill>
+                  <a:srgbClr val="333333"/>
+                </a:solidFill>
+                <a:latin typeface="Calibri" panose="020F0502020204030204" pitchFamily="34" charset="0"/>
+                <a:cs typeface="Calibri" panose="020F0502020204030204" pitchFamily="34" charset="0"/>
+              </a:rPr>
+              <a:t>return period (ERA5-ecPoint) </a:t>
             </a:r>
           </a:p>
           <a:p>

</xml_diff>

<commit_message>
Improved description of type of events
</commit_message>
<xml_diff>
--- a/chapter_04/figures/prob_tp_exceeding_50rp.pptx
+++ b/chapter_04/figures/prob_tp_exceeding_50rp.pptx
@@ -116,13 +116,13 @@
 <pc:chgInfo xmlns:a="http://schemas.openxmlformats.org/drawingml/2006/main" xmlns:r="http://schemas.openxmlformats.org/officeDocument/2006/relationships" xmlns:ac="http://schemas.microsoft.com/office/drawing/2013/main/command" xmlns:pc="http://schemas.microsoft.com/office/powerpoint/2013/main/command">
   <pc:docChgLst>
     <pc:chgData name="Fatima Pillosu" userId="a6295d4dc9e22643" providerId="LiveId" clId="{87453732-75AC-4426-B5D3-B7C69C2D4F54}"/>
-    <pc:docChg chg="modSld">
-      <pc:chgData name="Fatima Pillosu" userId="a6295d4dc9e22643" providerId="LiveId" clId="{87453732-75AC-4426-B5D3-B7C69C2D4F54}" dt="2026-01-15T10:01:23.087" v="2" actId="20577"/>
+    <pc:docChg chg="custSel modSld">
+      <pc:chgData name="Fatima Pillosu" userId="a6295d4dc9e22643" providerId="LiveId" clId="{87453732-75AC-4426-B5D3-B7C69C2D4F54}" dt="2026-01-19T22:24:23.345" v="57" actId="20577"/>
       <pc:docMkLst>
         <pc:docMk/>
       </pc:docMkLst>
       <pc:sldChg chg="modSp mod">
-        <pc:chgData name="Fatima Pillosu" userId="a6295d4dc9e22643" providerId="LiveId" clId="{87453732-75AC-4426-B5D3-B7C69C2D4F54}" dt="2026-01-15T10:01:23.087" v="2" actId="20577"/>
+        <pc:chgData name="Fatima Pillosu" userId="a6295d4dc9e22643" providerId="LiveId" clId="{87453732-75AC-4426-B5D3-B7C69C2D4F54}" dt="2026-01-19T22:24:23.345" v="57" actId="20577"/>
         <pc:sldMkLst>
           <pc:docMk/>
           <pc:sldMk cId="1403429394" sldId="257"/>
@@ -133,6 +133,22 @@
             <pc:docMk/>
             <pc:sldMk cId="1403429394" sldId="257"/>
             <ac:spMk id="34" creationId="{15B66109-5EC0-175E-124D-C46996895CE7}"/>
+          </ac:spMkLst>
+        </pc:spChg>
+        <pc:spChg chg="mod">
+          <ac:chgData name="Fatima Pillosu" userId="a6295d4dc9e22643" providerId="LiveId" clId="{87453732-75AC-4426-B5D3-B7C69C2D4F54}" dt="2026-01-19T22:24:16.946" v="55" actId="1076"/>
+          <ac:spMkLst>
+            <pc:docMk/>
+            <pc:sldMk cId="1403429394" sldId="257"/>
+            <ac:spMk id="64" creationId="{12F38479-AB54-6B30-2D3C-FF8C0302CC0C}"/>
+          </ac:spMkLst>
+        </pc:spChg>
+        <pc:spChg chg="mod">
+          <ac:chgData name="Fatima Pillosu" userId="a6295d4dc9e22643" providerId="LiveId" clId="{87453732-75AC-4426-B5D3-B7C69C2D4F54}" dt="2026-01-19T22:24:23.345" v="57" actId="20577"/>
+          <ac:spMkLst>
+            <pc:docMk/>
+            <pc:sldMk cId="1403429394" sldId="257"/>
+            <ac:spMk id="65" creationId="{F814593F-D80C-3FAD-DC51-3489C5EF4A97}"/>
           </ac:spMkLst>
         </pc:spChg>
       </pc:sldChg>
@@ -272,7 +288,7 @@
           <a:p>
             <a:fld id="{ED515D41-4DB4-46CC-BF5F-4F1657FD0E85}" type="datetimeFigureOut">
               <a:rPr lang="en-GB" smtClean="0"/>
-              <a:t>15/01/2026</a:t>
+              <a:t>19/01/2026</a:t>
             </a:fld>
             <a:endParaRPr lang="en-GB"/>
           </a:p>
@@ -442,7 +458,7 @@
           <a:p>
             <a:fld id="{ED515D41-4DB4-46CC-BF5F-4F1657FD0E85}" type="datetimeFigureOut">
               <a:rPr lang="en-GB" smtClean="0"/>
-              <a:t>15/01/2026</a:t>
+              <a:t>19/01/2026</a:t>
             </a:fld>
             <a:endParaRPr lang="en-GB"/>
           </a:p>
@@ -622,7 +638,7 @@
           <a:p>
             <a:fld id="{ED515D41-4DB4-46CC-BF5F-4F1657FD0E85}" type="datetimeFigureOut">
               <a:rPr lang="en-GB" smtClean="0"/>
-              <a:t>15/01/2026</a:t>
+              <a:t>19/01/2026</a:t>
             </a:fld>
             <a:endParaRPr lang="en-GB"/>
           </a:p>
@@ -792,7 +808,7 @@
           <a:p>
             <a:fld id="{ED515D41-4DB4-46CC-BF5F-4F1657FD0E85}" type="datetimeFigureOut">
               <a:rPr lang="en-GB" smtClean="0"/>
-              <a:t>15/01/2026</a:t>
+              <a:t>19/01/2026</a:t>
             </a:fld>
             <a:endParaRPr lang="en-GB"/>
           </a:p>
@@ -1038,7 +1054,7 @@
           <a:p>
             <a:fld id="{ED515D41-4DB4-46CC-BF5F-4F1657FD0E85}" type="datetimeFigureOut">
               <a:rPr lang="en-GB" smtClean="0"/>
-              <a:t>15/01/2026</a:t>
+              <a:t>19/01/2026</a:t>
             </a:fld>
             <a:endParaRPr lang="en-GB"/>
           </a:p>
@@ -1270,7 +1286,7 @@
           <a:p>
             <a:fld id="{ED515D41-4DB4-46CC-BF5F-4F1657FD0E85}" type="datetimeFigureOut">
               <a:rPr lang="en-GB" smtClean="0"/>
-              <a:t>15/01/2026</a:t>
+              <a:t>19/01/2026</a:t>
             </a:fld>
             <a:endParaRPr lang="en-GB"/>
           </a:p>
@@ -1637,7 +1653,7 @@
           <a:p>
             <a:fld id="{ED515D41-4DB4-46CC-BF5F-4F1657FD0E85}" type="datetimeFigureOut">
               <a:rPr lang="en-GB" smtClean="0"/>
-              <a:t>15/01/2026</a:t>
+              <a:t>19/01/2026</a:t>
             </a:fld>
             <a:endParaRPr lang="en-GB"/>
           </a:p>
@@ -1755,7 +1771,7 @@
           <a:p>
             <a:fld id="{ED515D41-4DB4-46CC-BF5F-4F1657FD0E85}" type="datetimeFigureOut">
               <a:rPr lang="en-GB" smtClean="0"/>
-              <a:t>15/01/2026</a:t>
+              <a:t>19/01/2026</a:t>
             </a:fld>
             <a:endParaRPr lang="en-GB"/>
           </a:p>
@@ -1850,7 +1866,7 @@
           <a:p>
             <a:fld id="{ED515D41-4DB4-46CC-BF5F-4F1657FD0E85}" type="datetimeFigureOut">
               <a:rPr lang="en-GB" smtClean="0"/>
-              <a:t>15/01/2026</a:t>
+              <a:t>19/01/2026</a:t>
             </a:fld>
             <a:endParaRPr lang="en-GB"/>
           </a:p>
@@ -2127,7 +2143,7 @@
           <a:p>
             <a:fld id="{ED515D41-4DB4-46CC-BF5F-4F1657FD0E85}" type="datetimeFigureOut">
               <a:rPr lang="en-GB" smtClean="0"/>
-              <a:t>15/01/2026</a:t>
+              <a:t>19/01/2026</a:t>
             </a:fld>
             <a:endParaRPr lang="en-GB"/>
           </a:p>
@@ -2384,7 +2400,7 @@
           <a:p>
             <a:fld id="{ED515D41-4DB4-46CC-BF5F-4F1657FD0E85}" type="datetimeFigureOut">
               <a:rPr lang="en-GB" smtClean="0"/>
-              <a:t>15/01/2026</a:t>
+              <a:t>19/01/2026</a:t>
             </a:fld>
             <a:endParaRPr lang="en-GB"/>
           </a:p>
@@ -2597,7 +2613,7 @@
           <a:p>
             <a:fld id="{ED515D41-4DB4-46CC-BF5F-4F1657FD0E85}" type="datetimeFigureOut">
               <a:rPr lang="en-GB" smtClean="0"/>
-              <a:t>15/01/2026</a:t>
+              <a:t>19/01/2026</a:t>
             </a:fld>
             <a:endParaRPr lang="en-GB"/>
           </a:p>
@@ -5835,7 +5851,7 @@
         </p:nvSpPr>
         <p:spPr>
           <a:xfrm>
-            <a:off x="306183" y="1111971"/>
+            <a:off x="267673" y="1126046"/>
             <a:ext cx="1043249" cy="338554"/>
           </a:xfrm>
           <a:prstGeom prst="rect">
@@ -5858,7 +5874,7 @@
                 <a:latin typeface="Calibri Light" panose="020F0302020204030204" pitchFamily="34" charset="0"/>
                 <a:cs typeface="Calibri Light" panose="020F0302020204030204" pitchFamily="34" charset="0"/>
               </a:rPr>
-              <a:t>Small Convective System</a:t>
+              <a:t>Storm-scale Convective System</a:t>
             </a:r>
           </a:p>
         </p:txBody>
@@ -5877,8 +5893,8 @@
         </p:nvSpPr>
         <p:spPr>
           <a:xfrm>
-            <a:off x="1068879" y="1026396"/>
-            <a:ext cx="1215022" cy="338554"/>
+            <a:off x="848507" y="890427"/>
+            <a:ext cx="1702887" cy="461665"/>
           </a:xfrm>
           <a:prstGeom prst="rect">
             <a:avLst/>
@@ -5913,7 +5929,20 @@
                 <a:latin typeface="Calibri Light" panose="020F0302020204030204" pitchFamily="34" charset="0"/>
                 <a:cs typeface="Calibri Light" panose="020F0302020204030204" pitchFamily="34" charset="0"/>
               </a:rPr>
-              <a:t>System</a:t>
+              <a:t>Convective System</a:t>
+            </a:r>
+          </a:p>
+          <a:p>
+            <a:pPr algn="ctr"/>
+            <a:r>
+              <a:rPr lang="en-GB" sz="800" dirty="0">
+                <a:solidFill>
+                  <a:srgbClr val="0000FF"/>
+                </a:solidFill>
+                <a:latin typeface="Calibri Light" panose="020F0302020204030204" pitchFamily="34" charset="0"/>
+                <a:cs typeface="Calibri Light" panose="020F0302020204030204" pitchFamily="34" charset="0"/>
+              </a:rPr>
+              <a:t>(Recurving Hurricane)</a:t>
             </a:r>
           </a:p>
         </p:txBody>

</xml_diff>